<commit_message>
Add EU AI Act context to deck opening
</commit_message>
<xml_diff>
--- a/docs/ai-pre-scan-presentation.pptx
+++ b/docs/ai-pre-scan-presentation.pptx
@@ -2,22 +2,22 @@
 <file path=ppt/presentation.xml><?xml version="1.0" encoding="utf-8"?>
 <p:presentation xmlns:p="http://schemas.openxmlformats.org/presentationml/2006/main">
   <p:sldMasterIdLst>
-    <p:sldMasterId xmlns:r="http://schemas.openxmlformats.org/officeDocument/2006/relationships" id="2147483648" r:id="Rf2fe0f5015244ac1"/>
+    <p:sldMasterId xmlns:r="http://schemas.openxmlformats.org/officeDocument/2006/relationships" id="2147483648" r:id="Rc5f6ca4a11874115"/>
   </p:sldMasterIdLst>
   <p:notesMasterIdLst>
-    <p:notesMasterId xmlns:r="http://schemas.openxmlformats.org/officeDocument/2006/relationships" r:id="R8e4555d0b6804bb8"/>
+    <p:notesMasterId xmlns:r="http://schemas.openxmlformats.org/officeDocument/2006/relationships" r:id="R474a4e1cdceb47d8"/>
   </p:notesMasterIdLst>
   <p:sldIdLst>
-    <p:sldId xmlns:r="http://schemas.openxmlformats.org/officeDocument/2006/relationships" id="256" r:id="Ra351fb8f34c24f1f"/>
-    <p:sldId xmlns:r="http://schemas.openxmlformats.org/officeDocument/2006/relationships" id="257" r:id="R8156a98df1934b9a"/>
-    <p:sldId xmlns:r="http://schemas.openxmlformats.org/officeDocument/2006/relationships" id="258" r:id="R730f85f7f7b14aad"/>
-    <p:sldId xmlns:r="http://schemas.openxmlformats.org/officeDocument/2006/relationships" id="259" r:id="R12b7c54cc0e74823"/>
-    <p:sldId xmlns:r="http://schemas.openxmlformats.org/officeDocument/2006/relationships" id="260" r:id="Rd08a3200124d43b7"/>
-    <p:sldId xmlns:r="http://schemas.openxmlformats.org/officeDocument/2006/relationships" id="261" r:id="R8db555331f7e4079"/>
-    <p:sldId xmlns:r="http://schemas.openxmlformats.org/officeDocument/2006/relationships" id="262" r:id="R960f720676ac402d"/>
-    <p:sldId xmlns:r="http://schemas.openxmlformats.org/officeDocument/2006/relationships" id="263" r:id="R3e51003469394678"/>
-    <p:sldId xmlns:r="http://schemas.openxmlformats.org/officeDocument/2006/relationships" id="264" r:id="Rb2665e3c5cb249dc"/>
-    <p:sldId xmlns:r="http://schemas.openxmlformats.org/officeDocument/2006/relationships" id="265" r:id="R7ebf5f5447544824"/>
+    <p:sldId xmlns:r="http://schemas.openxmlformats.org/officeDocument/2006/relationships" id="256" r:id="Rd75f0a5a99f74bc7"/>
+    <p:sldId xmlns:r="http://schemas.openxmlformats.org/officeDocument/2006/relationships" id="257" r:id="R369438767a5b4988"/>
+    <p:sldId xmlns:r="http://schemas.openxmlformats.org/officeDocument/2006/relationships" id="258" r:id="R113dcdaef52a440b"/>
+    <p:sldId xmlns:r="http://schemas.openxmlformats.org/officeDocument/2006/relationships" id="259" r:id="R473fd7c660194c52"/>
+    <p:sldId xmlns:r="http://schemas.openxmlformats.org/officeDocument/2006/relationships" id="260" r:id="Re6d1618cb09b4753"/>
+    <p:sldId xmlns:r="http://schemas.openxmlformats.org/officeDocument/2006/relationships" id="261" r:id="R54544ee9d30b4eb8"/>
+    <p:sldId xmlns:r="http://schemas.openxmlformats.org/officeDocument/2006/relationships" id="262" r:id="Re79b2cdb3f5243af"/>
+    <p:sldId xmlns:r="http://schemas.openxmlformats.org/officeDocument/2006/relationships" id="263" r:id="Re6fc0e3bc04848e9"/>
+    <p:sldId xmlns:r="http://schemas.openxmlformats.org/officeDocument/2006/relationships" id="264" r:id="R255a1c018afa4d79"/>
+    <p:sldId xmlns:r="http://schemas.openxmlformats.org/officeDocument/2006/relationships" id="265" r:id="R984ea5538b0d42f1"/>
   </p:sldIdLst>
   <p:sldSz cx="12192000" cy="6858000"/>
   <p:notesSz cx="6858000" cy="9144000"/>
@@ -386,7 +386,7 @@
                 <a:ea typeface="Arial"/>
                 <a:cs typeface="Arial"/>
               </a:rPr>
-              <a:t>Every AI Act assessment begins with a list of the AI systems a company uses. AI Pre-Scan turns a company name into an evidence-backed first draft and shows the adviser what still needs verification. It does not make the legal decision.</a:t>
+              <a:t>The EU AI Act addresses risks from AI systems through a risk-based approach. But before a company can assess what rules apply, it must know which AI systems it uses. AI Pre-Scan turns a company name into an evidence-backed first draft of that inventory.</a:t>
             </a:r>
             <a:endParaRPr sz="2000" b="0" u="none">
               <a:solidFill>
@@ -515,6 +515,33 @@
                 <a:cs typeface="Arial"/>
               </a:rPr>
               <a:t>- README.md</a:t>
+            </a:r>
+            <a:endParaRPr sz="2000" b="0" u="none">
+              <a:solidFill>
+                <a:srgbClr val="000000"/>
+              </a:solidFill>
+              <a:latin typeface="Arial"/>
+              <a:ea typeface="Arial"/>
+              <a:cs typeface="Arial"/>
+            </a:endParaRPr>
+          </a:p>
+          <a:p xmlns:a="http://schemas.openxmlformats.org/drawingml/2006/main">
+            <a:pPr indent="0" algn="l">
+              <a:lnSpc>
+                <a:spcPct val="100000"/>
+              </a:lnSpc>
+              <a:buNone/>
+            </a:pPr>
+            <a:r>
+              <a:rPr sz="2000" b="0" u="none">
+                <a:solidFill>
+                  <a:srgbClr val="000000"/>
+                </a:solidFill>
+                <a:latin typeface="Arial"/>
+                <a:ea typeface="Arial"/>
+                <a:cs typeface="Arial"/>
+              </a:rPr>
+              <a:t>- European Commission, “AI Act”: https://digital-strategy.ec.europa.eu/en/factpages/ai-act</a:t>
             </a:r>
             <a:endParaRPr sz="2000" b="0" u="none">
               <a:solidFill>
@@ -4019,8 +4046,8 @@
   </p:cSld>
   <p:clrMap bg1="lt1" tx1="dk1" bg2="lt2" tx2="dk2" accent1="accent1" accent2="accent2" accent3="accent3" accent4="accent4" accent5="accent5" accent6="accent6" hlink="hlink" folHlink="folHlink"/>
   <p:sldLayoutIdLst>
-    <p:sldLayoutId xmlns:r="http://schemas.openxmlformats.org/officeDocument/2006/relationships" id="2147483649" r:id="Rb68741653fe84f61"/>
-    <p:sldLayoutId xmlns:r="http://schemas.openxmlformats.org/officeDocument/2006/relationships" id="2147483650" r:id="R91ecdbabc9584577"/>
+    <p:sldLayoutId xmlns:r="http://schemas.openxmlformats.org/officeDocument/2006/relationships" id="2147483649" r:id="Re96647f487494410"/>
+    <p:sldLayoutId xmlns:r="http://schemas.openxmlformats.org/officeDocument/2006/relationships" id="2147483650" r:id="R8e418028d1914cc7"/>
   </p:sldLayoutIdLst>
 </p:sldMaster>
 </file>

</xml_diff>

<commit_message>
Simplify deck visuals and presenter notes
</commit_message>
<xml_diff>
--- a/docs/ai-pre-scan-presentation.pptx
+++ b/docs/ai-pre-scan-presentation.pptx
@@ -2,22 +2,22 @@
 <file path=ppt/presentation.xml><?xml version="1.0" encoding="utf-8"?>
 <p:presentation xmlns:p="http://schemas.openxmlformats.org/presentationml/2006/main">
   <p:sldMasterIdLst>
-    <p:sldMasterId xmlns:r="http://schemas.openxmlformats.org/officeDocument/2006/relationships" id="2147483648" r:id="Rc5f6ca4a11874115"/>
+    <p:sldMasterId xmlns:r="http://schemas.openxmlformats.org/officeDocument/2006/relationships" id="2147483648" r:id="R748a65716b3e4f92"/>
   </p:sldMasterIdLst>
   <p:notesMasterIdLst>
-    <p:notesMasterId xmlns:r="http://schemas.openxmlformats.org/officeDocument/2006/relationships" r:id="R474a4e1cdceb47d8"/>
+    <p:notesMasterId xmlns:r="http://schemas.openxmlformats.org/officeDocument/2006/relationships" r:id="R5b5f6733174e4b5d"/>
   </p:notesMasterIdLst>
   <p:sldIdLst>
-    <p:sldId xmlns:r="http://schemas.openxmlformats.org/officeDocument/2006/relationships" id="256" r:id="Rd75f0a5a99f74bc7"/>
-    <p:sldId xmlns:r="http://schemas.openxmlformats.org/officeDocument/2006/relationships" id="257" r:id="R369438767a5b4988"/>
-    <p:sldId xmlns:r="http://schemas.openxmlformats.org/officeDocument/2006/relationships" id="258" r:id="R113dcdaef52a440b"/>
-    <p:sldId xmlns:r="http://schemas.openxmlformats.org/officeDocument/2006/relationships" id="259" r:id="R473fd7c660194c52"/>
-    <p:sldId xmlns:r="http://schemas.openxmlformats.org/officeDocument/2006/relationships" id="260" r:id="Re6d1618cb09b4753"/>
-    <p:sldId xmlns:r="http://schemas.openxmlformats.org/officeDocument/2006/relationships" id="261" r:id="R54544ee9d30b4eb8"/>
-    <p:sldId xmlns:r="http://schemas.openxmlformats.org/officeDocument/2006/relationships" id="262" r:id="Re79b2cdb3f5243af"/>
-    <p:sldId xmlns:r="http://schemas.openxmlformats.org/officeDocument/2006/relationships" id="263" r:id="Re6fc0e3bc04848e9"/>
-    <p:sldId xmlns:r="http://schemas.openxmlformats.org/officeDocument/2006/relationships" id="264" r:id="R255a1c018afa4d79"/>
-    <p:sldId xmlns:r="http://schemas.openxmlformats.org/officeDocument/2006/relationships" id="265" r:id="R984ea5538b0d42f1"/>
+    <p:sldId xmlns:r="http://schemas.openxmlformats.org/officeDocument/2006/relationships" id="256" r:id="Ra12f18d98f844b34"/>
+    <p:sldId xmlns:r="http://schemas.openxmlformats.org/officeDocument/2006/relationships" id="257" r:id="R18eeb41c2a9944f0"/>
+    <p:sldId xmlns:r="http://schemas.openxmlformats.org/officeDocument/2006/relationships" id="258" r:id="R6c0bda55158d4cf5"/>
+    <p:sldId xmlns:r="http://schemas.openxmlformats.org/officeDocument/2006/relationships" id="259" r:id="Rab726b1460e445bc"/>
+    <p:sldId xmlns:r="http://schemas.openxmlformats.org/officeDocument/2006/relationships" id="260" r:id="Rdf04b6412d934680"/>
+    <p:sldId xmlns:r="http://schemas.openxmlformats.org/officeDocument/2006/relationships" id="261" r:id="Ree4a65eb775d46e3"/>
+    <p:sldId xmlns:r="http://schemas.openxmlformats.org/officeDocument/2006/relationships" id="262" r:id="R840e91533dce4774"/>
+    <p:sldId xmlns:r="http://schemas.openxmlformats.org/officeDocument/2006/relationships" id="263" r:id="Rd3dc5642fbaa4d6e"/>
+    <p:sldId xmlns:r="http://schemas.openxmlformats.org/officeDocument/2006/relationships" id="264" r:id="Ree7b6fc777414f78"/>
+    <p:sldId xmlns:r="http://schemas.openxmlformats.org/officeDocument/2006/relationships" id="265" r:id="Rde7afdbcf69e4726"/>
   </p:sldIdLst>
   <p:sldSz cx="12192000" cy="6858000"/>
   <p:notesSz cx="6858000" cy="9144000"/>
@@ -386,7 +386,7 @@
                 <a:ea typeface="Arial"/>
                 <a:cs typeface="Arial"/>
               </a:rPr>
-              <a:t>The EU AI Act addresses risks from AI systems through a risk-based approach. But before a company can assess what rules apply, it must know which AI systems it uses. AI Pre-Scan turns a company name into an evidence-backed first draft of that inventory.</a:t>
+              <a:t>• The EU AI Act addresses risks from AI systems through a risk-based approach.</a:t>
             </a:r>
             <a:endParaRPr sz="2000" b="0" u="none">
               <a:solidFill>
@@ -426,7 +426,7 @@
                 <a:ea typeface="Arial"/>
                 <a:cs typeface="Arial"/>
               </a:rPr>
-              <a:t>The problem begins before the compliance form opens.</a:t>
+              <a:t>• Before a company can assess what rules apply, it must know which AI systems it uses.</a:t>
             </a:r>
             <a:endParaRPr sz="2000" b="0" u="none">
               <a:solidFill>
@@ -466,7 +466,7 @@
                 <a:ea typeface="Arial"/>
                 <a:cs typeface="Arial"/>
               </a:rPr>
-              <a:t>[Sources]</a:t>
+              <a:t>• AI Pre-Scan turns a company name into an evidence-backed first draft of that inventory.</a:t>
             </a:r>
             <a:endParaRPr sz="2000" b="0" u="none">
               <a:solidFill>
@@ -490,6 +490,165 @@
                 <a:ea typeface="Arial"/>
                 <a:cs typeface="Arial"/>
               </a:rPr>
+              <a:t/>
+            </a:r>
+            <a:endParaRPr sz="2000" b="0" u="none">
+              <a:solidFill>
+                <a:srgbClr val="000000"/>
+              </a:solidFill>
+              <a:latin typeface="Arial"/>
+              <a:ea typeface="Arial"/>
+              <a:cs typeface="Arial"/>
+            </a:endParaRPr>
+          </a:p>
+          <a:p xmlns:a="http://schemas.openxmlformats.org/drawingml/2006/main">
+            <a:pPr indent="0" algn="l">
+              <a:buNone/>
+            </a:pPr>
+            <a:r>
+              <a:rPr sz="2000" b="0" u="none">
+                <a:solidFill>
+                  <a:srgbClr val="000000"/>
+                </a:solidFill>
+                <a:latin typeface="Arial"/>
+                <a:ea typeface="Arial"/>
+                <a:cs typeface="Arial"/>
+              </a:rPr>
+              <a:t>• [Pause.]</a:t>
+            </a:r>
+            <a:endParaRPr sz="2000" b="0" u="none">
+              <a:solidFill>
+                <a:srgbClr val="000000"/>
+              </a:solidFill>
+              <a:latin typeface="Arial"/>
+              <a:ea typeface="Arial"/>
+              <a:cs typeface="Arial"/>
+            </a:endParaRPr>
+          </a:p>
+          <a:p xmlns:a="http://schemas.openxmlformats.org/drawingml/2006/main">
+            <a:pPr indent="0" algn="l">
+              <a:lnSpc>
+                <a:spcPct val="100000"/>
+              </a:lnSpc>
+              <a:buNone/>
+            </a:pPr>
+            <a:r>
+              <a:rPr sz="2000" b="0" u="none">
+                <a:solidFill>
+                  <a:srgbClr val="000000"/>
+                </a:solidFill>
+                <a:latin typeface="Arial"/>
+                <a:ea typeface="Arial"/>
+                <a:cs typeface="Arial"/>
+              </a:rPr>
+              <a:t/>
+            </a:r>
+            <a:endParaRPr sz="2000" b="0" u="none">
+              <a:solidFill>
+                <a:srgbClr val="000000"/>
+              </a:solidFill>
+              <a:latin typeface="Arial"/>
+              <a:ea typeface="Arial"/>
+              <a:cs typeface="Arial"/>
+            </a:endParaRPr>
+          </a:p>
+          <a:p xmlns:a="http://schemas.openxmlformats.org/drawingml/2006/main">
+            <a:pPr indent="0" algn="l">
+              <a:lnSpc>
+                <a:spcPct val="100000"/>
+              </a:lnSpc>
+              <a:buNone/>
+            </a:pPr>
+            <a:r>
+              <a:rPr sz="2000" b="0" u="none">
+                <a:solidFill>
+                  <a:srgbClr val="000000"/>
+                </a:solidFill>
+                <a:latin typeface="Arial"/>
+                <a:ea typeface="Arial"/>
+                <a:cs typeface="Arial"/>
+              </a:rPr>
+              <a:t>• The problem begins before the compliance form opens.</a:t>
+            </a:r>
+            <a:endParaRPr sz="2000" b="0" u="none">
+              <a:solidFill>
+                <a:srgbClr val="000000"/>
+              </a:solidFill>
+              <a:latin typeface="Arial"/>
+              <a:ea typeface="Arial"/>
+              <a:cs typeface="Arial"/>
+            </a:endParaRPr>
+          </a:p>
+          <a:p xmlns:a="http://schemas.openxmlformats.org/drawingml/2006/main">
+            <a:pPr indent="0" algn="l">
+              <a:lnSpc>
+                <a:spcPct val="100000"/>
+              </a:lnSpc>
+              <a:buNone/>
+            </a:pPr>
+            <a:r>
+              <a:rPr sz="2000" b="0" u="none">
+                <a:solidFill>
+                  <a:srgbClr val="000000"/>
+                </a:solidFill>
+                <a:latin typeface="Arial"/>
+                <a:ea typeface="Arial"/>
+                <a:cs typeface="Arial"/>
+              </a:rPr>
+              <a:t/>
+            </a:r>
+            <a:endParaRPr sz="2000" b="0" u="none">
+              <a:solidFill>
+                <a:srgbClr val="000000"/>
+              </a:solidFill>
+              <a:latin typeface="Arial"/>
+              <a:ea typeface="Arial"/>
+              <a:cs typeface="Arial"/>
+            </a:endParaRPr>
+          </a:p>
+          <a:p xmlns:a="http://schemas.openxmlformats.org/drawingml/2006/main">
+            <a:pPr indent="0" algn="l">
+              <a:lnSpc>
+                <a:spcPct val="100000"/>
+              </a:lnSpc>
+              <a:buNone/>
+            </a:pPr>
+            <a:r>
+              <a:rPr sz="2000" b="0" u="none">
+                <a:solidFill>
+                  <a:srgbClr val="000000"/>
+                </a:solidFill>
+                <a:latin typeface="Arial"/>
+                <a:ea typeface="Arial"/>
+                <a:cs typeface="Arial"/>
+              </a:rPr>
+              <a:t>[Sources]</a:t>
+            </a:r>
+            <a:endParaRPr sz="2000" b="0" u="none">
+              <a:solidFill>
+                <a:srgbClr val="000000"/>
+              </a:solidFill>
+              <a:latin typeface="Arial"/>
+              <a:ea typeface="Arial"/>
+              <a:cs typeface="Arial"/>
+            </a:endParaRPr>
+          </a:p>
+          <a:p xmlns:a="http://schemas.openxmlformats.org/drawingml/2006/main">
+            <a:pPr indent="0" algn="l">
+              <a:lnSpc>
+                <a:spcPct val="100000"/>
+              </a:lnSpc>
+              <a:buNone/>
+            </a:pPr>
+            <a:r>
+              <a:rPr sz="2000" b="0" u="none">
+                <a:solidFill>
+                  <a:srgbClr val="000000"/>
+                </a:solidFill>
+                <a:latin typeface="Arial"/>
+                <a:ea typeface="Arial"/>
+                <a:cs typeface="Arial"/>
+              </a:rPr>
               <a:t>- docs/elevator-pitch.md</a:t>
             </a:r>
             <a:endParaRPr sz="2000" b="0" u="none">
@@ -503,6 +662,9 @@
           </a:p>
           <a:p xmlns:a="http://schemas.openxmlformats.org/drawingml/2006/main">
             <a:pPr indent="0" algn="l">
+              <a:lnSpc>
+                <a:spcPct val="100000"/>
+              </a:lnSpc>
               <a:buNone/>
             </a:pPr>
             <a:r>
@@ -657,7 +819,7 @@
                 <a:ea typeface="Arial"/>
                 <a:cs typeface="Arial"/>
               </a:rPr>
-              <a:t>The MVP is working end to end. A scan can begin in the browser or from the command line with a company name. It researches across Serper, NewsAPI, GLEIF and Wikidata. OpenAI supports extraction, Pinecone stores evidence and the deterministic gate decides whether a finding is supported. The output is a Markdown report, which n8n can deliver into Notion. We evaluated twelve companies and retained two sample reports as reproducible artefacts; they are not hand-edited showcase copy. The offline test suite also passes. Scheduled sweeps and vendor-corpus ingestion are designed next steps, but they are not part of the built MVP.</a:t>
+              <a:t>• The MVP works end to end.</a:t>
             </a:r>
             <a:endParaRPr sz="2000" b="0" u="none">
               <a:solidFill>
@@ -697,7 +859,7 @@
                 <a:ea typeface="Arial"/>
                 <a:cs typeface="Arial"/>
               </a:rPr>
-              <a:t>[Sources]</a:t>
+              <a:t>• It runs in the browser or from the command line with a company-name trigger.</a:t>
             </a:r>
             <a:endParaRPr sz="2000" b="0" u="none">
               <a:solidFill>
@@ -721,7 +883,7 @@
                 <a:ea typeface="Arial"/>
                 <a:cs typeface="Arial"/>
               </a:rPr>
-              <a:t>- README.md</a:t>
+              <a:t/>
             </a:r>
             <a:endParaRPr sz="2000" b="0" u="none">
               <a:solidFill>
@@ -745,7 +907,7 @@
                 <a:ea typeface="Arial"/>
                 <a:cs typeface="Arial"/>
               </a:rPr>
-              <a:t>- docs/architecture.md</a:t>
+              <a:t>• It finds evidence through Serper, NewsAPI, GLEIF and Wikidata.</a:t>
             </a:r>
             <a:endParaRPr sz="2000" b="0" u="none">
               <a:solidFill>
@@ -769,7 +931,7 @@
                 <a:ea typeface="Arial"/>
                 <a:cs typeface="Arial"/>
               </a:rPr>
-              <a:t>- workflows/README.md</a:t>
+              <a:t/>
             </a:r>
             <a:endParaRPr sz="2000" b="0" u="none">
               <a:solidFill>
@@ -793,7 +955,7 @@
                 <a:ea typeface="Arial"/>
                 <a:cs typeface="Arial"/>
               </a:rPr>
-              <a:t>- eval/results.md</a:t>
+              <a:t>• OpenAI supports extraction, Pinecone stores evidence and the deterministic gate verifies each finding.</a:t>
             </a:r>
             <a:endParaRPr sz="2000" b="0" u="none">
               <a:solidFill>
@@ -817,6 +979,435 @@
                 <a:ea typeface="Arial"/>
                 <a:cs typeface="Arial"/>
               </a:rPr>
+              <a:t/>
+            </a:r>
+            <a:endParaRPr sz="2000" b="0" u="none">
+              <a:solidFill>
+                <a:srgbClr val="000000"/>
+              </a:solidFill>
+              <a:latin typeface="Arial"/>
+              <a:ea typeface="Arial"/>
+              <a:cs typeface="Arial"/>
+            </a:endParaRPr>
+          </a:p>
+          <a:p xmlns:a="http://schemas.openxmlformats.org/drawingml/2006/main">
+            <a:pPr indent="0" algn="l">
+              <a:buNone/>
+            </a:pPr>
+            <a:r>
+              <a:rPr sz="2000" b="0" u="none">
+                <a:solidFill>
+                  <a:srgbClr val="000000"/>
+                </a:solidFill>
+                <a:latin typeface="Arial"/>
+                <a:ea typeface="Arial"/>
+                <a:cs typeface="Arial"/>
+              </a:rPr>
+              <a:t>• The output is a Markdown report; n8n can deliver it into Notion.</a:t>
+            </a:r>
+            <a:endParaRPr sz="2000" b="0" u="none">
+              <a:solidFill>
+                <a:srgbClr val="000000"/>
+              </a:solidFill>
+              <a:latin typeface="Arial"/>
+              <a:ea typeface="Arial"/>
+              <a:cs typeface="Arial"/>
+            </a:endParaRPr>
+          </a:p>
+          <a:p xmlns:a="http://schemas.openxmlformats.org/drawingml/2006/main">
+            <a:pPr indent="0" algn="l">
+              <a:lnSpc>
+                <a:spcPct val="100000"/>
+              </a:lnSpc>
+              <a:buNone/>
+            </a:pPr>
+            <a:r>
+              <a:rPr sz="2000" b="0" u="none">
+                <a:solidFill>
+                  <a:srgbClr val="000000"/>
+                </a:solidFill>
+                <a:latin typeface="Arial"/>
+                <a:ea typeface="Arial"/>
+                <a:cs typeface="Arial"/>
+              </a:rPr>
+              <a:t/>
+            </a:r>
+            <a:endParaRPr sz="2000" b="0" u="none">
+              <a:solidFill>
+                <a:srgbClr val="000000"/>
+              </a:solidFill>
+              <a:latin typeface="Arial"/>
+              <a:ea typeface="Arial"/>
+              <a:cs typeface="Arial"/>
+            </a:endParaRPr>
+          </a:p>
+          <a:p xmlns:a="http://schemas.openxmlformats.org/drawingml/2006/main">
+            <a:pPr indent="0" algn="l">
+              <a:lnSpc>
+                <a:spcPct val="100000"/>
+              </a:lnSpc>
+              <a:buNone/>
+            </a:pPr>
+            <a:r>
+              <a:rPr sz="2000" b="0" u="none">
+                <a:solidFill>
+                  <a:srgbClr val="000000"/>
+                </a:solidFill>
+                <a:latin typeface="Arial"/>
+                <a:ea typeface="Arial"/>
+                <a:cs typeface="Arial"/>
+              </a:rPr>
+              <a:t>• The evidence base includes a twelve-company evaluation, two retained sample reports and 104 passing offline tests.</a:t>
+            </a:r>
+            <a:endParaRPr sz="2000" b="0" u="none">
+              <a:solidFill>
+                <a:srgbClr val="000000"/>
+              </a:solidFill>
+              <a:latin typeface="Arial"/>
+              <a:ea typeface="Arial"/>
+              <a:cs typeface="Arial"/>
+            </a:endParaRPr>
+          </a:p>
+          <a:p xmlns:a="http://schemas.openxmlformats.org/drawingml/2006/main">
+            <a:pPr indent="0" algn="l">
+              <a:lnSpc>
+                <a:spcPct val="100000"/>
+              </a:lnSpc>
+              <a:buNone/>
+            </a:pPr>
+            <a:r>
+              <a:rPr sz="2000" b="0" u="none">
+                <a:solidFill>
+                  <a:srgbClr val="000000"/>
+                </a:solidFill>
+                <a:latin typeface="Arial"/>
+                <a:ea typeface="Arial"/>
+                <a:cs typeface="Arial"/>
+              </a:rPr>
+              <a:t/>
+            </a:r>
+            <a:endParaRPr sz="2000" b="0" u="none">
+              <a:solidFill>
+                <a:srgbClr val="000000"/>
+              </a:solidFill>
+              <a:latin typeface="Arial"/>
+              <a:ea typeface="Arial"/>
+              <a:cs typeface="Arial"/>
+            </a:endParaRPr>
+          </a:p>
+          <a:p xmlns:a="http://schemas.openxmlformats.org/drawingml/2006/main">
+            <a:pPr indent="0" algn="l">
+              <a:lnSpc>
+                <a:spcPct val="100000"/>
+              </a:lnSpc>
+              <a:buNone/>
+            </a:pPr>
+            <a:r>
+              <a:rPr sz="2000" b="0" u="none">
+                <a:solidFill>
+                  <a:srgbClr val="000000"/>
+                </a:solidFill>
+                <a:latin typeface="Arial"/>
+                <a:ea typeface="Arial"/>
+                <a:cs typeface="Arial"/>
+              </a:rPr>
+              <a:t>• The retained samples are generated artefacts—not hand-edited showcase copy.</a:t>
+            </a:r>
+            <a:endParaRPr sz="2000" b="0" u="none">
+              <a:solidFill>
+                <a:srgbClr val="000000"/>
+              </a:solidFill>
+              <a:latin typeface="Arial"/>
+              <a:ea typeface="Arial"/>
+              <a:cs typeface="Arial"/>
+            </a:endParaRPr>
+          </a:p>
+          <a:p xmlns:a="http://schemas.openxmlformats.org/drawingml/2006/main">
+            <a:pPr indent="0" algn="l">
+              <a:lnSpc>
+                <a:spcPct val="100000"/>
+              </a:lnSpc>
+              <a:buNone/>
+            </a:pPr>
+            <a:r>
+              <a:rPr sz="2000" b="0" u="none">
+                <a:solidFill>
+                  <a:srgbClr val="000000"/>
+                </a:solidFill>
+                <a:latin typeface="Arial"/>
+                <a:ea typeface="Arial"/>
+                <a:cs typeface="Arial"/>
+              </a:rPr>
+              <a:t/>
+            </a:r>
+            <a:endParaRPr sz="2000" b="0" u="none">
+              <a:solidFill>
+                <a:srgbClr val="000000"/>
+              </a:solidFill>
+              <a:latin typeface="Arial"/>
+              <a:ea typeface="Arial"/>
+              <a:cs typeface="Arial"/>
+            </a:endParaRPr>
+          </a:p>
+          <a:p xmlns:a="http://schemas.openxmlformats.org/drawingml/2006/main">
+            <a:pPr indent="0" algn="l">
+              <a:lnSpc>
+                <a:spcPct val="100000"/>
+              </a:lnSpc>
+              <a:buNone/>
+            </a:pPr>
+            <a:r>
+              <a:rPr sz="2000" b="0" u="none">
+                <a:solidFill>
+                  <a:srgbClr val="000000"/>
+                </a:solidFill>
+                <a:latin typeface="Arial"/>
+                <a:ea typeface="Arial"/>
+                <a:cs typeface="Arial"/>
+              </a:rPr>
+              <a:t>• [Pause.]</a:t>
+            </a:r>
+            <a:endParaRPr sz="2000" b="0" u="none">
+              <a:solidFill>
+                <a:srgbClr val="000000"/>
+              </a:solidFill>
+              <a:latin typeface="Arial"/>
+              <a:ea typeface="Arial"/>
+              <a:cs typeface="Arial"/>
+            </a:endParaRPr>
+          </a:p>
+          <a:p xmlns:a="http://schemas.openxmlformats.org/drawingml/2006/main">
+            <a:pPr indent="0" algn="l">
+              <a:lnSpc>
+                <a:spcPct val="100000"/>
+              </a:lnSpc>
+              <a:buNone/>
+            </a:pPr>
+            <a:r>
+              <a:rPr sz="2000" b="0" u="none">
+                <a:solidFill>
+                  <a:srgbClr val="000000"/>
+                </a:solidFill>
+                <a:latin typeface="Arial"/>
+                <a:ea typeface="Arial"/>
+                <a:cs typeface="Arial"/>
+              </a:rPr>
+              <a:t/>
+            </a:r>
+            <a:endParaRPr sz="2000" b="0" u="none">
+              <a:solidFill>
+                <a:srgbClr val="000000"/>
+              </a:solidFill>
+              <a:latin typeface="Arial"/>
+              <a:ea typeface="Arial"/>
+              <a:cs typeface="Arial"/>
+            </a:endParaRPr>
+          </a:p>
+          <a:p xmlns:a="http://schemas.openxmlformats.org/drawingml/2006/main">
+            <a:pPr indent="0" algn="l">
+              <a:lnSpc>
+                <a:spcPct val="100000"/>
+              </a:lnSpc>
+              <a:buNone/>
+            </a:pPr>
+            <a:r>
+              <a:rPr sz="2000" b="0" u="none">
+                <a:solidFill>
+                  <a:srgbClr val="000000"/>
+                </a:solidFill>
+                <a:latin typeface="Arial"/>
+                <a:ea typeface="Arial"/>
+                <a:cs typeface="Arial"/>
+              </a:rPr>
+              <a:t>• Scheduled sweeps and vendor-corpus ingestion are designed next steps, not part of the built MVP.</a:t>
+            </a:r>
+            <a:endParaRPr sz="2000" b="0" u="none">
+              <a:solidFill>
+                <a:srgbClr val="000000"/>
+              </a:solidFill>
+              <a:latin typeface="Arial"/>
+              <a:ea typeface="Arial"/>
+              <a:cs typeface="Arial"/>
+            </a:endParaRPr>
+          </a:p>
+          <a:p xmlns:a="http://schemas.openxmlformats.org/drawingml/2006/main">
+            <a:pPr indent="0" algn="l">
+              <a:lnSpc>
+                <a:spcPct val="100000"/>
+              </a:lnSpc>
+              <a:buNone/>
+            </a:pPr>
+            <a:r>
+              <a:rPr sz="2000" b="0" u="none">
+                <a:solidFill>
+                  <a:srgbClr val="000000"/>
+                </a:solidFill>
+                <a:latin typeface="Arial"/>
+                <a:ea typeface="Arial"/>
+                <a:cs typeface="Arial"/>
+              </a:rPr>
+              <a:t/>
+            </a:r>
+            <a:endParaRPr sz="2000" b="0" u="none">
+              <a:solidFill>
+                <a:srgbClr val="000000"/>
+              </a:solidFill>
+              <a:latin typeface="Arial"/>
+              <a:ea typeface="Arial"/>
+              <a:cs typeface="Arial"/>
+            </a:endParaRPr>
+          </a:p>
+          <a:p xmlns:a="http://schemas.openxmlformats.org/drawingml/2006/main">
+            <a:pPr indent="0" algn="l">
+              <a:lnSpc>
+                <a:spcPct val="100000"/>
+              </a:lnSpc>
+              <a:buNone/>
+            </a:pPr>
+            <a:r>
+              <a:rPr sz="2000" b="0" u="none">
+                <a:solidFill>
+                  <a:srgbClr val="000000"/>
+                </a:solidFill>
+                <a:latin typeface="Arial"/>
+                <a:ea typeface="Arial"/>
+                <a:cs typeface="Arial"/>
+              </a:rPr>
+              <a:t>[Sources]</a:t>
+            </a:r>
+            <a:endParaRPr sz="2000" b="0" u="none">
+              <a:solidFill>
+                <a:srgbClr val="000000"/>
+              </a:solidFill>
+              <a:latin typeface="Arial"/>
+              <a:ea typeface="Arial"/>
+              <a:cs typeface="Arial"/>
+            </a:endParaRPr>
+          </a:p>
+          <a:p xmlns:a="http://schemas.openxmlformats.org/drawingml/2006/main">
+            <a:pPr indent="0" algn="l">
+              <a:lnSpc>
+                <a:spcPct val="100000"/>
+              </a:lnSpc>
+              <a:buNone/>
+            </a:pPr>
+            <a:r>
+              <a:rPr sz="2000" b="0" u="none">
+                <a:solidFill>
+                  <a:srgbClr val="000000"/>
+                </a:solidFill>
+                <a:latin typeface="Arial"/>
+                <a:ea typeface="Arial"/>
+                <a:cs typeface="Arial"/>
+              </a:rPr>
+              <a:t>- README.md</a:t>
+            </a:r>
+            <a:endParaRPr sz="2000" b="0" u="none">
+              <a:solidFill>
+                <a:srgbClr val="000000"/>
+              </a:solidFill>
+              <a:latin typeface="Arial"/>
+              <a:ea typeface="Arial"/>
+              <a:cs typeface="Arial"/>
+            </a:endParaRPr>
+          </a:p>
+          <a:p xmlns:a="http://schemas.openxmlformats.org/drawingml/2006/main">
+            <a:pPr indent="0" algn="l">
+              <a:lnSpc>
+                <a:spcPct val="100000"/>
+              </a:lnSpc>
+              <a:buNone/>
+            </a:pPr>
+            <a:r>
+              <a:rPr sz="2000" b="0" u="none">
+                <a:solidFill>
+                  <a:srgbClr val="000000"/>
+                </a:solidFill>
+                <a:latin typeface="Arial"/>
+                <a:ea typeface="Arial"/>
+                <a:cs typeface="Arial"/>
+              </a:rPr>
+              <a:t>- docs/architecture.md</a:t>
+            </a:r>
+            <a:endParaRPr sz="2000" b="0" u="none">
+              <a:solidFill>
+                <a:srgbClr val="000000"/>
+              </a:solidFill>
+              <a:latin typeface="Arial"/>
+              <a:ea typeface="Arial"/>
+              <a:cs typeface="Arial"/>
+            </a:endParaRPr>
+          </a:p>
+          <a:p xmlns:a="http://schemas.openxmlformats.org/drawingml/2006/main">
+            <a:pPr indent="0" algn="l">
+              <a:lnSpc>
+                <a:spcPct val="100000"/>
+              </a:lnSpc>
+              <a:buNone/>
+            </a:pPr>
+            <a:r>
+              <a:rPr sz="2000" b="0" u="none">
+                <a:solidFill>
+                  <a:srgbClr val="000000"/>
+                </a:solidFill>
+                <a:latin typeface="Arial"/>
+                <a:ea typeface="Arial"/>
+                <a:cs typeface="Arial"/>
+              </a:rPr>
+              <a:t>- workflows/README.md</a:t>
+            </a:r>
+            <a:endParaRPr sz="2000" b="0" u="none">
+              <a:solidFill>
+                <a:srgbClr val="000000"/>
+              </a:solidFill>
+              <a:latin typeface="Arial"/>
+              <a:ea typeface="Arial"/>
+              <a:cs typeface="Arial"/>
+            </a:endParaRPr>
+          </a:p>
+          <a:p xmlns:a="http://schemas.openxmlformats.org/drawingml/2006/main">
+            <a:pPr indent="0" algn="l">
+              <a:lnSpc>
+                <a:spcPct val="100000"/>
+              </a:lnSpc>
+              <a:buNone/>
+            </a:pPr>
+            <a:r>
+              <a:rPr sz="2000" b="0" u="none">
+                <a:solidFill>
+                  <a:srgbClr val="000000"/>
+                </a:solidFill>
+                <a:latin typeface="Arial"/>
+                <a:ea typeface="Arial"/>
+                <a:cs typeface="Arial"/>
+              </a:rPr>
+              <a:t>- eval/results.md</a:t>
+            </a:r>
+            <a:endParaRPr sz="2000" b="0" u="none">
+              <a:solidFill>
+                <a:srgbClr val="000000"/>
+              </a:solidFill>
+              <a:latin typeface="Arial"/>
+              <a:ea typeface="Arial"/>
+              <a:cs typeface="Arial"/>
+            </a:endParaRPr>
+          </a:p>
+          <a:p xmlns:a="http://schemas.openxmlformats.org/drawingml/2006/main">
+            <a:pPr indent="0" algn="l">
+              <a:lnSpc>
+                <a:spcPct val="100000"/>
+              </a:lnSpc>
+              <a:buNone/>
+            </a:pPr>
+            <a:r>
+              <a:rPr sz="2000" b="0" u="none">
+                <a:solidFill>
+                  <a:srgbClr val="000000"/>
+                </a:solidFill>
+                <a:latin typeface="Arial"/>
+                <a:ea typeface="Arial"/>
+                <a:cs typeface="Arial"/>
+              </a:rPr>
               <a:t>- samples/personio.md</a:t>
             </a:r>
             <a:endParaRPr sz="2000" b="0" u="none">
@@ -830,6 +1421,9 @@
           </a:p>
           <a:p xmlns:a="http://schemas.openxmlformats.org/drawingml/2006/main">
             <a:pPr indent="0" algn="l">
+              <a:lnSpc>
+                <a:spcPct val="100000"/>
+              </a:lnSpc>
               <a:buNone/>
             </a:pPr>
             <a:r>
@@ -957,7 +1551,7 @@
                 <a:ea typeface="Arial"/>
                 <a:cs typeface="Arial"/>
               </a:rPr>
-              <a:t>Most compliance tools sensibly assess one known system at a time. But that creates a hidden assumption: someone has already found the systems. For many small companies, that inventory simply does not exist. A recruitment platform adds an AI feature. Marketing buys a new tool. An employee starts using a consumer assistant. None of those routes necessarily creates a central record. So, when the checker asks for each individual AI system, the SME's honest answer may be: “Which systems are those?” The compliance process begins with a blank page. AI Pre-Scan fills that missing step.</a:t>
+              <a:t>• Most compliance tools assess one known system at a time.</a:t>
             </a:r>
             <a:endParaRPr sz="2000" b="0" u="none">
               <a:solidFill>
@@ -997,7 +1591,7 @@
                 <a:ea typeface="Arial"/>
                 <a:cs typeface="Arial"/>
               </a:rPr>
-              <a:t>AI Pre-Scan creates a useful starting point before that meeting.</a:t>
+              <a:t>• That assumes someone has already found the systems.</a:t>
             </a:r>
             <a:endParaRPr sz="2000" b="0" u="none">
               <a:solidFill>
@@ -1037,7 +1631,7 @@
                 <a:ea typeface="Arial"/>
                 <a:cs typeface="Arial"/>
               </a:rPr>
-              <a:t>[Sources]</a:t>
+              <a:t>• For many SMEs, that inventory does not exist.</a:t>
             </a:r>
             <a:endParaRPr sz="2000" b="0" u="none">
               <a:solidFill>
@@ -1061,6 +1655,327 @@
                 <a:ea typeface="Arial"/>
                 <a:cs typeface="Arial"/>
               </a:rPr>
+              <a:t/>
+            </a:r>
+            <a:endParaRPr sz="2000" b="0" u="none">
+              <a:solidFill>
+                <a:srgbClr val="000000"/>
+              </a:solidFill>
+              <a:latin typeface="Arial"/>
+              <a:ea typeface="Arial"/>
+              <a:cs typeface="Arial"/>
+            </a:endParaRPr>
+          </a:p>
+          <a:p xmlns:a="http://schemas.openxmlformats.org/drawingml/2006/main">
+            <a:pPr indent="0" algn="l">
+              <a:buNone/>
+            </a:pPr>
+            <a:r>
+              <a:rPr sz="2000" b="0" u="none">
+                <a:solidFill>
+                  <a:srgbClr val="000000"/>
+                </a:solidFill>
+                <a:latin typeface="Arial"/>
+                <a:ea typeface="Arial"/>
+                <a:cs typeface="Arial"/>
+              </a:rPr>
+              <a:t>• AI can arrive through a vendor update, a team purchase or an employee tool.</a:t>
+            </a:r>
+            <a:endParaRPr sz="2000" b="0" u="none">
+              <a:solidFill>
+                <a:srgbClr val="000000"/>
+              </a:solidFill>
+              <a:latin typeface="Arial"/>
+              <a:ea typeface="Arial"/>
+              <a:cs typeface="Arial"/>
+            </a:endParaRPr>
+          </a:p>
+          <a:p xmlns:a="http://schemas.openxmlformats.org/drawingml/2006/main">
+            <a:pPr indent="0" algn="l">
+              <a:lnSpc>
+                <a:spcPct val="100000"/>
+              </a:lnSpc>
+              <a:buNone/>
+            </a:pPr>
+            <a:r>
+              <a:rPr sz="2000" b="0" u="none">
+                <a:solidFill>
+                  <a:srgbClr val="000000"/>
+                </a:solidFill>
+                <a:latin typeface="Arial"/>
+                <a:ea typeface="Arial"/>
+                <a:cs typeface="Arial"/>
+              </a:rPr>
+              <a:t/>
+            </a:r>
+            <a:endParaRPr sz="2000" b="0" u="none">
+              <a:solidFill>
+                <a:srgbClr val="000000"/>
+              </a:solidFill>
+              <a:latin typeface="Arial"/>
+              <a:ea typeface="Arial"/>
+              <a:cs typeface="Arial"/>
+            </a:endParaRPr>
+          </a:p>
+          <a:p xmlns:a="http://schemas.openxmlformats.org/drawingml/2006/main">
+            <a:pPr indent="0" algn="l">
+              <a:lnSpc>
+                <a:spcPct val="100000"/>
+              </a:lnSpc>
+              <a:buNone/>
+            </a:pPr>
+            <a:r>
+              <a:rPr sz="2000" b="0" u="none">
+                <a:solidFill>
+                  <a:srgbClr val="000000"/>
+                </a:solidFill>
+                <a:latin typeface="Arial"/>
+                <a:ea typeface="Arial"/>
+                <a:cs typeface="Arial"/>
+              </a:rPr>
+              <a:t>• So, when the checker asks for each individual AI system, the SME may honestly ask: “Which systems are those?”</a:t>
+            </a:r>
+            <a:endParaRPr sz="2000" b="0" u="none">
+              <a:solidFill>
+                <a:srgbClr val="000000"/>
+              </a:solidFill>
+              <a:latin typeface="Arial"/>
+              <a:ea typeface="Arial"/>
+              <a:cs typeface="Arial"/>
+            </a:endParaRPr>
+          </a:p>
+          <a:p xmlns:a="http://schemas.openxmlformats.org/drawingml/2006/main">
+            <a:pPr indent="0" algn="l">
+              <a:lnSpc>
+                <a:spcPct val="100000"/>
+              </a:lnSpc>
+              <a:buNone/>
+            </a:pPr>
+            <a:r>
+              <a:rPr sz="2000" b="0" u="none">
+                <a:solidFill>
+                  <a:srgbClr val="000000"/>
+                </a:solidFill>
+                <a:latin typeface="Arial"/>
+                <a:ea typeface="Arial"/>
+                <a:cs typeface="Arial"/>
+              </a:rPr>
+              <a:t/>
+            </a:r>
+            <a:endParaRPr sz="2000" b="0" u="none">
+              <a:solidFill>
+                <a:srgbClr val="000000"/>
+              </a:solidFill>
+              <a:latin typeface="Arial"/>
+              <a:ea typeface="Arial"/>
+              <a:cs typeface="Arial"/>
+            </a:endParaRPr>
+          </a:p>
+          <a:p xmlns:a="http://schemas.openxmlformats.org/drawingml/2006/main">
+            <a:pPr indent="0" algn="l">
+              <a:lnSpc>
+                <a:spcPct val="100000"/>
+              </a:lnSpc>
+              <a:buNone/>
+            </a:pPr>
+            <a:r>
+              <a:rPr sz="2000" b="0" u="none">
+                <a:solidFill>
+                  <a:srgbClr val="000000"/>
+                </a:solidFill>
+                <a:latin typeface="Arial"/>
+                <a:ea typeface="Arial"/>
+                <a:cs typeface="Arial"/>
+              </a:rPr>
+              <a:t>• [Pause.]</a:t>
+            </a:r>
+            <a:endParaRPr sz="2000" b="0" u="none">
+              <a:solidFill>
+                <a:srgbClr val="000000"/>
+              </a:solidFill>
+              <a:latin typeface="Arial"/>
+              <a:ea typeface="Arial"/>
+              <a:cs typeface="Arial"/>
+            </a:endParaRPr>
+          </a:p>
+          <a:p xmlns:a="http://schemas.openxmlformats.org/drawingml/2006/main">
+            <a:pPr indent="0" algn="l">
+              <a:lnSpc>
+                <a:spcPct val="100000"/>
+              </a:lnSpc>
+              <a:buNone/>
+            </a:pPr>
+            <a:r>
+              <a:rPr sz="2000" b="0" u="none">
+                <a:solidFill>
+                  <a:srgbClr val="000000"/>
+                </a:solidFill>
+                <a:latin typeface="Arial"/>
+                <a:ea typeface="Arial"/>
+                <a:cs typeface="Arial"/>
+              </a:rPr>
+              <a:t/>
+            </a:r>
+            <a:endParaRPr sz="2000" b="0" u="none">
+              <a:solidFill>
+                <a:srgbClr val="000000"/>
+              </a:solidFill>
+              <a:latin typeface="Arial"/>
+              <a:ea typeface="Arial"/>
+              <a:cs typeface="Arial"/>
+            </a:endParaRPr>
+          </a:p>
+          <a:p xmlns:a="http://schemas.openxmlformats.org/drawingml/2006/main">
+            <a:pPr indent="0" algn="l">
+              <a:lnSpc>
+                <a:spcPct val="100000"/>
+              </a:lnSpc>
+              <a:buNone/>
+            </a:pPr>
+            <a:r>
+              <a:rPr sz="2000" b="0" u="none">
+                <a:solidFill>
+                  <a:srgbClr val="000000"/>
+                </a:solidFill>
+                <a:latin typeface="Arial"/>
+                <a:ea typeface="Arial"/>
+                <a:cs typeface="Arial"/>
+              </a:rPr>
+              <a:t>• AI Pre-Scan fills that missing step.</a:t>
+            </a:r>
+            <a:endParaRPr sz="2000" b="0" u="none">
+              <a:solidFill>
+                <a:srgbClr val="000000"/>
+              </a:solidFill>
+              <a:latin typeface="Arial"/>
+              <a:ea typeface="Arial"/>
+              <a:cs typeface="Arial"/>
+            </a:endParaRPr>
+          </a:p>
+          <a:p xmlns:a="http://schemas.openxmlformats.org/drawingml/2006/main">
+            <a:pPr indent="0" algn="l">
+              <a:lnSpc>
+                <a:spcPct val="100000"/>
+              </a:lnSpc>
+              <a:buNone/>
+            </a:pPr>
+            <a:r>
+              <a:rPr sz="2000" b="0" u="none">
+                <a:solidFill>
+                  <a:srgbClr val="000000"/>
+                </a:solidFill>
+                <a:latin typeface="Arial"/>
+                <a:ea typeface="Arial"/>
+                <a:cs typeface="Arial"/>
+              </a:rPr>
+              <a:t/>
+            </a:r>
+            <a:endParaRPr sz="2000" b="0" u="none">
+              <a:solidFill>
+                <a:srgbClr val="000000"/>
+              </a:solidFill>
+              <a:latin typeface="Arial"/>
+              <a:ea typeface="Arial"/>
+              <a:cs typeface="Arial"/>
+            </a:endParaRPr>
+          </a:p>
+          <a:p xmlns:a="http://schemas.openxmlformats.org/drawingml/2006/main">
+            <a:pPr indent="0" algn="l">
+              <a:lnSpc>
+                <a:spcPct val="100000"/>
+              </a:lnSpc>
+              <a:buNone/>
+            </a:pPr>
+            <a:r>
+              <a:rPr sz="2000" b="0" u="none">
+                <a:solidFill>
+                  <a:srgbClr val="000000"/>
+                </a:solidFill>
+                <a:latin typeface="Arial"/>
+                <a:ea typeface="Arial"/>
+                <a:cs typeface="Arial"/>
+              </a:rPr>
+              <a:t>• AI Pre-Scan creates a useful starting point before that meeting.</a:t>
+            </a:r>
+            <a:endParaRPr sz="2000" b="0" u="none">
+              <a:solidFill>
+                <a:srgbClr val="000000"/>
+              </a:solidFill>
+              <a:latin typeface="Arial"/>
+              <a:ea typeface="Arial"/>
+              <a:cs typeface="Arial"/>
+            </a:endParaRPr>
+          </a:p>
+          <a:p xmlns:a="http://schemas.openxmlformats.org/drawingml/2006/main">
+            <a:pPr indent="0" algn="l">
+              <a:lnSpc>
+                <a:spcPct val="100000"/>
+              </a:lnSpc>
+              <a:buNone/>
+            </a:pPr>
+            <a:r>
+              <a:rPr sz="2000" b="0" u="none">
+                <a:solidFill>
+                  <a:srgbClr val="000000"/>
+                </a:solidFill>
+                <a:latin typeface="Arial"/>
+                <a:ea typeface="Arial"/>
+                <a:cs typeface="Arial"/>
+              </a:rPr>
+              <a:t/>
+            </a:r>
+            <a:endParaRPr sz="2000" b="0" u="none">
+              <a:solidFill>
+                <a:srgbClr val="000000"/>
+              </a:solidFill>
+              <a:latin typeface="Arial"/>
+              <a:ea typeface="Arial"/>
+              <a:cs typeface="Arial"/>
+            </a:endParaRPr>
+          </a:p>
+          <a:p xmlns:a="http://schemas.openxmlformats.org/drawingml/2006/main">
+            <a:pPr indent="0" algn="l">
+              <a:lnSpc>
+                <a:spcPct val="100000"/>
+              </a:lnSpc>
+              <a:buNone/>
+            </a:pPr>
+            <a:r>
+              <a:rPr sz="2000" b="0" u="none">
+                <a:solidFill>
+                  <a:srgbClr val="000000"/>
+                </a:solidFill>
+                <a:latin typeface="Arial"/>
+                <a:ea typeface="Arial"/>
+                <a:cs typeface="Arial"/>
+              </a:rPr>
+              <a:t>[Sources]</a:t>
+            </a:r>
+            <a:endParaRPr sz="2000" b="0" u="none">
+              <a:solidFill>
+                <a:srgbClr val="000000"/>
+              </a:solidFill>
+              <a:latin typeface="Arial"/>
+              <a:ea typeface="Arial"/>
+              <a:cs typeface="Arial"/>
+            </a:endParaRPr>
+          </a:p>
+          <a:p xmlns:a="http://schemas.openxmlformats.org/drawingml/2006/main">
+            <a:pPr indent="0" algn="l">
+              <a:lnSpc>
+                <a:spcPct val="100000"/>
+              </a:lnSpc>
+              <a:buNone/>
+            </a:pPr>
+            <a:r>
+              <a:rPr sz="2000" b="0" u="none">
+                <a:solidFill>
+                  <a:srgbClr val="000000"/>
+                </a:solidFill>
+                <a:latin typeface="Arial"/>
+                <a:ea typeface="Arial"/>
+                <a:cs typeface="Arial"/>
+              </a:rPr>
               <a:t>- docs/elevator-pitch.md</a:t>
             </a:r>
             <a:endParaRPr sz="2000" b="0" u="none">
@@ -1074,6 +1989,9 @@
           </a:p>
           <a:p xmlns:a="http://schemas.openxmlformats.org/drawingml/2006/main">
             <a:pPr indent="0" algn="l">
+              <a:lnSpc>
+                <a:spcPct val="100000"/>
+              </a:lnSpc>
               <a:buNone/>
             </a:pPr>
             <a:r>
@@ -1201,7 +2119,7 @@
                 <a:ea typeface="Arial"/>
                 <a:cs typeface="Arial"/>
               </a:rPr>
-              <a:t>Here is the complete loop. First, the system resolves the company and searches its public footprint: its own website, registry data, careers pages, vendor references and news. Second, it extracts candidate systems, but every proposed finding must pass the evidence gate. The exact quote must be present, the source must be traceable and the timing must fit the claim. Anything unsupported becomes undetermined, not a fact. Third, the adviser receives a candidate inventory plus the questions the public web cannot answer. Human review confirms the facts; a separate deterministic checker applies the law.</a:t>
+              <a:t>• The only input is a company name.</a:t>
             </a:r>
             <a:endParaRPr sz="2000" b="0" u="none">
               <a:solidFill>
@@ -1241,7 +2159,7 @@
                 <a:ea typeface="Arial"/>
                 <a:cs typeface="Arial"/>
               </a:rPr>
-              <a:t>The fastest way to understand that boundary is to see both kinds of output.</a:t>
+              <a:t>• First, the system maps the public footprint: registry, website, careers, vendor references and news.</a:t>
             </a:r>
             <a:endParaRPr sz="2000" b="0" u="none">
               <a:solidFill>
@@ -1281,7 +2199,7 @@
                 <a:ea typeface="Arial"/>
                 <a:cs typeface="Arial"/>
               </a:rPr>
-              <a:t>[Sources]</a:t>
+              <a:t>• Second, every candidate finding must pass the evidence gate.</a:t>
             </a:r>
             <a:endParaRPr sz="2000" b="0" u="none">
               <a:solidFill>
@@ -1305,7 +2223,7 @@
                 <a:ea typeface="Arial"/>
                 <a:cs typeface="Arial"/>
               </a:rPr>
-              <a:t>- docs/system-overview-slide.pptx</a:t>
+              <a:t/>
             </a:r>
             <a:endParaRPr sz="2000" b="0" u="none">
               <a:solidFill>
@@ -1329,6 +2247,381 @@
                 <a:ea typeface="Arial"/>
                 <a:cs typeface="Arial"/>
               </a:rPr>
+              <a:t>• The exact quote must exist, the source must be traceable and the timing must fit the claim.</a:t>
+            </a:r>
+            <a:endParaRPr sz="2000" b="0" u="none">
+              <a:solidFill>
+                <a:srgbClr val="000000"/>
+              </a:solidFill>
+              <a:latin typeface="Arial"/>
+              <a:ea typeface="Arial"/>
+              <a:cs typeface="Arial"/>
+            </a:endParaRPr>
+          </a:p>
+          <a:p xmlns:a="http://schemas.openxmlformats.org/drawingml/2006/main">
+            <a:pPr indent="0" algn="l">
+              <a:buNone/>
+            </a:pPr>
+            <a:r>
+              <a:rPr sz="2000" b="0" u="none">
+                <a:solidFill>
+                  <a:srgbClr val="000000"/>
+                </a:solidFill>
+                <a:latin typeface="Arial"/>
+                <a:ea typeface="Arial"/>
+                <a:cs typeface="Arial"/>
+              </a:rPr>
+              <a:t/>
+            </a:r>
+            <a:endParaRPr sz="2000" b="0" u="none">
+              <a:solidFill>
+                <a:srgbClr val="000000"/>
+              </a:solidFill>
+              <a:latin typeface="Arial"/>
+              <a:ea typeface="Arial"/>
+              <a:cs typeface="Arial"/>
+            </a:endParaRPr>
+          </a:p>
+          <a:p xmlns:a="http://schemas.openxmlformats.org/drawingml/2006/main">
+            <a:pPr indent="0" algn="l">
+              <a:lnSpc>
+                <a:spcPct val="100000"/>
+              </a:lnSpc>
+              <a:buNone/>
+            </a:pPr>
+            <a:r>
+              <a:rPr sz="2000" b="0" u="none">
+                <a:solidFill>
+                  <a:srgbClr val="000000"/>
+                </a:solidFill>
+                <a:latin typeface="Arial"/>
+                <a:ea typeface="Arial"/>
+                <a:cs typeface="Arial"/>
+              </a:rPr>
+              <a:t>• Unsupported findings become undetermined, not facts.</a:t>
+            </a:r>
+            <a:endParaRPr sz="2000" b="0" u="none">
+              <a:solidFill>
+                <a:srgbClr val="000000"/>
+              </a:solidFill>
+              <a:latin typeface="Arial"/>
+              <a:ea typeface="Arial"/>
+              <a:cs typeface="Arial"/>
+            </a:endParaRPr>
+          </a:p>
+          <a:p xmlns:a="http://schemas.openxmlformats.org/drawingml/2006/main">
+            <a:pPr indent="0" algn="l">
+              <a:lnSpc>
+                <a:spcPct val="100000"/>
+              </a:lnSpc>
+              <a:buNone/>
+            </a:pPr>
+            <a:r>
+              <a:rPr sz="2000" b="0" u="none">
+                <a:solidFill>
+                  <a:srgbClr val="000000"/>
+                </a:solidFill>
+                <a:latin typeface="Arial"/>
+                <a:ea typeface="Arial"/>
+                <a:cs typeface="Arial"/>
+              </a:rPr>
+              <a:t/>
+            </a:r>
+            <a:endParaRPr sz="2000" b="0" u="none">
+              <a:solidFill>
+                <a:srgbClr val="000000"/>
+              </a:solidFill>
+              <a:latin typeface="Arial"/>
+              <a:ea typeface="Arial"/>
+              <a:cs typeface="Arial"/>
+            </a:endParaRPr>
+          </a:p>
+          <a:p xmlns:a="http://schemas.openxmlformats.org/drawingml/2006/main">
+            <a:pPr indent="0" algn="l">
+              <a:lnSpc>
+                <a:spcPct val="100000"/>
+              </a:lnSpc>
+              <a:buNone/>
+            </a:pPr>
+            <a:r>
+              <a:rPr sz="2000" b="0" u="none">
+                <a:solidFill>
+                  <a:srgbClr val="000000"/>
+                </a:solidFill>
+                <a:latin typeface="Arial"/>
+                <a:ea typeface="Arial"/>
+                <a:cs typeface="Arial"/>
+              </a:rPr>
+              <a:t>• Third, the adviser receives a candidate inventory plus focused client questions.</a:t>
+            </a:r>
+            <a:endParaRPr sz="2000" b="0" u="none">
+              <a:solidFill>
+                <a:srgbClr val="000000"/>
+              </a:solidFill>
+              <a:latin typeface="Arial"/>
+              <a:ea typeface="Arial"/>
+              <a:cs typeface="Arial"/>
+            </a:endParaRPr>
+          </a:p>
+          <a:p xmlns:a="http://schemas.openxmlformats.org/drawingml/2006/main">
+            <a:pPr indent="0" algn="l">
+              <a:lnSpc>
+                <a:spcPct val="100000"/>
+              </a:lnSpc>
+              <a:buNone/>
+            </a:pPr>
+            <a:r>
+              <a:rPr sz="2000" b="0" u="none">
+                <a:solidFill>
+                  <a:srgbClr val="000000"/>
+                </a:solidFill>
+                <a:latin typeface="Arial"/>
+                <a:ea typeface="Arial"/>
+                <a:cs typeface="Arial"/>
+              </a:rPr>
+              <a:t/>
+            </a:r>
+            <a:endParaRPr sz="2000" b="0" u="none">
+              <a:solidFill>
+                <a:srgbClr val="000000"/>
+              </a:solidFill>
+              <a:latin typeface="Arial"/>
+              <a:ea typeface="Arial"/>
+              <a:cs typeface="Arial"/>
+            </a:endParaRPr>
+          </a:p>
+          <a:p xmlns:a="http://schemas.openxmlformats.org/drawingml/2006/main">
+            <a:pPr indent="0" algn="l">
+              <a:lnSpc>
+                <a:spcPct val="100000"/>
+              </a:lnSpc>
+              <a:buNone/>
+            </a:pPr>
+            <a:r>
+              <a:rPr sz="2000" b="0" u="none">
+                <a:solidFill>
+                  <a:srgbClr val="000000"/>
+                </a:solidFill>
+                <a:latin typeface="Arial"/>
+                <a:ea typeface="Arial"/>
+                <a:cs typeface="Arial"/>
+              </a:rPr>
+              <a:t>• Human review confirms the facts; a separate deterministic checker applies the law.</a:t>
+            </a:r>
+            <a:endParaRPr sz="2000" b="0" u="none">
+              <a:solidFill>
+                <a:srgbClr val="000000"/>
+              </a:solidFill>
+              <a:latin typeface="Arial"/>
+              <a:ea typeface="Arial"/>
+              <a:cs typeface="Arial"/>
+            </a:endParaRPr>
+          </a:p>
+          <a:p xmlns:a="http://schemas.openxmlformats.org/drawingml/2006/main">
+            <a:pPr indent="0" algn="l">
+              <a:lnSpc>
+                <a:spcPct val="100000"/>
+              </a:lnSpc>
+              <a:buNone/>
+            </a:pPr>
+            <a:r>
+              <a:rPr sz="2000" b="0" u="none">
+                <a:solidFill>
+                  <a:srgbClr val="000000"/>
+                </a:solidFill>
+                <a:latin typeface="Arial"/>
+                <a:ea typeface="Arial"/>
+                <a:cs typeface="Arial"/>
+              </a:rPr>
+              <a:t/>
+            </a:r>
+            <a:endParaRPr sz="2000" b="0" u="none">
+              <a:solidFill>
+                <a:srgbClr val="000000"/>
+              </a:solidFill>
+              <a:latin typeface="Arial"/>
+              <a:ea typeface="Arial"/>
+              <a:cs typeface="Arial"/>
+            </a:endParaRPr>
+          </a:p>
+          <a:p xmlns:a="http://schemas.openxmlformats.org/drawingml/2006/main">
+            <a:pPr indent="0" algn="l">
+              <a:lnSpc>
+                <a:spcPct val="100000"/>
+              </a:lnSpc>
+              <a:buNone/>
+            </a:pPr>
+            <a:r>
+              <a:rPr sz="2000" b="0" u="none">
+                <a:solidFill>
+                  <a:srgbClr val="000000"/>
+                </a:solidFill>
+                <a:latin typeface="Arial"/>
+                <a:ea typeface="Arial"/>
+                <a:cs typeface="Arial"/>
+              </a:rPr>
+              <a:t>• [Pause.]</a:t>
+            </a:r>
+            <a:endParaRPr sz="2000" b="0" u="none">
+              <a:solidFill>
+                <a:srgbClr val="000000"/>
+              </a:solidFill>
+              <a:latin typeface="Arial"/>
+              <a:ea typeface="Arial"/>
+              <a:cs typeface="Arial"/>
+            </a:endParaRPr>
+          </a:p>
+          <a:p xmlns:a="http://schemas.openxmlformats.org/drawingml/2006/main">
+            <a:pPr indent="0" algn="l">
+              <a:lnSpc>
+                <a:spcPct val="100000"/>
+              </a:lnSpc>
+              <a:buNone/>
+            </a:pPr>
+            <a:r>
+              <a:rPr sz="2000" b="0" u="none">
+                <a:solidFill>
+                  <a:srgbClr val="000000"/>
+                </a:solidFill>
+                <a:latin typeface="Arial"/>
+                <a:ea typeface="Arial"/>
+                <a:cs typeface="Arial"/>
+              </a:rPr>
+              <a:t/>
+            </a:r>
+            <a:endParaRPr sz="2000" b="0" u="none">
+              <a:solidFill>
+                <a:srgbClr val="000000"/>
+              </a:solidFill>
+              <a:latin typeface="Arial"/>
+              <a:ea typeface="Arial"/>
+              <a:cs typeface="Arial"/>
+            </a:endParaRPr>
+          </a:p>
+          <a:p xmlns:a="http://schemas.openxmlformats.org/drawingml/2006/main">
+            <a:pPr indent="0" algn="l">
+              <a:lnSpc>
+                <a:spcPct val="100000"/>
+              </a:lnSpc>
+              <a:buNone/>
+            </a:pPr>
+            <a:r>
+              <a:rPr sz="2000" b="0" u="none">
+                <a:solidFill>
+                  <a:srgbClr val="000000"/>
+                </a:solidFill>
+                <a:latin typeface="Arial"/>
+                <a:ea typeface="Arial"/>
+                <a:cs typeface="Arial"/>
+              </a:rPr>
+              <a:t>• The fastest way to understand that boundary is to see both kinds of output.</a:t>
+            </a:r>
+            <a:endParaRPr sz="2000" b="0" u="none">
+              <a:solidFill>
+                <a:srgbClr val="000000"/>
+              </a:solidFill>
+              <a:latin typeface="Arial"/>
+              <a:ea typeface="Arial"/>
+              <a:cs typeface="Arial"/>
+            </a:endParaRPr>
+          </a:p>
+          <a:p xmlns:a="http://schemas.openxmlformats.org/drawingml/2006/main">
+            <a:pPr indent="0" algn="l">
+              <a:lnSpc>
+                <a:spcPct val="100000"/>
+              </a:lnSpc>
+              <a:buNone/>
+            </a:pPr>
+            <a:r>
+              <a:rPr sz="2000" b="0" u="none">
+                <a:solidFill>
+                  <a:srgbClr val="000000"/>
+                </a:solidFill>
+                <a:latin typeface="Arial"/>
+                <a:ea typeface="Arial"/>
+                <a:cs typeface="Arial"/>
+              </a:rPr>
+              <a:t/>
+            </a:r>
+            <a:endParaRPr sz="2000" b="0" u="none">
+              <a:solidFill>
+                <a:srgbClr val="000000"/>
+              </a:solidFill>
+              <a:latin typeface="Arial"/>
+              <a:ea typeface="Arial"/>
+              <a:cs typeface="Arial"/>
+            </a:endParaRPr>
+          </a:p>
+          <a:p xmlns:a="http://schemas.openxmlformats.org/drawingml/2006/main">
+            <a:pPr indent="0" algn="l">
+              <a:lnSpc>
+                <a:spcPct val="100000"/>
+              </a:lnSpc>
+              <a:buNone/>
+            </a:pPr>
+            <a:r>
+              <a:rPr sz="2000" b="0" u="none">
+                <a:solidFill>
+                  <a:srgbClr val="000000"/>
+                </a:solidFill>
+                <a:latin typeface="Arial"/>
+                <a:ea typeface="Arial"/>
+                <a:cs typeface="Arial"/>
+              </a:rPr>
+              <a:t>[Sources]</a:t>
+            </a:r>
+            <a:endParaRPr sz="2000" b="0" u="none">
+              <a:solidFill>
+                <a:srgbClr val="000000"/>
+              </a:solidFill>
+              <a:latin typeface="Arial"/>
+              <a:ea typeface="Arial"/>
+              <a:cs typeface="Arial"/>
+            </a:endParaRPr>
+          </a:p>
+          <a:p xmlns:a="http://schemas.openxmlformats.org/drawingml/2006/main">
+            <a:pPr indent="0" algn="l">
+              <a:lnSpc>
+                <a:spcPct val="100000"/>
+              </a:lnSpc>
+              <a:buNone/>
+            </a:pPr>
+            <a:r>
+              <a:rPr sz="2000" b="0" u="none">
+                <a:solidFill>
+                  <a:srgbClr val="000000"/>
+                </a:solidFill>
+                <a:latin typeface="Arial"/>
+                <a:ea typeface="Arial"/>
+                <a:cs typeface="Arial"/>
+              </a:rPr>
+              <a:t>- docs/system-overview-slide.pptx</a:t>
+            </a:r>
+            <a:endParaRPr sz="2000" b="0" u="none">
+              <a:solidFill>
+                <a:srgbClr val="000000"/>
+              </a:solidFill>
+              <a:latin typeface="Arial"/>
+              <a:ea typeface="Arial"/>
+              <a:cs typeface="Arial"/>
+            </a:endParaRPr>
+          </a:p>
+          <a:p xmlns:a="http://schemas.openxmlformats.org/drawingml/2006/main">
+            <a:pPr indent="0" algn="l">
+              <a:lnSpc>
+                <a:spcPct val="100000"/>
+              </a:lnSpc>
+              <a:buNone/>
+            </a:pPr>
+            <a:r>
+              <a:rPr sz="2000" b="0" u="none">
+                <a:solidFill>
+                  <a:srgbClr val="000000"/>
+                </a:solidFill>
+                <a:latin typeface="Arial"/>
+                <a:ea typeface="Arial"/>
+                <a:cs typeface="Arial"/>
+              </a:rPr>
               <a:t>- docs/architecture.md</a:t>
             </a:r>
             <a:endParaRPr sz="2000" b="0" u="none">
@@ -1342,6 +2635,9 @@
           </a:p>
           <a:p xmlns:a="http://schemas.openxmlformats.org/drawingml/2006/main">
             <a:pPr indent="0" algn="l">
+              <a:lnSpc>
+                <a:spcPct val="100000"/>
+              </a:lnSpc>
               <a:buNone/>
             </a:pPr>
             <a:r>
@@ -1469,7 +2765,7 @@
                 <a:ea typeface="Arial"/>
                 <a:cs typeface="Arial"/>
               </a:rPr>
-              <a:t>[Enter Personio and select Scan.]</a:t>
+              <a:t>• [Enter Personio and select Scan.]</a:t>
             </a:r>
             <a:endParaRPr sz="2000" b="0" u="none">
               <a:solidFill>
@@ -1509,7 +2805,7 @@
                 <a:ea typeface="Arial"/>
                 <a:cs typeface="Arial"/>
               </a:rPr>
-              <a:t>I begin with only a company name. From here, I take my hands off the keyboard and let the workflow run. It is resolving the organisation, researching its public footprint, extracting candidates and checking each claim against the evidence.</a:t>
+              <a:t>• I begin with only a company name.</a:t>
             </a:r>
             <a:endParaRPr sz="2000" b="0" u="none">
               <a:solidFill>
@@ -1549,7 +2845,7 @@
                 <a:ea typeface="Arial"/>
                 <a:cs typeface="Arial"/>
               </a:rPr>
-              <a:t>[If the workflow loops back to research, point to it.]</a:t>
+              <a:t>• From here, I take my hands off the keyboard while the workflow researches, extracts and checks the evidence.</a:t>
             </a:r>
             <a:endParaRPr sz="2000" b="0" u="none">
               <a:solidFill>
@@ -1597,7 +2893,7 @@
                 <a:ea typeface="Arial"/>
                 <a:cs typeface="Arial"/>
               </a:rPr>
-              <a:t>This loop-back is intentional. The gate could not support a proposed claim, so the graph returned to research instead of allowing a plausible-sounding statement into the report.</a:t>
+              <a:t>• [If the workflow loops back to research, point to it.]</a:t>
             </a:r>
             <a:endParaRPr sz="2000" b="0" u="none">
               <a:solidFill>
@@ -1648,7 +2944,7 @@
                 <a:ea typeface="Arial"/>
                 <a:cs typeface="Arial"/>
               </a:rPr>
-              <a:t>[Open the Personio result and point to the highlighted quote.]</a:t>
+              <a:t>• That loop-back is intentional: the gate could not support a claim, so the workflow researched again.</a:t>
             </a:r>
             <a:endParaRPr sz="2000" b="0" u="none">
               <a:solidFill>
@@ -1702,7 +2998,7 @@
                 <a:ea typeface="Arial"/>
                 <a:cs typeface="Arial"/>
               </a:rPr>
-              <a:t>For Personio, the report contains three candidate systems: one evidenced and two undetermined. The important part is not the count; it is this exact sentence: “AI Performance Summaries provide an AI-generated summary…” The adviser can inspect the support immediately, without treating the model's wording as evidence. The two candidates whose current use could not be established are converted into focused client questions.</a:t>
+              <a:t>• [Open the Personio result and point to the highlighted quote.]</a:t>
             </a:r>
             <a:endParaRPr sz="2000" b="0" u="none">
               <a:solidFill>
@@ -1756,7 +3052,7 @@
                 <a:ea typeface="Arial"/>
                 <a:cs typeface="Arial"/>
               </a:rPr>
-              <a:t>[Switch to the Ballymaloe Foods result.]</a:t>
+              <a:t>• Personio has three candidates: one evidenced and two undetermined.</a:t>
             </a:r>
             <a:endParaRPr sz="2000" b="0" u="none">
               <a:solidFill>
@@ -1810,7 +3106,7 @@
                 <a:ea typeface="Arial"/>
                 <a:cs typeface="Arial"/>
               </a:rPr>
-              <a:t>Now compare that with Ballymaloe Foods. The scan found no public evidence, so it claimed zero systems and produced one question to discuss. That does not mean the company uses no AI. It means an external scan cannot see enough to make that claim. This is the honest result: evidence when evidence exists, and a question when it does not.</a:t>
+              <a:t>• The key is this exact supporting sentence—not the model's wording.</a:t>
             </a:r>
             <a:endParaRPr sz="2000" b="0" u="none">
               <a:solidFill>
@@ -1864,7 +3160,7 @@
                 <a:ea typeface="Arial"/>
                 <a:cs typeface="Arial"/>
               </a:rPr>
-              <a:t>[If the live run is unavailable, open the retained sample reports.]</a:t>
+              <a:t>• The two unresolved candidates become focused client questions.</a:t>
             </a:r>
             <a:endParaRPr sz="2000" b="0" u="none">
               <a:solidFill>
@@ -1918,7 +3214,7 @@
                 <a:ea typeface="Arial"/>
                 <a:cs typeface="Arial"/>
               </a:rPr>
-              <a:t>These are pre-generated reports created through the same documented run path.</a:t>
+              <a:t>• [Switch to the Ballymaloe Foods result.]</a:t>
             </a:r>
             <a:endParaRPr sz="2000" b="0" u="none">
               <a:solidFill>
@@ -1972,7 +3268,223 @@
                 <a:ea typeface="Arial"/>
                 <a:cs typeface="Arial"/>
               </a:rPr>
-              <a:t>Those two reports are different because honesty is enforced before a finding ships.</a:t>
+              <a:t>• Here, the scan found no public evidence, so it claimed zero systems and produced one question.</a:t>
+            </a:r>
+            <a:endParaRPr sz="2000" b="0" u="none">
+              <a:solidFill>
+                <a:srgbClr val="000000"/>
+              </a:solidFill>
+              <a:latin typeface="Arial"/>
+              <a:ea typeface="Arial"/>
+              <a:cs typeface="Arial"/>
+            </a:endParaRPr>
+          </a:p>
+          <a:p xmlns:a="http://schemas.openxmlformats.org/drawingml/2006/main">
+            <a:pPr indent="0" algn="l">
+              <a:lnSpc>
+                <a:spcPct val="100000"/>
+              </a:lnSpc>
+              <a:buNone/>
+            </a:pPr>
+            <a:r>
+              <a:rPr sz="2000" b="0" u="none">
+                <a:solidFill>
+                  <a:srgbClr val="000000"/>
+                </a:solidFill>
+                <a:latin typeface="Arial"/>
+                <a:ea typeface="Arial"/>
+                <a:cs typeface="Arial"/>
+              </a:rPr>
+              <a:t/>
+            </a:r>
+            <a:endParaRPr sz="2000" b="0" u="none">
+              <a:solidFill>
+                <a:srgbClr val="000000"/>
+              </a:solidFill>
+              <a:latin typeface="Arial"/>
+              <a:ea typeface="Arial"/>
+              <a:cs typeface="Arial"/>
+            </a:endParaRPr>
+          </a:p>
+          <a:p xmlns:a="http://schemas.openxmlformats.org/drawingml/2006/main">
+            <a:pPr indent="0" algn="l">
+              <a:lnSpc>
+                <a:spcPct val="100000"/>
+              </a:lnSpc>
+              <a:buNone/>
+            </a:pPr>
+            <a:r>
+              <a:rPr sz="2000" b="0" u="none">
+                <a:solidFill>
+                  <a:srgbClr val="000000"/>
+                </a:solidFill>
+                <a:latin typeface="Arial"/>
+                <a:ea typeface="Arial"/>
+                <a:cs typeface="Arial"/>
+              </a:rPr>
+              <a:t>• No public evidence does not mean no AI use; it means the external scan cannot make that claim.</a:t>
+            </a:r>
+            <a:endParaRPr sz="2000" b="0" u="none">
+              <a:solidFill>
+                <a:srgbClr val="000000"/>
+              </a:solidFill>
+              <a:latin typeface="Arial"/>
+              <a:ea typeface="Arial"/>
+              <a:cs typeface="Arial"/>
+            </a:endParaRPr>
+          </a:p>
+          <a:p xmlns:a="http://schemas.openxmlformats.org/drawingml/2006/main">
+            <a:pPr indent="0" algn="l">
+              <a:lnSpc>
+                <a:spcPct val="100000"/>
+              </a:lnSpc>
+              <a:buNone/>
+            </a:pPr>
+            <a:r>
+              <a:rPr sz="2000" b="0" u="none">
+                <a:solidFill>
+                  <a:srgbClr val="000000"/>
+                </a:solidFill>
+                <a:latin typeface="Arial"/>
+                <a:ea typeface="Arial"/>
+                <a:cs typeface="Arial"/>
+              </a:rPr>
+              <a:t/>
+            </a:r>
+            <a:endParaRPr sz="2000" b="0" u="none">
+              <a:solidFill>
+                <a:srgbClr val="000000"/>
+              </a:solidFill>
+              <a:latin typeface="Arial"/>
+              <a:ea typeface="Arial"/>
+              <a:cs typeface="Arial"/>
+            </a:endParaRPr>
+          </a:p>
+          <a:p xmlns:a="http://schemas.openxmlformats.org/drawingml/2006/main">
+            <a:pPr indent="0" algn="l">
+              <a:lnSpc>
+                <a:spcPct val="100000"/>
+              </a:lnSpc>
+              <a:buNone/>
+            </a:pPr>
+            <a:r>
+              <a:rPr sz="2000" b="0" u="none">
+                <a:solidFill>
+                  <a:srgbClr val="000000"/>
+                </a:solidFill>
+                <a:latin typeface="Arial"/>
+                <a:ea typeface="Arial"/>
+                <a:cs typeface="Arial"/>
+              </a:rPr>
+              <a:t>• [If the live run is unavailable, open the retained sample reports.]</a:t>
+            </a:r>
+            <a:endParaRPr sz="2000" b="0" u="none">
+              <a:solidFill>
+                <a:srgbClr val="000000"/>
+              </a:solidFill>
+              <a:latin typeface="Arial"/>
+              <a:ea typeface="Arial"/>
+              <a:cs typeface="Arial"/>
+            </a:endParaRPr>
+          </a:p>
+          <a:p xmlns:a="http://schemas.openxmlformats.org/drawingml/2006/main">
+            <a:pPr indent="0" algn="l">
+              <a:lnSpc>
+                <a:spcPct val="100000"/>
+              </a:lnSpc>
+              <a:buNone/>
+            </a:pPr>
+            <a:r>
+              <a:rPr sz="2000" b="0" u="none">
+                <a:solidFill>
+                  <a:srgbClr val="000000"/>
+                </a:solidFill>
+                <a:latin typeface="Arial"/>
+                <a:ea typeface="Arial"/>
+                <a:cs typeface="Arial"/>
+              </a:rPr>
+              <a:t/>
+            </a:r>
+            <a:endParaRPr sz="2000" b="0" u="none">
+              <a:solidFill>
+                <a:srgbClr val="000000"/>
+              </a:solidFill>
+              <a:latin typeface="Arial"/>
+              <a:ea typeface="Arial"/>
+              <a:cs typeface="Arial"/>
+            </a:endParaRPr>
+          </a:p>
+          <a:p xmlns:a="http://schemas.openxmlformats.org/drawingml/2006/main">
+            <a:pPr indent="0" algn="l">
+              <a:lnSpc>
+                <a:spcPct val="100000"/>
+              </a:lnSpc>
+              <a:buNone/>
+            </a:pPr>
+            <a:r>
+              <a:rPr sz="2000" b="0" u="none">
+                <a:solidFill>
+                  <a:srgbClr val="000000"/>
+                </a:solidFill>
+                <a:latin typeface="Arial"/>
+                <a:ea typeface="Arial"/>
+                <a:cs typeface="Arial"/>
+              </a:rPr>
+              <a:t>• These reports were generated through the same documented run path.</a:t>
+            </a:r>
+            <a:endParaRPr sz="2000" b="0" u="none">
+              <a:solidFill>
+                <a:srgbClr val="000000"/>
+              </a:solidFill>
+              <a:latin typeface="Arial"/>
+              <a:ea typeface="Arial"/>
+              <a:cs typeface="Arial"/>
+            </a:endParaRPr>
+          </a:p>
+          <a:p xmlns:a="http://schemas.openxmlformats.org/drawingml/2006/main">
+            <a:pPr indent="0" algn="l">
+              <a:lnSpc>
+                <a:spcPct val="100000"/>
+              </a:lnSpc>
+              <a:buNone/>
+            </a:pPr>
+            <a:r>
+              <a:rPr sz="2000" b="0" u="none">
+                <a:solidFill>
+                  <a:srgbClr val="000000"/>
+                </a:solidFill>
+                <a:latin typeface="Arial"/>
+                <a:ea typeface="Arial"/>
+                <a:cs typeface="Arial"/>
+              </a:rPr>
+              <a:t/>
+            </a:r>
+            <a:endParaRPr sz="2000" b="0" u="none">
+              <a:solidFill>
+                <a:srgbClr val="000000"/>
+              </a:solidFill>
+              <a:latin typeface="Arial"/>
+              <a:ea typeface="Arial"/>
+              <a:cs typeface="Arial"/>
+            </a:endParaRPr>
+          </a:p>
+          <a:p xmlns:a="http://schemas.openxmlformats.org/drawingml/2006/main">
+            <a:pPr indent="0" algn="l">
+              <a:lnSpc>
+                <a:spcPct val="100000"/>
+              </a:lnSpc>
+              <a:buNone/>
+            </a:pPr>
+            <a:r>
+              <a:rPr sz="2000" b="0" u="none">
+                <a:solidFill>
+                  <a:srgbClr val="000000"/>
+                </a:solidFill>
+                <a:latin typeface="Arial"/>
+                <a:ea typeface="Arial"/>
+                <a:cs typeface="Arial"/>
+              </a:rPr>
+              <a:t>• Those two reports are different because honesty is enforced before a finding ships.</a:t>
             </a:r>
             <a:endParaRPr sz="2000" b="0" u="none">
               <a:solidFill>
@@ -2223,7 +3735,7 @@
                 <a:ea typeface="Arial"/>
                 <a:cs typeface="Arial"/>
               </a:rPr>
-              <a:t>This gate is the core trust mechanism. A model cannot ship a finding merely because it sounds plausible. Three checks must pass: the exact quote exists in the fetched source, the provenance is complete and the source is current enough for the claim being made. If any check fails, the workflow researches again. If it still cannot support the claim, the result becomes undetermined and the uncertainty becomes a client question. Across five evaluation runs, honest refusal stayed at one hundred percent, thin-company false positives stayed at zero and provenance violations stayed at zero. The trust comes from the gate, not from asking the model to be careful.</a:t>
+              <a:t>• This gate is the trust mechanism.</a:t>
             </a:r>
             <a:endParaRPr sz="2000" b="0" u="none">
               <a:solidFill>
@@ -2263,7 +3775,7 @@
                 <a:ea typeface="Arial"/>
                 <a:cs typeface="Arial"/>
               </a:rPr>
-              <a:t>That gate also explains the stack choice.</a:t>
+              <a:t>• A finding ships only when all three checks pass.</a:t>
             </a:r>
             <a:endParaRPr sz="2000" b="0" u="none">
               <a:solidFill>
@@ -2303,7 +3815,7 @@
                 <a:ea typeface="Arial"/>
                 <a:cs typeface="Arial"/>
               </a:rPr>
-              <a:t>[Sources]</a:t>
+              <a:t>• One: the exact quote exists in the fetched source.</a:t>
             </a:r>
             <a:endParaRPr sz="2000" b="0" u="none">
               <a:solidFill>
@@ -2327,7 +3839,7 @@
                 <a:ea typeface="Arial"/>
                 <a:cs typeface="Arial"/>
               </a:rPr>
-              <a:t>- src/ai_prescan/gate.py</a:t>
+              <a:t/>
             </a:r>
             <a:endParaRPr sz="2000" b="0" u="none">
               <a:solidFill>
@@ -2351,6 +3863,489 @@
                 <a:ea typeface="Arial"/>
                 <a:cs typeface="Arial"/>
               </a:rPr>
+              <a:t>• Two: the source is traceable, with complete identity and retrieval details.</a:t>
+            </a:r>
+            <a:endParaRPr sz="2000" b="0" u="none">
+              <a:solidFill>
+                <a:srgbClr val="000000"/>
+              </a:solidFill>
+              <a:latin typeface="Arial"/>
+              <a:ea typeface="Arial"/>
+              <a:cs typeface="Arial"/>
+            </a:endParaRPr>
+          </a:p>
+          <a:p xmlns:a="http://schemas.openxmlformats.org/drawingml/2006/main">
+            <a:pPr indent="0" algn="l">
+              <a:buNone/>
+            </a:pPr>
+            <a:r>
+              <a:rPr sz="2000" b="0" u="none">
+                <a:solidFill>
+                  <a:srgbClr val="000000"/>
+                </a:solidFill>
+                <a:latin typeface="Arial"/>
+                <a:ea typeface="Arial"/>
+                <a:cs typeface="Arial"/>
+              </a:rPr>
+              <a:t/>
+            </a:r>
+            <a:endParaRPr sz="2000" b="0" u="none">
+              <a:solidFill>
+                <a:srgbClr val="000000"/>
+              </a:solidFill>
+              <a:latin typeface="Arial"/>
+              <a:ea typeface="Arial"/>
+              <a:cs typeface="Arial"/>
+            </a:endParaRPr>
+          </a:p>
+          <a:p xmlns:a="http://schemas.openxmlformats.org/drawingml/2006/main">
+            <a:pPr indent="0" algn="l">
+              <a:lnSpc>
+                <a:spcPct val="100000"/>
+              </a:lnSpc>
+              <a:buNone/>
+            </a:pPr>
+            <a:r>
+              <a:rPr sz="2000" b="0" u="none">
+                <a:solidFill>
+                  <a:srgbClr val="000000"/>
+                </a:solidFill>
+                <a:latin typeface="Arial"/>
+                <a:ea typeface="Arial"/>
+                <a:cs typeface="Arial"/>
+              </a:rPr>
+              <a:t>• Three: the source is current enough for the claim.</a:t>
+            </a:r>
+            <a:endParaRPr sz="2000" b="0" u="none">
+              <a:solidFill>
+                <a:srgbClr val="000000"/>
+              </a:solidFill>
+              <a:latin typeface="Arial"/>
+              <a:ea typeface="Arial"/>
+              <a:cs typeface="Arial"/>
+            </a:endParaRPr>
+          </a:p>
+          <a:p xmlns:a="http://schemas.openxmlformats.org/drawingml/2006/main">
+            <a:pPr indent="0" algn="l">
+              <a:lnSpc>
+                <a:spcPct val="100000"/>
+              </a:lnSpc>
+              <a:buNone/>
+            </a:pPr>
+            <a:r>
+              <a:rPr sz="2000" b="0" u="none">
+                <a:solidFill>
+                  <a:srgbClr val="000000"/>
+                </a:solidFill>
+                <a:latin typeface="Arial"/>
+                <a:ea typeface="Arial"/>
+                <a:cs typeface="Arial"/>
+              </a:rPr>
+              <a:t/>
+            </a:r>
+            <a:endParaRPr sz="2000" b="0" u="none">
+              <a:solidFill>
+                <a:srgbClr val="000000"/>
+              </a:solidFill>
+              <a:latin typeface="Arial"/>
+              <a:ea typeface="Arial"/>
+              <a:cs typeface="Arial"/>
+            </a:endParaRPr>
+          </a:p>
+          <a:p xmlns:a="http://schemas.openxmlformats.org/drawingml/2006/main">
+            <a:pPr indent="0" algn="l">
+              <a:lnSpc>
+                <a:spcPct val="100000"/>
+              </a:lnSpc>
+              <a:buNone/>
+            </a:pPr>
+            <a:r>
+              <a:rPr sz="2000" b="0" u="none">
+                <a:solidFill>
+                  <a:srgbClr val="000000"/>
+                </a:solidFill>
+                <a:latin typeface="Arial"/>
+                <a:ea typeface="Arial"/>
+                <a:cs typeface="Arial"/>
+              </a:rPr>
+              <a:t>• If a check fails, the workflow researches again.</a:t>
+            </a:r>
+            <a:endParaRPr sz="2000" b="0" u="none">
+              <a:solidFill>
+                <a:srgbClr val="000000"/>
+              </a:solidFill>
+              <a:latin typeface="Arial"/>
+              <a:ea typeface="Arial"/>
+              <a:cs typeface="Arial"/>
+            </a:endParaRPr>
+          </a:p>
+          <a:p xmlns:a="http://schemas.openxmlformats.org/drawingml/2006/main">
+            <a:pPr indent="0" algn="l">
+              <a:lnSpc>
+                <a:spcPct val="100000"/>
+              </a:lnSpc>
+              <a:buNone/>
+            </a:pPr>
+            <a:r>
+              <a:rPr sz="2000" b="0" u="none">
+                <a:solidFill>
+                  <a:srgbClr val="000000"/>
+                </a:solidFill>
+                <a:latin typeface="Arial"/>
+                <a:ea typeface="Arial"/>
+                <a:cs typeface="Arial"/>
+              </a:rPr>
+              <a:t/>
+            </a:r>
+            <a:endParaRPr sz="2000" b="0" u="none">
+              <a:solidFill>
+                <a:srgbClr val="000000"/>
+              </a:solidFill>
+              <a:latin typeface="Arial"/>
+              <a:ea typeface="Arial"/>
+              <a:cs typeface="Arial"/>
+            </a:endParaRPr>
+          </a:p>
+          <a:p xmlns:a="http://schemas.openxmlformats.org/drawingml/2006/main">
+            <a:pPr indent="0" algn="l">
+              <a:lnSpc>
+                <a:spcPct val="100000"/>
+              </a:lnSpc>
+              <a:buNone/>
+            </a:pPr>
+            <a:r>
+              <a:rPr sz="2000" b="0" u="none">
+                <a:solidFill>
+                  <a:srgbClr val="000000"/>
+                </a:solidFill>
+                <a:latin typeface="Arial"/>
+                <a:ea typeface="Arial"/>
+                <a:cs typeface="Arial"/>
+              </a:rPr>
+              <a:t>• If support still cannot be found, the result becomes undetermined and the uncertainty becomes a client question.</a:t>
+            </a:r>
+            <a:endParaRPr sz="2000" b="0" u="none">
+              <a:solidFill>
+                <a:srgbClr val="000000"/>
+              </a:solidFill>
+              <a:latin typeface="Arial"/>
+              <a:ea typeface="Arial"/>
+              <a:cs typeface="Arial"/>
+            </a:endParaRPr>
+          </a:p>
+          <a:p xmlns:a="http://schemas.openxmlformats.org/drawingml/2006/main">
+            <a:pPr indent="0" algn="l">
+              <a:lnSpc>
+                <a:spcPct val="100000"/>
+              </a:lnSpc>
+              <a:buNone/>
+            </a:pPr>
+            <a:r>
+              <a:rPr sz="2000" b="0" u="none">
+                <a:solidFill>
+                  <a:srgbClr val="000000"/>
+                </a:solidFill>
+                <a:latin typeface="Arial"/>
+                <a:ea typeface="Arial"/>
+                <a:cs typeface="Arial"/>
+              </a:rPr>
+              <a:t/>
+            </a:r>
+            <a:endParaRPr sz="2000" b="0" u="none">
+              <a:solidFill>
+                <a:srgbClr val="000000"/>
+              </a:solidFill>
+              <a:latin typeface="Arial"/>
+              <a:ea typeface="Arial"/>
+              <a:cs typeface="Arial"/>
+            </a:endParaRPr>
+          </a:p>
+          <a:p xmlns:a="http://schemas.openxmlformats.org/drawingml/2006/main">
+            <a:pPr indent="0" algn="l">
+              <a:lnSpc>
+                <a:spcPct val="100000"/>
+              </a:lnSpc>
+              <a:buNone/>
+            </a:pPr>
+            <a:r>
+              <a:rPr sz="2000" b="0" u="none">
+                <a:solidFill>
+                  <a:srgbClr val="000000"/>
+                </a:solidFill>
+                <a:latin typeface="Arial"/>
+                <a:ea typeface="Arial"/>
+                <a:cs typeface="Arial"/>
+              </a:rPr>
+              <a:t>• Across five runs: unsupported claims refused, 1.0; false claims on thin-data companies, 0; missing source details, 0.</a:t>
+            </a:r>
+            <a:endParaRPr sz="2000" b="0" u="none">
+              <a:solidFill>
+                <a:srgbClr val="000000"/>
+              </a:solidFill>
+              <a:latin typeface="Arial"/>
+              <a:ea typeface="Arial"/>
+              <a:cs typeface="Arial"/>
+            </a:endParaRPr>
+          </a:p>
+          <a:p xmlns:a="http://schemas.openxmlformats.org/drawingml/2006/main">
+            <a:pPr indent="0" algn="l">
+              <a:lnSpc>
+                <a:spcPct val="100000"/>
+              </a:lnSpc>
+              <a:buNone/>
+            </a:pPr>
+            <a:r>
+              <a:rPr sz="2000" b="0" u="none">
+                <a:solidFill>
+                  <a:srgbClr val="000000"/>
+                </a:solidFill>
+                <a:latin typeface="Arial"/>
+                <a:ea typeface="Arial"/>
+                <a:cs typeface="Arial"/>
+              </a:rPr>
+              <a:t/>
+            </a:r>
+            <a:endParaRPr sz="2000" b="0" u="none">
+              <a:solidFill>
+                <a:srgbClr val="000000"/>
+              </a:solidFill>
+              <a:latin typeface="Arial"/>
+              <a:ea typeface="Arial"/>
+              <a:cs typeface="Arial"/>
+            </a:endParaRPr>
+          </a:p>
+          <a:p xmlns:a="http://schemas.openxmlformats.org/drawingml/2006/main">
+            <a:pPr indent="0" algn="l">
+              <a:lnSpc>
+                <a:spcPct val="100000"/>
+              </a:lnSpc>
+              <a:buNone/>
+            </a:pPr>
+            <a:r>
+              <a:rPr sz="2000" b="0" u="none">
+                <a:solidFill>
+                  <a:srgbClr val="000000"/>
+                </a:solidFill>
+                <a:latin typeface="Arial"/>
+                <a:ea typeface="Arial"/>
+                <a:cs typeface="Arial"/>
+              </a:rPr>
+              <a:t>• [Pause.]</a:t>
+            </a:r>
+            <a:endParaRPr sz="2000" b="0" u="none">
+              <a:solidFill>
+                <a:srgbClr val="000000"/>
+              </a:solidFill>
+              <a:latin typeface="Arial"/>
+              <a:ea typeface="Arial"/>
+              <a:cs typeface="Arial"/>
+            </a:endParaRPr>
+          </a:p>
+          <a:p xmlns:a="http://schemas.openxmlformats.org/drawingml/2006/main">
+            <a:pPr indent="0" algn="l">
+              <a:lnSpc>
+                <a:spcPct val="100000"/>
+              </a:lnSpc>
+              <a:buNone/>
+            </a:pPr>
+            <a:r>
+              <a:rPr sz="2000" b="0" u="none">
+                <a:solidFill>
+                  <a:srgbClr val="000000"/>
+                </a:solidFill>
+                <a:latin typeface="Arial"/>
+                <a:ea typeface="Arial"/>
+                <a:cs typeface="Arial"/>
+              </a:rPr>
+              <a:t/>
+            </a:r>
+            <a:endParaRPr sz="2000" b="0" u="none">
+              <a:solidFill>
+                <a:srgbClr val="000000"/>
+              </a:solidFill>
+              <a:latin typeface="Arial"/>
+              <a:ea typeface="Arial"/>
+              <a:cs typeface="Arial"/>
+            </a:endParaRPr>
+          </a:p>
+          <a:p xmlns:a="http://schemas.openxmlformats.org/drawingml/2006/main">
+            <a:pPr indent="0" algn="l">
+              <a:lnSpc>
+                <a:spcPct val="100000"/>
+              </a:lnSpc>
+              <a:buNone/>
+            </a:pPr>
+            <a:r>
+              <a:rPr sz="2000" b="0" u="none">
+                <a:solidFill>
+                  <a:srgbClr val="000000"/>
+                </a:solidFill>
+                <a:latin typeface="Arial"/>
+                <a:ea typeface="Arial"/>
+                <a:cs typeface="Arial"/>
+              </a:rPr>
+              <a:t>• The trust comes from the gate, not from asking the model to be careful.</a:t>
+            </a:r>
+            <a:endParaRPr sz="2000" b="0" u="none">
+              <a:solidFill>
+                <a:srgbClr val="000000"/>
+              </a:solidFill>
+              <a:latin typeface="Arial"/>
+              <a:ea typeface="Arial"/>
+              <a:cs typeface="Arial"/>
+            </a:endParaRPr>
+          </a:p>
+          <a:p xmlns:a="http://schemas.openxmlformats.org/drawingml/2006/main">
+            <a:pPr indent="0" algn="l">
+              <a:lnSpc>
+                <a:spcPct val="100000"/>
+              </a:lnSpc>
+              <a:buNone/>
+            </a:pPr>
+            <a:r>
+              <a:rPr sz="2000" b="0" u="none">
+                <a:solidFill>
+                  <a:srgbClr val="000000"/>
+                </a:solidFill>
+                <a:latin typeface="Arial"/>
+                <a:ea typeface="Arial"/>
+                <a:cs typeface="Arial"/>
+              </a:rPr>
+              <a:t/>
+            </a:r>
+            <a:endParaRPr sz="2000" b="0" u="none">
+              <a:solidFill>
+                <a:srgbClr val="000000"/>
+              </a:solidFill>
+              <a:latin typeface="Arial"/>
+              <a:ea typeface="Arial"/>
+              <a:cs typeface="Arial"/>
+            </a:endParaRPr>
+          </a:p>
+          <a:p xmlns:a="http://schemas.openxmlformats.org/drawingml/2006/main">
+            <a:pPr indent="0" algn="l">
+              <a:lnSpc>
+                <a:spcPct val="100000"/>
+              </a:lnSpc>
+              <a:buNone/>
+            </a:pPr>
+            <a:r>
+              <a:rPr sz="2000" b="0" u="none">
+                <a:solidFill>
+                  <a:srgbClr val="000000"/>
+                </a:solidFill>
+                <a:latin typeface="Arial"/>
+                <a:ea typeface="Arial"/>
+                <a:cs typeface="Arial"/>
+              </a:rPr>
+              <a:t>• That gate also explains the stack choice.</a:t>
+            </a:r>
+            <a:endParaRPr sz="2000" b="0" u="none">
+              <a:solidFill>
+                <a:srgbClr val="000000"/>
+              </a:solidFill>
+              <a:latin typeface="Arial"/>
+              <a:ea typeface="Arial"/>
+              <a:cs typeface="Arial"/>
+            </a:endParaRPr>
+          </a:p>
+          <a:p xmlns:a="http://schemas.openxmlformats.org/drawingml/2006/main">
+            <a:pPr indent="0" algn="l">
+              <a:lnSpc>
+                <a:spcPct val="100000"/>
+              </a:lnSpc>
+              <a:buNone/>
+            </a:pPr>
+            <a:r>
+              <a:rPr sz="2000" b="0" u="none">
+                <a:solidFill>
+                  <a:srgbClr val="000000"/>
+                </a:solidFill>
+                <a:latin typeface="Arial"/>
+                <a:ea typeface="Arial"/>
+                <a:cs typeface="Arial"/>
+              </a:rPr>
+              <a:t/>
+            </a:r>
+            <a:endParaRPr sz="2000" b="0" u="none">
+              <a:solidFill>
+                <a:srgbClr val="000000"/>
+              </a:solidFill>
+              <a:latin typeface="Arial"/>
+              <a:ea typeface="Arial"/>
+              <a:cs typeface="Arial"/>
+            </a:endParaRPr>
+          </a:p>
+          <a:p xmlns:a="http://schemas.openxmlformats.org/drawingml/2006/main">
+            <a:pPr indent="0" algn="l">
+              <a:lnSpc>
+                <a:spcPct val="100000"/>
+              </a:lnSpc>
+              <a:buNone/>
+            </a:pPr>
+            <a:r>
+              <a:rPr sz="2000" b="0" u="none">
+                <a:solidFill>
+                  <a:srgbClr val="000000"/>
+                </a:solidFill>
+                <a:latin typeface="Arial"/>
+                <a:ea typeface="Arial"/>
+                <a:cs typeface="Arial"/>
+              </a:rPr>
+              <a:t>[Sources]</a:t>
+            </a:r>
+            <a:endParaRPr sz="2000" b="0" u="none">
+              <a:solidFill>
+                <a:srgbClr val="000000"/>
+              </a:solidFill>
+              <a:latin typeface="Arial"/>
+              <a:ea typeface="Arial"/>
+              <a:cs typeface="Arial"/>
+            </a:endParaRPr>
+          </a:p>
+          <a:p xmlns:a="http://schemas.openxmlformats.org/drawingml/2006/main">
+            <a:pPr indent="0" algn="l">
+              <a:lnSpc>
+                <a:spcPct val="100000"/>
+              </a:lnSpc>
+              <a:buNone/>
+            </a:pPr>
+            <a:r>
+              <a:rPr sz="2000" b="0" u="none">
+                <a:solidFill>
+                  <a:srgbClr val="000000"/>
+                </a:solidFill>
+                <a:latin typeface="Arial"/>
+                <a:ea typeface="Arial"/>
+                <a:cs typeface="Arial"/>
+              </a:rPr>
+              <a:t>- src/ai_prescan/gate.py</a:t>
+            </a:r>
+            <a:endParaRPr sz="2000" b="0" u="none">
+              <a:solidFill>
+                <a:srgbClr val="000000"/>
+              </a:solidFill>
+              <a:latin typeface="Arial"/>
+              <a:ea typeface="Arial"/>
+              <a:cs typeface="Arial"/>
+            </a:endParaRPr>
+          </a:p>
+          <a:p xmlns:a="http://schemas.openxmlformats.org/drawingml/2006/main">
+            <a:pPr indent="0" algn="l">
+              <a:lnSpc>
+                <a:spcPct val="100000"/>
+              </a:lnSpc>
+              <a:buNone/>
+            </a:pPr>
+            <a:r>
+              <a:rPr sz="2000" b="0" u="none">
+                <a:solidFill>
+                  <a:srgbClr val="000000"/>
+                </a:solidFill>
+                <a:latin typeface="Arial"/>
+                <a:ea typeface="Arial"/>
+                <a:cs typeface="Arial"/>
+              </a:rPr>
               <a:t>- eval/results.md</a:t>
             </a:r>
             <a:endParaRPr sz="2000" b="0" u="none">
@@ -2364,6 +4359,9 @@
           </a:p>
           <a:p xmlns:a="http://schemas.openxmlformats.org/drawingml/2006/main">
             <a:pPr indent="0" algn="l">
+              <a:lnSpc>
+                <a:spcPct val="100000"/>
+              </a:lnSpc>
               <a:buNone/>
             </a:pPr>
             <a:r>
@@ -2491,7 +4489,7 @@
                 <a:ea typeface="Arial"/>
                 <a:cs typeface="Arial"/>
               </a:rPr>
-              <a:t>LangGraph is the primary orchestration layer because the deterministic evidence gate has to sit inside the decision loop. A supported finding moves forward to the report. A failed check sends the workflow back to research. When the retry limit is reached, the claim becomes undetermined rather than being forced through. n8n has a deliberately narrower role: it receives the finished report and files it in Notion. It does not research, judge evidence or make compliance decisions. We verified that delivery from the Notion API response itself, not merely from n8n reporting a successful run.</a:t>
+              <a:t>• LangGraph keeps the deterministic evidence gate inside the workflow loop.</a:t>
             </a:r>
             <a:endParaRPr sz="2000" b="0" u="none">
               <a:solidFill>
@@ -2531,7 +4529,7 @@
                 <a:ea typeface="Arial"/>
                 <a:cs typeface="Arial"/>
               </a:rPr>
-              <a:t>The same architecture points to a recurring product, not just a one-off scan.</a:t>
+              <a:t>• If the evidence checks pass, supported facts and questions move to the report.</a:t>
             </a:r>
             <a:endParaRPr sz="2000" b="0" u="none">
               <a:solidFill>
@@ -2571,7 +4569,7 @@
                 <a:ea typeface="Arial"/>
                 <a:cs typeface="Arial"/>
               </a:rPr>
-              <a:t>[Sources]</a:t>
+              <a:t>• If a check fails and retries remain, the workflow researches again.</a:t>
             </a:r>
             <a:endParaRPr sz="2000" b="0" u="none">
               <a:solidFill>
@@ -2595,7 +4593,7 @@
                 <a:ea typeface="Arial"/>
                 <a:cs typeface="Arial"/>
               </a:rPr>
-              <a:t>- stack_decision.md</a:t>
+              <a:t/>
             </a:r>
             <a:endParaRPr sz="2000" b="0" u="none">
               <a:solidFill>
@@ -2619,6 +4617,381 @@
                 <a:ea typeface="Arial"/>
                 <a:cs typeface="Arial"/>
               </a:rPr>
+              <a:t>• If no retries remain, the claim becomes undetermined.</a:t>
+            </a:r>
+            <a:endParaRPr sz="2000" b="0" u="none">
+              <a:solidFill>
+                <a:srgbClr val="000000"/>
+              </a:solidFill>
+              <a:latin typeface="Arial"/>
+              <a:ea typeface="Arial"/>
+              <a:cs typeface="Arial"/>
+            </a:endParaRPr>
+          </a:p>
+          <a:p xmlns:a="http://schemas.openxmlformats.org/drawingml/2006/main">
+            <a:pPr indent="0" algn="l">
+              <a:buNone/>
+            </a:pPr>
+            <a:r>
+              <a:rPr sz="2000" b="0" u="none">
+                <a:solidFill>
+                  <a:srgbClr val="000000"/>
+                </a:solidFill>
+                <a:latin typeface="Arial"/>
+                <a:ea typeface="Arial"/>
+                <a:cs typeface="Arial"/>
+              </a:rPr>
+              <a:t/>
+            </a:r>
+            <a:endParaRPr sz="2000" b="0" u="none">
+              <a:solidFill>
+                <a:srgbClr val="000000"/>
+              </a:solidFill>
+              <a:latin typeface="Arial"/>
+              <a:ea typeface="Arial"/>
+              <a:cs typeface="Arial"/>
+            </a:endParaRPr>
+          </a:p>
+          <a:p xmlns:a="http://schemas.openxmlformats.org/drawingml/2006/main">
+            <a:pPr indent="0" algn="l">
+              <a:lnSpc>
+                <a:spcPct val="100000"/>
+              </a:lnSpc>
+              <a:buNone/>
+            </a:pPr>
+            <a:r>
+              <a:rPr sz="2000" b="0" u="none">
+                <a:solidFill>
+                  <a:srgbClr val="000000"/>
+                </a:solidFill>
+                <a:latin typeface="Arial"/>
+                <a:ea typeface="Arial"/>
+                <a:cs typeface="Arial"/>
+              </a:rPr>
+              <a:t>• Nothing is forced through.</a:t>
+            </a:r>
+            <a:endParaRPr sz="2000" b="0" u="none">
+              <a:solidFill>
+                <a:srgbClr val="000000"/>
+              </a:solidFill>
+              <a:latin typeface="Arial"/>
+              <a:ea typeface="Arial"/>
+              <a:cs typeface="Arial"/>
+            </a:endParaRPr>
+          </a:p>
+          <a:p xmlns:a="http://schemas.openxmlformats.org/drawingml/2006/main">
+            <a:pPr indent="0" algn="l">
+              <a:lnSpc>
+                <a:spcPct val="100000"/>
+              </a:lnSpc>
+              <a:buNone/>
+            </a:pPr>
+            <a:r>
+              <a:rPr sz="2000" b="0" u="none">
+                <a:solidFill>
+                  <a:srgbClr val="000000"/>
+                </a:solidFill>
+                <a:latin typeface="Arial"/>
+                <a:ea typeface="Arial"/>
+                <a:cs typeface="Arial"/>
+              </a:rPr>
+              <a:t/>
+            </a:r>
+            <a:endParaRPr sz="2000" b="0" u="none">
+              <a:solidFill>
+                <a:srgbClr val="000000"/>
+              </a:solidFill>
+              <a:latin typeface="Arial"/>
+              <a:ea typeface="Arial"/>
+              <a:cs typeface="Arial"/>
+            </a:endParaRPr>
+          </a:p>
+          <a:p xmlns:a="http://schemas.openxmlformats.org/drawingml/2006/main">
+            <a:pPr indent="0" algn="l">
+              <a:lnSpc>
+                <a:spcPct val="100000"/>
+              </a:lnSpc>
+              <a:buNone/>
+            </a:pPr>
+            <a:r>
+              <a:rPr sz="2000" b="0" u="none">
+                <a:solidFill>
+                  <a:srgbClr val="000000"/>
+                </a:solidFill>
+                <a:latin typeface="Arial"/>
+                <a:ea typeface="Arial"/>
+                <a:cs typeface="Arial"/>
+              </a:rPr>
+              <a:t>• The grey rail is separate: n8n only files the finished report in Notion.</a:t>
+            </a:r>
+            <a:endParaRPr sz="2000" b="0" u="none">
+              <a:solidFill>
+                <a:srgbClr val="000000"/>
+              </a:solidFill>
+              <a:latin typeface="Arial"/>
+              <a:ea typeface="Arial"/>
+              <a:cs typeface="Arial"/>
+            </a:endParaRPr>
+          </a:p>
+          <a:p xmlns:a="http://schemas.openxmlformats.org/drawingml/2006/main">
+            <a:pPr indent="0" algn="l">
+              <a:lnSpc>
+                <a:spcPct val="100000"/>
+              </a:lnSpc>
+              <a:buNone/>
+            </a:pPr>
+            <a:r>
+              <a:rPr sz="2000" b="0" u="none">
+                <a:solidFill>
+                  <a:srgbClr val="000000"/>
+                </a:solidFill>
+                <a:latin typeface="Arial"/>
+                <a:ea typeface="Arial"/>
+                <a:cs typeface="Arial"/>
+              </a:rPr>
+              <a:t/>
+            </a:r>
+            <a:endParaRPr sz="2000" b="0" u="none">
+              <a:solidFill>
+                <a:srgbClr val="000000"/>
+              </a:solidFill>
+              <a:latin typeface="Arial"/>
+              <a:ea typeface="Arial"/>
+              <a:cs typeface="Arial"/>
+            </a:endParaRPr>
+          </a:p>
+          <a:p xmlns:a="http://schemas.openxmlformats.org/drawingml/2006/main">
+            <a:pPr indent="0" algn="l">
+              <a:lnSpc>
+                <a:spcPct val="100000"/>
+              </a:lnSpc>
+              <a:buNone/>
+            </a:pPr>
+            <a:r>
+              <a:rPr sz="2000" b="0" u="none">
+                <a:solidFill>
+                  <a:srgbClr val="000000"/>
+                </a:solidFill>
+                <a:latin typeface="Arial"/>
+                <a:ea typeface="Arial"/>
+                <a:cs typeface="Arial"/>
+              </a:rPr>
+              <a:t>• n8n does not research, judge evidence or make compliance decisions.</a:t>
+            </a:r>
+            <a:endParaRPr sz="2000" b="0" u="none">
+              <a:solidFill>
+                <a:srgbClr val="000000"/>
+              </a:solidFill>
+              <a:latin typeface="Arial"/>
+              <a:ea typeface="Arial"/>
+              <a:cs typeface="Arial"/>
+            </a:endParaRPr>
+          </a:p>
+          <a:p xmlns:a="http://schemas.openxmlformats.org/drawingml/2006/main">
+            <a:pPr indent="0" algn="l">
+              <a:lnSpc>
+                <a:spcPct val="100000"/>
+              </a:lnSpc>
+              <a:buNone/>
+            </a:pPr>
+            <a:r>
+              <a:rPr sz="2000" b="0" u="none">
+                <a:solidFill>
+                  <a:srgbClr val="000000"/>
+                </a:solidFill>
+                <a:latin typeface="Arial"/>
+                <a:ea typeface="Arial"/>
+                <a:cs typeface="Arial"/>
+              </a:rPr>
+              <a:t/>
+            </a:r>
+            <a:endParaRPr sz="2000" b="0" u="none">
+              <a:solidFill>
+                <a:srgbClr val="000000"/>
+              </a:solidFill>
+              <a:latin typeface="Arial"/>
+              <a:ea typeface="Arial"/>
+              <a:cs typeface="Arial"/>
+            </a:endParaRPr>
+          </a:p>
+          <a:p xmlns:a="http://schemas.openxmlformats.org/drawingml/2006/main">
+            <a:pPr indent="0" algn="l">
+              <a:lnSpc>
+                <a:spcPct val="100000"/>
+              </a:lnSpc>
+              <a:buNone/>
+            </a:pPr>
+            <a:r>
+              <a:rPr sz="2000" b="0" u="none">
+                <a:solidFill>
+                  <a:srgbClr val="000000"/>
+                </a:solidFill>
+                <a:latin typeface="Arial"/>
+                <a:ea typeface="Arial"/>
+                <a:cs typeface="Arial"/>
+              </a:rPr>
+              <a:t>• We verified delivery from the Notion API response—not only from an n8n success message.</a:t>
+            </a:r>
+            <a:endParaRPr sz="2000" b="0" u="none">
+              <a:solidFill>
+                <a:srgbClr val="000000"/>
+              </a:solidFill>
+              <a:latin typeface="Arial"/>
+              <a:ea typeface="Arial"/>
+              <a:cs typeface="Arial"/>
+            </a:endParaRPr>
+          </a:p>
+          <a:p xmlns:a="http://schemas.openxmlformats.org/drawingml/2006/main">
+            <a:pPr indent="0" algn="l">
+              <a:lnSpc>
+                <a:spcPct val="100000"/>
+              </a:lnSpc>
+              <a:buNone/>
+            </a:pPr>
+            <a:r>
+              <a:rPr sz="2000" b="0" u="none">
+                <a:solidFill>
+                  <a:srgbClr val="000000"/>
+                </a:solidFill>
+                <a:latin typeface="Arial"/>
+                <a:ea typeface="Arial"/>
+                <a:cs typeface="Arial"/>
+              </a:rPr>
+              <a:t/>
+            </a:r>
+            <a:endParaRPr sz="2000" b="0" u="none">
+              <a:solidFill>
+                <a:srgbClr val="000000"/>
+              </a:solidFill>
+              <a:latin typeface="Arial"/>
+              <a:ea typeface="Arial"/>
+              <a:cs typeface="Arial"/>
+            </a:endParaRPr>
+          </a:p>
+          <a:p xmlns:a="http://schemas.openxmlformats.org/drawingml/2006/main">
+            <a:pPr indent="0" algn="l">
+              <a:lnSpc>
+                <a:spcPct val="100000"/>
+              </a:lnSpc>
+              <a:buNone/>
+            </a:pPr>
+            <a:r>
+              <a:rPr sz="2000" b="0" u="none">
+                <a:solidFill>
+                  <a:srgbClr val="000000"/>
+                </a:solidFill>
+                <a:latin typeface="Arial"/>
+                <a:ea typeface="Arial"/>
+                <a:cs typeface="Arial"/>
+              </a:rPr>
+              <a:t>• The same architecture points to a recurring product, not just a one-off scan.</a:t>
+            </a:r>
+            <a:endParaRPr sz="2000" b="0" u="none">
+              <a:solidFill>
+                <a:srgbClr val="000000"/>
+              </a:solidFill>
+              <a:latin typeface="Arial"/>
+              <a:ea typeface="Arial"/>
+              <a:cs typeface="Arial"/>
+            </a:endParaRPr>
+          </a:p>
+          <a:p xmlns:a="http://schemas.openxmlformats.org/drawingml/2006/main">
+            <a:pPr indent="0" algn="l">
+              <a:lnSpc>
+                <a:spcPct val="100000"/>
+              </a:lnSpc>
+              <a:buNone/>
+            </a:pPr>
+            <a:r>
+              <a:rPr sz="2000" b="0" u="none">
+                <a:solidFill>
+                  <a:srgbClr val="000000"/>
+                </a:solidFill>
+                <a:latin typeface="Arial"/>
+                <a:ea typeface="Arial"/>
+                <a:cs typeface="Arial"/>
+              </a:rPr>
+              <a:t/>
+            </a:r>
+            <a:endParaRPr sz="2000" b="0" u="none">
+              <a:solidFill>
+                <a:srgbClr val="000000"/>
+              </a:solidFill>
+              <a:latin typeface="Arial"/>
+              <a:ea typeface="Arial"/>
+              <a:cs typeface="Arial"/>
+            </a:endParaRPr>
+          </a:p>
+          <a:p xmlns:a="http://schemas.openxmlformats.org/drawingml/2006/main">
+            <a:pPr indent="0" algn="l">
+              <a:lnSpc>
+                <a:spcPct val="100000"/>
+              </a:lnSpc>
+              <a:buNone/>
+            </a:pPr>
+            <a:r>
+              <a:rPr sz="2000" b="0" u="none">
+                <a:solidFill>
+                  <a:srgbClr val="000000"/>
+                </a:solidFill>
+                <a:latin typeface="Arial"/>
+                <a:ea typeface="Arial"/>
+                <a:cs typeface="Arial"/>
+              </a:rPr>
+              <a:t>[Sources]</a:t>
+            </a:r>
+            <a:endParaRPr sz="2000" b="0" u="none">
+              <a:solidFill>
+                <a:srgbClr val="000000"/>
+              </a:solidFill>
+              <a:latin typeface="Arial"/>
+              <a:ea typeface="Arial"/>
+              <a:cs typeface="Arial"/>
+            </a:endParaRPr>
+          </a:p>
+          <a:p xmlns:a="http://schemas.openxmlformats.org/drawingml/2006/main">
+            <a:pPr indent="0" algn="l">
+              <a:lnSpc>
+                <a:spcPct val="100000"/>
+              </a:lnSpc>
+              <a:buNone/>
+            </a:pPr>
+            <a:r>
+              <a:rPr sz="2000" b="0" u="none">
+                <a:solidFill>
+                  <a:srgbClr val="000000"/>
+                </a:solidFill>
+                <a:latin typeface="Arial"/>
+                <a:ea typeface="Arial"/>
+                <a:cs typeface="Arial"/>
+              </a:rPr>
+              <a:t>- stack_decision.md</a:t>
+            </a:r>
+            <a:endParaRPr sz="2000" b="0" u="none">
+              <a:solidFill>
+                <a:srgbClr val="000000"/>
+              </a:solidFill>
+              <a:latin typeface="Arial"/>
+              <a:ea typeface="Arial"/>
+              <a:cs typeface="Arial"/>
+            </a:endParaRPr>
+          </a:p>
+          <a:p xmlns:a="http://schemas.openxmlformats.org/drawingml/2006/main">
+            <a:pPr indent="0" algn="l">
+              <a:lnSpc>
+                <a:spcPct val="100000"/>
+              </a:lnSpc>
+              <a:buNone/>
+            </a:pPr>
+            <a:r>
+              <a:rPr sz="2000" b="0" u="none">
+                <a:solidFill>
+                  <a:srgbClr val="000000"/>
+                </a:solidFill>
+                <a:latin typeface="Arial"/>
+                <a:ea typeface="Arial"/>
+                <a:cs typeface="Arial"/>
+              </a:rPr>
               <a:t>- docs/architecture.md</a:t>
             </a:r>
             <a:endParaRPr sz="2000" b="0" u="none">
@@ -2632,6 +5005,9 @@
           </a:p>
           <a:p xmlns:a="http://schemas.openxmlformats.org/drawingml/2006/main">
             <a:pPr indent="0" algn="l">
+              <a:lnSpc>
+                <a:spcPct val="100000"/>
+              </a:lnSpc>
               <a:buNone/>
             </a:pPr>
             <a:r>
@@ -2759,7 +5135,7 @@
                 <a:ea typeface="Arial"/>
                 <a:cs typeface="Arial"/>
               </a:rPr>
-              <a:t>The MVP today is an on-demand scan of one company. The sharper post-MVP opportunity is vendor-drift monitoring. Imagine that, in May, a client's recruitment system has no evidenced AI-ranking feature. In June, the vendor adds AI CV ranking. By July, the adviser receives an alert: the client's system landscape changed even though the client bought nothing and started no internal project. That change signal can recur across an adviser portfolio. The commercial hypothesis is therefore simple: begin with an adviser pilot, prove that the drift alerts are accurate and useful, then test retained monitoring. That is future validation, not current traction. What is built today is the starting point: AI Pre-Scan turns AI discovery from a blank-page investigation into an auditable, focused conversation.</a:t>
+              <a:t>• The MVP today is an on-demand scan of one company.</a:t>
             </a:r>
             <a:endParaRPr sz="2000" b="0" u="none">
               <a:solidFill>
@@ -2799,7 +5175,7 @@
                 <a:ea typeface="Arial"/>
                 <a:cs typeface="Arial"/>
               </a:rPr>
-              <a:t>[End the timed presentation here. Open the appendix only for questions.]</a:t>
+              <a:t>• The post-MVP opportunity is vendor-drift monitoring.</a:t>
             </a:r>
             <a:endParaRPr sz="2000" b="0" u="none">
               <a:solidFill>
@@ -2839,7 +5215,7 @@
                 <a:ea typeface="Arial"/>
                 <a:cs typeface="Arial"/>
               </a:rPr>
-              <a:t>[Sources]</a:t>
+              <a:t>• In May, the client already uses an ATS, but no AI-ranking feature is evidenced.</a:t>
             </a:r>
             <a:endParaRPr sz="2000" b="0" u="none">
               <a:solidFill>
@@ -2863,6 +5239,489 @@
                 <a:ea typeface="Arial"/>
                 <a:cs typeface="Arial"/>
               </a:rPr>
+              <a:t/>
+            </a:r>
+            <a:endParaRPr sz="2000" b="0" u="none">
+              <a:solidFill>
+                <a:srgbClr val="000000"/>
+              </a:solidFill>
+              <a:latin typeface="Arial"/>
+              <a:ea typeface="Arial"/>
+              <a:cs typeface="Arial"/>
+            </a:endParaRPr>
+          </a:p>
+          <a:p xmlns:a="http://schemas.openxmlformats.org/drawingml/2006/main">
+            <a:pPr indent="0" algn="l">
+              <a:buNone/>
+            </a:pPr>
+            <a:r>
+              <a:rPr sz="2000" b="0" u="none">
+                <a:solidFill>
+                  <a:srgbClr val="000000"/>
+                </a:solidFill>
+                <a:latin typeface="Arial"/>
+                <a:ea typeface="Arial"/>
+                <a:cs typeface="Arial"/>
+              </a:rPr>
+              <a:t>• In June, the vendor adds AI CV ranking; the client buys nothing new.</a:t>
+            </a:r>
+            <a:endParaRPr sz="2000" b="0" u="none">
+              <a:solidFill>
+                <a:srgbClr val="000000"/>
+              </a:solidFill>
+              <a:latin typeface="Arial"/>
+              <a:ea typeface="Arial"/>
+              <a:cs typeface="Arial"/>
+            </a:endParaRPr>
+          </a:p>
+          <a:p xmlns:a="http://schemas.openxmlformats.org/drawingml/2006/main">
+            <a:pPr indent="0" algn="l">
+              <a:lnSpc>
+                <a:spcPct val="100000"/>
+              </a:lnSpc>
+              <a:buNone/>
+            </a:pPr>
+            <a:r>
+              <a:rPr sz="2000" b="0" u="none">
+                <a:solidFill>
+                  <a:srgbClr val="000000"/>
+                </a:solidFill>
+                <a:latin typeface="Arial"/>
+                <a:ea typeface="Arial"/>
+                <a:cs typeface="Arial"/>
+              </a:rPr>
+              <a:t/>
+            </a:r>
+            <a:endParaRPr sz="2000" b="0" u="none">
+              <a:solidFill>
+                <a:srgbClr val="000000"/>
+              </a:solidFill>
+              <a:latin typeface="Arial"/>
+              <a:ea typeface="Arial"/>
+              <a:cs typeface="Arial"/>
+            </a:endParaRPr>
+          </a:p>
+          <a:p xmlns:a="http://schemas.openxmlformats.org/drawingml/2006/main">
+            <a:pPr indent="0" algn="l">
+              <a:lnSpc>
+                <a:spcPct val="100000"/>
+              </a:lnSpc>
+              <a:buNone/>
+            </a:pPr>
+            <a:r>
+              <a:rPr sz="2000" b="0" u="none">
+                <a:solidFill>
+                  <a:srgbClr val="000000"/>
+                </a:solidFill>
+                <a:latin typeface="Arial"/>
+                <a:ea typeface="Arial"/>
+                <a:cs typeface="Arial"/>
+              </a:rPr>
+              <a:t>• In July, the adviser receives an alert: the client's AI inventory changed.</a:t>
+            </a:r>
+            <a:endParaRPr sz="2000" b="0" u="none">
+              <a:solidFill>
+                <a:srgbClr val="000000"/>
+              </a:solidFill>
+              <a:latin typeface="Arial"/>
+              <a:ea typeface="Arial"/>
+              <a:cs typeface="Arial"/>
+            </a:endParaRPr>
+          </a:p>
+          <a:p xmlns:a="http://schemas.openxmlformats.org/drawingml/2006/main">
+            <a:pPr indent="0" algn="l">
+              <a:lnSpc>
+                <a:spcPct val="100000"/>
+              </a:lnSpc>
+              <a:buNone/>
+            </a:pPr>
+            <a:r>
+              <a:rPr sz="2000" b="0" u="none">
+                <a:solidFill>
+                  <a:srgbClr val="000000"/>
+                </a:solidFill>
+                <a:latin typeface="Arial"/>
+                <a:ea typeface="Arial"/>
+                <a:cs typeface="Arial"/>
+              </a:rPr>
+              <a:t/>
+            </a:r>
+            <a:endParaRPr sz="2000" b="0" u="none">
+              <a:solidFill>
+                <a:srgbClr val="000000"/>
+              </a:solidFill>
+              <a:latin typeface="Arial"/>
+              <a:ea typeface="Arial"/>
+              <a:cs typeface="Arial"/>
+            </a:endParaRPr>
+          </a:p>
+          <a:p xmlns:a="http://schemas.openxmlformats.org/drawingml/2006/main">
+            <a:pPr indent="0" algn="l">
+              <a:lnSpc>
+                <a:spcPct val="100000"/>
+              </a:lnSpc>
+              <a:buNone/>
+            </a:pPr>
+            <a:r>
+              <a:rPr sz="2000" b="0" u="none">
+                <a:solidFill>
+                  <a:srgbClr val="000000"/>
+                </a:solidFill>
+                <a:latin typeface="Arial"/>
+                <a:ea typeface="Arial"/>
+                <a:cs typeface="Arial"/>
+              </a:rPr>
+              <a:t>• That change signal can recur across an adviser portfolio.</a:t>
+            </a:r>
+            <a:endParaRPr sz="2000" b="0" u="none">
+              <a:solidFill>
+                <a:srgbClr val="000000"/>
+              </a:solidFill>
+              <a:latin typeface="Arial"/>
+              <a:ea typeface="Arial"/>
+              <a:cs typeface="Arial"/>
+            </a:endParaRPr>
+          </a:p>
+          <a:p xmlns:a="http://schemas.openxmlformats.org/drawingml/2006/main">
+            <a:pPr indent="0" algn="l">
+              <a:lnSpc>
+                <a:spcPct val="100000"/>
+              </a:lnSpc>
+              <a:buNone/>
+            </a:pPr>
+            <a:r>
+              <a:rPr sz="2000" b="0" u="none">
+                <a:solidFill>
+                  <a:srgbClr val="000000"/>
+                </a:solidFill>
+                <a:latin typeface="Arial"/>
+                <a:ea typeface="Arial"/>
+                <a:cs typeface="Arial"/>
+              </a:rPr>
+              <a:t/>
+            </a:r>
+            <a:endParaRPr sz="2000" b="0" u="none">
+              <a:solidFill>
+                <a:srgbClr val="000000"/>
+              </a:solidFill>
+              <a:latin typeface="Arial"/>
+              <a:ea typeface="Arial"/>
+              <a:cs typeface="Arial"/>
+            </a:endParaRPr>
+          </a:p>
+          <a:p xmlns:a="http://schemas.openxmlformats.org/drawingml/2006/main">
+            <a:pPr indent="0" algn="l">
+              <a:lnSpc>
+                <a:spcPct val="100000"/>
+              </a:lnSpc>
+              <a:buNone/>
+            </a:pPr>
+            <a:r>
+              <a:rPr sz="2000" b="0" u="none">
+                <a:solidFill>
+                  <a:srgbClr val="000000"/>
+                </a:solidFill>
+                <a:latin typeface="Arial"/>
+                <a:ea typeface="Arial"/>
+                <a:cs typeface="Arial"/>
+              </a:rPr>
+              <a:t>• The commercial test is: adviser pilot, validate useful drift alerts, then test retained monitoring.</a:t>
+            </a:r>
+            <a:endParaRPr sz="2000" b="0" u="none">
+              <a:solidFill>
+                <a:srgbClr val="000000"/>
+              </a:solidFill>
+              <a:latin typeface="Arial"/>
+              <a:ea typeface="Arial"/>
+              <a:cs typeface="Arial"/>
+            </a:endParaRPr>
+          </a:p>
+          <a:p xmlns:a="http://schemas.openxmlformats.org/drawingml/2006/main">
+            <a:pPr indent="0" algn="l">
+              <a:lnSpc>
+                <a:spcPct val="100000"/>
+              </a:lnSpc>
+              <a:buNone/>
+            </a:pPr>
+            <a:r>
+              <a:rPr sz="2000" b="0" u="none">
+                <a:solidFill>
+                  <a:srgbClr val="000000"/>
+                </a:solidFill>
+                <a:latin typeface="Arial"/>
+                <a:ea typeface="Arial"/>
+                <a:cs typeface="Arial"/>
+              </a:rPr>
+              <a:t/>
+            </a:r>
+            <a:endParaRPr sz="2000" b="0" u="none">
+              <a:solidFill>
+                <a:srgbClr val="000000"/>
+              </a:solidFill>
+              <a:latin typeface="Arial"/>
+              <a:ea typeface="Arial"/>
+              <a:cs typeface="Arial"/>
+            </a:endParaRPr>
+          </a:p>
+          <a:p xmlns:a="http://schemas.openxmlformats.org/drawingml/2006/main">
+            <a:pPr indent="0" algn="l">
+              <a:lnSpc>
+                <a:spcPct val="100000"/>
+              </a:lnSpc>
+              <a:buNone/>
+            </a:pPr>
+            <a:r>
+              <a:rPr sz="2000" b="0" u="none">
+                <a:solidFill>
+                  <a:srgbClr val="000000"/>
+                </a:solidFill>
+                <a:latin typeface="Arial"/>
+                <a:ea typeface="Arial"/>
+                <a:cs typeface="Arial"/>
+              </a:rPr>
+              <a:t>• This is future validation—not current traction.</a:t>
+            </a:r>
+            <a:endParaRPr sz="2000" b="0" u="none">
+              <a:solidFill>
+                <a:srgbClr val="000000"/>
+              </a:solidFill>
+              <a:latin typeface="Arial"/>
+              <a:ea typeface="Arial"/>
+              <a:cs typeface="Arial"/>
+            </a:endParaRPr>
+          </a:p>
+          <a:p xmlns:a="http://schemas.openxmlformats.org/drawingml/2006/main">
+            <a:pPr indent="0" algn="l">
+              <a:lnSpc>
+                <a:spcPct val="100000"/>
+              </a:lnSpc>
+              <a:buNone/>
+            </a:pPr>
+            <a:r>
+              <a:rPr sz="2000" b="0" u="none">
+                <a:solidFill>
+                  <a:srgbClr val="000000"/>
+                </a:solidFill>
+                <a:latin typeface="Arial"/>
+                <a:ea typeface="Arial"/>
+                <a:cs typeface="Arial"/>
+              </a:rPr>
+              <a:t/>
+            </a:r>
+            <a:endParaRPr sz="2000" b="0" u="none">
+              <a:solidFill>
+                <a:srgbClr val="000000"/>
+              </a:solidFill>
+              <a:latin typeface="Arial"/>
+              <a:ea typeface="Arial"/>
+              <a:cs typeface="Arial"/>
+            </a:endParaRPr>
+          </a:p>
+          <a:p xmlns:a="http://schemas.openxmlformats.org/drawingml/2006/main">
+            <a:pPr indent="0" algn="l">
+              <a:lnSpc>
+                <a:spcPct val="100000"/>
+              </a:lnSpc>
+              <a:buNone/>
+            </a:pPr>
+            <a:r>
+              <a:rPr sz="2000" b="0" u="none">
+                <a:solidFill>
+                  <a:srgbClr val="000000"/>
+                </a:solidFill>
+                <a:latin typeface="Arial"/>
+                <a:ea typeface="Arial"/>
+                <a:cs typeface="Arial"/>
+              </a:rPr>
+              <a:t>• [Pause.]</a:t>
+            </a:r>
+            <a:endParaRPr sz="2000" b="0" u="none">
+              <a:solidFill>
+                <a:srgbClr val="000000"/>
+              </a:solidFill>
+              <a:latin typeface="Arial"/>
+              <a:ea typeface="Arial"/>
+              <a:cs typeface="Arial"/>
+            </a:endParaRPr>
+          </a:p>
+          <a:p xmlns:a="http://schemas.openxmlformats.org/drawingml/2006/main">
+            <a:pPr indent="0" algn="l">
+              <a:lnSpc>
+                <a:spcPct val="100000"/>
+              </a:lnSpc>
+              <a:buNone/>
+            </a:pPr>
+            <a:r>
+              <a:rPr sz="2000" b="0" u="none">
+                <a:solidFill>
+                  <a:srgbClr val="000000"/>
+                </a:solidFill>
+                <a:latin typeface="Arial"/>
+                <a:ea typeface="Arial"/>
+                <a:cs typeface="Arial"/>
+              </a:rPr>
+              <a:t/>
+            </a:r>
+            <a:endParaRPr sz="2000" b="0" u="none">
+              <a:solidFill>
+                <a:srgbClr val="000000"/>
+              </a:solidFill>
+              <a:latin typeface="Arial"/>
+              <a:ea typeface="Arial"/>
+              <a:cs typeface="Arial"/>
+            </a:endParaRPr>
+          </a:p>
+          <a:p xmlns:a="http://schemas.openxmlformats.org/drawingml/2006/main">
+            <a:pPr indent="0" algn="l">
+              <a:lnSpc>
+                <a:spcPct val="100000"/>
+              </a:lnSpc>
+              <a:buNone/>
+            </a:pPr>
+            <a:r>
+              <a:rPr sz="2000" b="0" u="none">
+                <a:solidFill>
+                  <a:srgbClr val="000000"/>
+                </a:solidFill>
+                <a:latin typeface="Arial"/>
+                <a:ea typeface="Arial"/>
+                <a:cs typeface="Arial"/>
+              </a:rPr>
+              <a:t>• AI Pre-Scan can turn a blank-page scan into an auditable, recurring conversation.</a:t>
+            </a:r>
+            <a:endParaRPr sz="2000" b="0" u="none">
+              <a:solidFill>
+                <a:srgbClr val="000000"/>
+              </a:solidFill>
+              <a:latin typeface="Arial"/>
+              <a:ea typeface="Arial"/>
+              <a:cs typeface="Arial"/>
+            </a:endParaRPr>
+          </a:p>
+          <a:p xmlns:a="http://schemas.openxmlformats.org/drawingml/2006/main">
+            <a:pPr indent="0" algn="l">
+              <a:lnSpc>
+                <a:spcPct val="100000"/>
+              </a:lnSpc>
+              <a:buNone/>
+            </a:pPr>
+            <a:r>
+              <a:rPr sz="2000" b="0" u="none">
+                <a:solidFill>
+                  <a:srgbClr val="000000"/>
+                </a:solidFill>
+                <a:latin typeface="Arial"/>
+                <a:ea typeface="Arial"/>
+                <a:cs typeface="Arial"/>
+              </a:rPr>
+              <a:t/>
+            </a:r>
+            <a:endParaRPr sz="2000" b="0" u="none">
+              <a:solidFill>
+                <a:srgbClr val="000000"/>
+              </a:solidFill>
+              <a:latin typeface="Arial"/>
+              <a:ea typeface="Arial"/>
+              <a:cs typeface="Arial"/>
+            </a:endParaRPr>
+          </a:p>
+          <a:p xmlns:a="http://schemas.openxmlformats.org/drawingml/2006/main">
+            <a:pPr indent="0" algn="l">
+              <a:lnSpc>
+                <a:spcPct val="100000"/>
+              </a:lnSpc>
+              <a:buNone/>
+            </a:pPr>
+            <a:r>
+              <a:rPr sz="2000" b="0" u="none">
+                <a:solidFill>
+                  <a:srgbClr val="000000"/>
+                </a:solidFill>
+                <a:latin typeface="Arial"/>
+                <a:ea typeface="Arial"/>
+                <a:cs typeface="Arial"/>
+              </a:rPr>
+              <a:t>• [End the timed presentation here. Open the appendix only for questions.]</a:t>
+            </a:r>
+            <a:endParaRPr sz="2000" b="0" u="none">
+              <a:solidFill>
+                <a:srgbClr val="000000"/>
+              </a:solidFill>
+              <a:latin typeface="Arial"/>
+              <a:ea typeface="Arial"/>
+              <a:cs typeface="Arial"/>
+            </a:endParaRPr>
+          </a:p>
+          <a:p xmlns:a="http://schemas.openxmlformats.org/drawingml/2006/main">
+            <a:pPr indent="0" algn="l">
+              <a:lnSpc>
+                <a:spcPct val="100000"/>
+              </a:lnSpc>
+              <a:buNone/>
+            </a:pPr>
+            <a:r>
+              <a:rPr sz="2000" b="0" u="none">
+                <a:solidFill>
+                  <a:srgbClr val="000000"/>
+                </a:solidFill>
+                <a:latin typeface="Arial"/>
+                <a:ea typeface="Arial"/>
+                <a:cs typeface="Arial"/>
+              </a:rPr>
+              <a:t/>
+            </a:r>
+            <a:endParaRPr sz="2000" b="0" u="none">
+              <a:solidFill>
+                <a:srgbClr val="000000"/>
+              </a:solidFill>
+              <a:latin typeface="Arial"/>
+              <a:ea typeface="Arial"/>
+              <a:cs typeface="Arial"/>
+            </a:endParaRPr>
+          </a:p>
+          <a:p xmlns:a="http://schemas.openxmlformats.org/drawingml/2006/main">
+            <a:pPr indent="0" algn="l">
+              <a:lnSpc>
+                <a:spcPct val="100000"/>
+              </a:lnSpc>
+              <a:buNone/>
+            </a:pPr>
+            <a:r>
+              <a:rPr sz="2000" b="0" u="none">
+                <a:solidFill>
+                  <a:srgbClr val="000000"/>
+                </a:solidFill>
+                <a:latin typeface="Arial"/>
+                <a:ea typeface="Arial"/>
+                <a:cs typeface="Arial"/>
+              </a:rPr>
+              <a:t>[Sources]</a:t>
+            </a:r>
+            <a:endParaRPr sz="2000" b="0" u="none">
+              <a:solidFill>
+                <a:srgbClr val="000000"/>
+              </a:solidFill>
+              <a:latin typeface="Arial"/>
+              <a:ea typeface="Arial"/>
+              <a:cs typeface="Arial"/>
+            </a:endParaRPr>
+          </a:p>
+          <a:p xmlns:a="http://schemas.openxmlformats.org/drawingml/2006/main">
+            <a:pPr indent="0" algn="l">
+              <a:lnSpc>
+                <a:spcPct val="100000"/>
+              </a:lnSpc>
+              <a:buNone/>
+            </a:pPr>
+            <a:r>
+              <a:rPr sz="2000" b="0" u="none">
+                <a:solidFill>
+                  <a:srgbClr val="000000"/>
+                </a:solidFill>
+                <a:latin typeface="Arial"/>
+                <a:ea typeface="Arial"/>
+                <a:cs typeface="Arial"/>
+              </a:rPr>
               <a:t>- gtm_future_sprints.md</a:t>
             </a:r>
             <a:endParaRPr sz="2000" b="0" u="none">
@@ -2876,6 +5735,9 @@
           </a:p>
           <a:p xmlns:a="http://schemas.openxmlformats.org/drawingml/2006/main">
             <a:pPr indent="0" algn="l">
+              <a:lnSpc>
+                <a:spcPct val="100000"/>
+              </a:lnSpc>
               <a:buNone/>
             </a:pPr>
             <a:r>
@@ -3003,7 +5865,7 @@
                 <a:ea typeface="Arial"/>
                 <a:cs typeface="Arial"/>
               </a:rPr>
-              <a:t>The evaluation shows a clear split. The honesty controls are stable: unsupported claims are refused, thin-company false positives are zero and provenance violations are zero. Discovery quality is not yet at target. Recall is point four four four against point seven five. Role correctness is point seven three nine against point nine. Over-claiming is point three three three against a maximum of point one. We also saw identical code produce different recall across two runs. So one run cannot prove that a configuration improved the system. The next evaluation step is repeated runs per configuration, or a frozen page cache, before making tuning claims.</a:t>
+              <a:t>• The evaluation shows a clear split.</a:t>
             </a:r>
             <a:endParaRPr sz="2000" b="0" u="none">
               <a:solidFill>
@@ -3043,7 +5905,7 @@
                 <a:ea typeface="Arial"/>
                 <a:cs typeface="Arial"/>
               </a:rPr>
-              <a:t>[Sources]</a:t>
+              <a:t>• The honesty controls are stable: honest refusal is 1.0; thin-company false positives are 0; provenance violations are 0.</a:t>
             </a:r>
             <a:endParaRPr sz="2000" b="0" u="none">
               <a:solidFill>
@@ -3067,6 +5929,435 @@
                 <a:ea typeface="Arial"/>
                 <a:cs typeface="Arial"/>
               </a:rPr>
+              <a:t/>
+            </a:r>
+            <a:endParaRPr sz="2000" b="0" u="none">
+              <a:solidFill>
+                <a:srgbClr val="000000"/>
+              </a:solidFill>
+              <a:latin typeface="Arial"/>
+              <a:ea typeface="Arial"/>
+              <a:cs typeface="Arial"/>
+            </a:endParaRPr>
+          </a:p>
+          <a:p xmlns:a="http://schemas.openxmlformats.org/drawingml/2006/main">
+            <a:pPr indent="0" algn="l">
+              <a:buNone/>
+            </a:pPr>
+            <a:r>
+              <a:rPr sz="2000" b="0" u="none">
+                <a:solidFill>
+                  <a:srgbClr val="000000"/>
+                </a:solidFill>
+                <a:latin typeface="Arial"/>
+                <a:ea typeface="Arial"/>
+                <a:cs typeface="Arial"/>
+              </a:rPr>
+              <a:t>• Discovery quality is not yet at target.</a:t>
+            </a:r>
+            <a:endParaRPr sz="2000" b="0" u="none">
+              <a:solidFill>
+                <a:srgbClr val="000000"/>
+              </a:solidFill>
+              <a:latin typeface="Arial"/>
+              <a:ea typeface="Arial"/>
+              <a:cs typeface="Arial"/>
+            </a:endParaRPr>
+          </a:p>
+          <a:p xmlns:a="http://schemas.openxmlformats.org/drawingml/2006/main">
+            <a:pPr indent="0" algn="l">
+              <a:lnSpc>
+                <a:spcPct val="100000"/>
+              </a:lnSpc>
+              <a:buNone/>
+            </a:pPr>
+            <a:r>
+              <a:rPr sz="2000" b="0" u="none">
+                <a:solidFill>
+                  <a:srgbClr val="000000"/>
+                </a:solidFill>
+                <a:latin typeface="Arial"/>
+                <a:ea typeface="Arial"/>
+                <a:cs typeface="Arial"/>
+              </a:rPr>
+              <a:t/>
+            </a:r>
+            <a:endParaRPr sz="2000" b="0" u="none">
+              <a:solidFill>
+                <a:srgbClr val="000000"/>
+              </a:solidFill>
+              <a:latin typeface="Arial"/>
+              <a:ea typeface="Arial"/>
+              <a:cs typeface="Arial"/>
+            </a:endParaRPr>
+          </a:p>
+          <a:p xmlns:a="http://schemas.openxmlformats.org/drawingml/2006/main">
+            <a:pPr indent="0" algn="l">
+              <a:lnSpc>
+                <a:spcPct val="100000"/>
+              </a:lnSpc>
+              <a:buNone/>
+            </a:pPr>
+            <a:r>
+              <a:rPr sz="2000" b="0" u="none">
+                <a:solidFill>
+                  <a:srgbClr val="000000"/>
+                </a:solidFill>
+                <a:latin typeface="Arial"/>
+                <a:ea typeface="Arial"/>
+                <a:cs typeface="Arial"/>
+              </a:rPr>
+              <a:t>• Recall—how many expected systems were found—is 0.444 against a 0.75 target.</a:t>
+            </a:r>
+            <a:endParaRPr sz="2000" b="0" u="none">
+              <a:solidFill>
+                <a:srgbClr val="000000"/>
+              </a:solidFill>
+              <a:latin typeface="Arial"/>
+              <a:ea typeface="Arial"/>
+              <a:cs typeface="Arial"/>
+            </a:endParaRPr>
+          </a:p>
+          <a:p xmlns:a="http://schemas.openxmlformats.org/drawingml/2006/main">
+            <a:pPr indent="0" algn="l">
+              <a:lnSpc>
+                <a:spcPct val="100000"/>
+              </a:lnSpc>
+              <a:buNone/>
+            </a:pPr>
+            <a:r>
+              <a:rPr sz="2000" b="0" u="none">
+                <a:solidFill>
+                  <a:srgbClr val="000000"/>
+                </a:solidFill>
+                <a:latin typeface="Arial"/>
+                <a:ea typeface="Arial"/>
+                <a:cs typeface="Arial"/>
+              </a:rPr>
+              <a:t/>
+            </a:r>
+            <a:endParaRPr sz="2000" b="0" u="none">
+              <a:solidFill>
+                <a:srgbClr val="000000"/>
+              </a:solidFill>
+              <a:latin typeface="Arial"/>
+              <a:ea typeface="Arial"/>
+              <a:cs typeface="Arial"/>
+            </a:endParaRPr>
+          </a:p>
+          <a:p xmlns:a="http://schemas.openxmlformats.org/drawingml/2006/main">
+            <a:pPr indent="0" algn="l">
+              <a:lnSpc>
+                <a:spcPct val="100000"/>
+              </a:lnSpc>
+              <a:buNone/>
+            </a:pPr>
+            <a:r>
+              <a:rPr sz="2000" b="0" u="none">
+                <a:solidFill>
+                  <a:srgbClr val="000000"/>
+                </a:solidFill>
+                <a:latin typeface="Arial"/>
+                <a:ea typeface="Arial"/>
+                <a:cs typeface="Arial"/>
+              </a:rPr>
+              <a:t>• Role correctness—whether company roles were labelled correctly—is 0.739 against 0.90.</a:t>
+            </a:r>
+            <a:endParaRPr sz="2000" b="0" u="none">
+              <a:solidFill>
+                <a:srgbClr val="000000"/>
+              </a:solidFill>
+              <a:latin typeface="Arial"/>
+              <a:ea typeface="Arial"/>
+              <a:cs typeface="Arial"/>
+            </a:endParaRPr>
+          </a:p>
+          <a:p xmlns:a="http://schemas.openxmlformats.org/drawingml/2006/main">
+            <a:pPr indent="0" algn="l">
+              <a:lnSpc>
+                <a:spcPct val="100000"/>
+              </a:lnSpc>
+              <a:buNone/>
+            </a:pPr>
+            <a:r>
+              <a:rPr sz="2000" b="0" u="none">
+                <a:solidFill>
+                  <a:srgbClr val="000000"/>
+                </a:solidFill>
+                <a:latin typeface="Arial"/>
+                <a:ea typeface="Arial"/>
+                <a:cs typeface="Arial"/>
+              </a:rPr>
+              <a:t/>
+            </a:r>
+            <a:endParaRPr sz="2000" b="0" u="none">
+              <a:solidFill>
+                <a:srgbClr val="000000"/>
+              </a:solidFill>
+              <a:latin typeface="Arial"/>
+              <a:ea typeface="Arial"/>
+              <a:cs typeface="Arial"/>
+            </a:endParaRPr>
+          </a:p>
+          <a:p xmlns:a="http://schemas.openxmlformats.org/drawingml/2006/main">
+            <a:pPr indent="0" algn="l">
+              <a:lnSpc>
+                <a:spcPct val="100000"/>
+              </a:lnSpc>
+              <a:buNone/>
+            </a:pPr>
+            <a:r>
+              <a:rPr sz="2000" b="0" u="none">
+                <a:solidFill>
+                  <a:srgbClr val="000000"/>
+                </a:solidFill>
+                <a:latin typeface="Arial"/>
+                <a:ea typeface="Arial"/>
+                <a:cs typeface="Arial"/>
+              </a:rPr>
+              <a:t>• The over-claim rate—unsupported claims of current use—is 0.333 against a maximum of 0.10.</a:t>
+            </a:r>
+            <a:endParaRPr sz="2000" b="0" u="none">
+              <a:solidFill>
+                <a:srgbClr val="000000"/>
+              </a:solidFill>
+              <a:latin typeface="Arial"/>
+              <a:ea typeface="Arial"/>
+              <a:cs typeface="Arial"/>
+            </a:endParaRPr>
+          </a:p>
+          <a:p xmlns:a="http://schemas.openxmlformats.org/drawingml/2006/main">
+            <a:pPr indent="0" algn="l">
+              <a:lnSpc>
+                <a:spcPct val="100000"/>
+              </a:lnSpc>
+              <a:buNone/>
+            </a:pPr>
+            <a:r>
+              <a:rPr sz="2000" b="0" u="none">
+                <a:solidFill>
+                  <a:srgbClr val="000000"/>
+                </a:solidFill>
+                <a:latin typeface="Arial"/>
+                <a:ea typeface="Arial"/>
+                <a:cs typeface="Arial"/>
+              </a:rPr>
+              <a:t/>
+            </a:r>
+            <a:endParaRPr sz="2000" b="0" u="none">
+              <a:solidFill>
+                <a:srgbClr val="000000"/>
+              </a:solidFill>
+              <a:latin typeface="Arial"/>
+              <a:ea typeface="Arial"/>
+              <a:cs typeface="Arial"/>
+            </a:endParaRPr>
+          </a:p>
+          <a:p xmlns:a="http://schemas.openxmlformats.org/drawingml/2006/main">
+            <a:pPr indent="0" algn="l">
+              <a:lnSpc>
+                <a:spcPct val="100000"/>
+              </a:lnSpc>
+              <a:buNone/>
+            </a:pPr>
+            <a:r>
+              <a:rPr sz="2000" b="0" u="none">
+                <a:solidFill>
+                  <a:srgbClr val="000000"/>
+                </a:solidFill>
+                <a:latin typeface="Arial"/>
+                <a:ea typeface="Arial"/>
+                <a:cs typeface="Arial"/>
+              </a:rPr>
+              <a:t>• The same code produced recall of 0.556 and 0.444 in two runs.</a:t>
+            </a:r>
+            <a:endParaRPr sz="2000" b="0" u="none">
+              <a:solidFill>
+                <a:srgbClr val="000000"/>
+              </a:solidFill>
+              <a:latin typeface="Arial"/>
+              <a:ea typeface="Arial"/>
+              <a:cs typeface="Arial"/>
+            </a:endParaRPr>
+          </a:p>
+          <a:p xmlns:a="http://schemas.openxmlformats.org/drawingml/2006/main">
+            <a:pPr indent="0" algn="l">
+              <a:lnSpc>
+                <a:spcPct val="100000"/>
+              </a:lnSpc>
+              <a:buNone/>
+            </a:pPr>
+            <a:r>
+              <a:rPr sz="2000" b="0" u="none">
+                <a:solidFill>
+                  <a:srgbClr val="000000"/>
+                </a:solidFill>
+                <a:latin typeface="Arial"/>
+                <a:ea typeface="Arial"/>
+                <a:cs typeface="Arial"/>
+              </a:rPr>
+              <a:t/>
+            </a:r>
+            <a:endParaRPr sz="2000" b="0" u="none">
+              <a:solidFill>
+                <a:srgbClr val="000000"/>
+              </a:solidFill>
+              <a:latin typeface="Arial"/>
+              <a:ea typeface="Arial"/>
+              <a:cs typeface="Arial"/>
+            </a:endParaRPr>
+          </a:p>
+          <a:p xmlns:a="http://schemas.openxmlformats.org/drawingml/2006/main">
+            <a:pPr indent="0" algn="l">
+              <a:lnSpc>
+                <a:spcPct val="100000"/>
+              </a:lnSpc>
+              <a:buNone/>
+            </a:pPr>
+            <a:r>
+              <a:rPr sz="2000" b="0" u="none">
+                <a:solidFill>
+                  <a:srgbClr val="000000"/>
+                </a:solidFill>
+                <a:latin typeface="Arial"/>
+                <a:ea typeface="Arial"/>
+                <a:cs typeface="Arial"/>
+              </a:rPr>
+              <a:t>• [Pause.]</a:t>
+            </a:r>
+            <a:endParaRPr sz="2000" b="0" u="none">
+              <a:solidFill>
+                <a:srgbClr val="000000"/>
+              </a:solidFill>
+              <a:latin typeface="Arial"/>
+              <a:ea typeface="Arial"/>
+              <a:cs typeface="Arial"/>
+            </a:endParaRPr>
+          </a:p>
+          <a:p xmlns:a="http://schemas.openxmlformats.org/drawingml/2006/main">
+            <a:pPr indent="0" algn="l">
+              <a:lnSpc>
+                <a:spcPct val="100000"/>
+              </a:lnSpc>
+              <a:buNone/>
+            </a:pPr>
+            <a:r>
+              <a:rPr sz="2000" b="0" u="none">
+                <a:solidFill>
+                  <a:srgbClr val="000000"/>
+                </a:solidFill>
+                <a:latin typeface="Arial"/>
+                <a:ea typeface="Arial"/>
+                <a:cs typeface="Arial"/>
+              </a:rPr>
+              <a:t/>
+            </a:r>
+            <a:endParaRPr sz="2000" b="0" u="none">
+              <a:solidFill>
+                <a:srgbClr val="000000"/>
+              </a:solidFill>
+              <a:latin typeface="Arial"/>
+              <a:ea typeface="Arial"/>
+              <a:cs typeface="Arial"/>
+            </a:endParaRPr>
+          </a:p>
+          <a:p xmlns:a="http://schemas.openxmlformats.org/drawingml/2006/main">
+            <a:pPr indent="0" algn="l">
+              <a:lnSpc>
+                <a:spcPct val="100000"/>
+              </a:lnSpc>
+              <a:buNone/>
+            </a:pPr>
+            <a:r>
+              <a:rPr sz="2000" b="0" u="none">
+                <a:solidFill>
+                  <a:srgbClr val="000000"/>
+                </a:solidFill>
+                <a:latin typeface="Arial"/>
+                <a:ea typeface="Arial"/>
+                <a:cs typeface="Arial"/>
+              </a:rPr>
+              <a:t>• One run cannot prove an improvement; use repeated runs or a frozen page cache before tuning claims.</a:t>
+            </a:r>
+            <a:endParaRPr sz="2000" b="0" u="none">
+              <a:solidFill>
+                <a:srgbClr val="000000"/>
+              </a:solidFill>
+              <a:latin typeface="Arial"/>
+              <a:ea typeface="Arial"/>
+              <a:cs typeface="Arial"/>
+            </a:endParaRPr>
+          </a:p>
+          <a:p xmlns:a="http://schemas.openxmlformats.org/drawingml/2006/main">
+            <a:pPr indent="0" algn="l">
+              <a:lnSpc>
+                <a:spcPct val="100000"/>
+              </a:lnSpc>
+              <a:buNone/>
+            </a:pPr>
+            <a:r>
+              <a:rPr sz="2000" b="0" u="none">
+                <a:solidFill>
+                  <a:srgbClr val="000000"/>
+                </a:solidFill>
+                <a:latin typeface="Arial"/>
+                <a:ea typeface="Arial"/>
+                <a:cs typeface="Arial"/>
+              </a:rPr>
+              <a:t/>
+            </a:r>
+            <a:endParaRPr sz="2000" b="0" u="none">
+              <a:solidFill>
+                <a:srgbClr val="000000"/>
+              </a:solidFill>
+              <a:latin typeface="Arial"/>
+              <a:ea typeface="Arial"/>
+              <a:cs typeface="Arial"/>
+            </a:endParaRPr>
+          </a:p>
+          <a:p xmlns:a="http://schemas.openxmlformats.org/drawingml/2006/main">
+            <a:pPr indent="0" algn="l">
+              <a:lnSpc>
+                <a:spcPct val="100000"/>
+              </a:lnSpc>
+              <a:buNone/>
+            </a:pPr>
+            <a:r>
+              <a:rPr sz="2000" b="0" u="none">
+                <a:solidFill>
+                  <a:srgbClr val="000000"/>
+                </a:solidFill>
+                <a:latin typeface="Arial"/>
+                <a:ea typeface="Arial"/>
+                <a:cs typeface="Arial"/>
+              </a:rPr>
+              <a:t>[Sources]</a:t>
+            </a:r>
+            <a:endParaRPr sz="2000" b="0" u="none">
+              <a:solidFill>
+                <a:srgbClr val="000000"/>
+              </a:solidFill>
+              <a:latin typeface="Arial"/>
+              <a:ea typeface="Arial"/>
+              <a:cs typeface="Arial"/>
+            </a:endParaRPr>
+          </a:p>
+          <a:p xmlns:a="http://schemas.openxmlformats.org/drawingml/2006/main">
+            <a:pPr indent="0" algn="l">
+              <a:lnSpc>
+                <a:spcPct val="100000"/>
+              </a:lnSpc>
+              <a:buNone/>
+            </a:pPr>
+            <a:r>
+              <a:rPr sz="2000" b="0" u="none">
+                <a:solidFill>
+                  <a:srgbClr val="000000"/>
+                </a:solidFill>
+                <a:latin typeface="Arial"/>
+                <a:ea typeface="Arial"/>
+                <a:cs typeface="Arial"/>
+              </a:rPr>
               <a:t>- eval/results.md</a:t>
             </a:r>
             <a:endParaRPr sz="2000" b="0" u="none">
@@ -3080,6 +6371,9 @@
           </a:p>
           <a:p xmlns:a="http://schemas.openxmlformats.org/drawingml/2006/main">
             <a:pPr indent="0" algn="l">
+              <a:lnSpc>
+                <a:spcPct val="100000"/>
+              </a:lnSpc>
               <a:buNone/>
             </a:pPr>
             <a:r>
@@ -3207,7 +6501,7 @@
                 <a:ea typeface="Arial"/>
                 <a:cs typeface="Arial"/>
               </a:rPr>
-              <a:t>The boundary is deliberate. AI Pre-Scan discovers and documents candidate facts from public sources: possible systems, exact quoted evidence, provenance and unresolved questions. It does not classify legal risk. An adviser first confirms the facts with the client; only then does a separate deterministic checker apply the law and determine obligations. There is no path around that human checkpoint. Internal tools, systems behind a login and employee use of consumer AI remain outside an external scan's field of view. So the product never claims complete visibility, legal advice or an autonomous compliance decision.</a:t>
+              <a:t>• The boundary is deliberate.</a:t>
             </a:r>
             <a:endParaRPr sz="2000" b="0" u="none">
               <a:solidFill>
@@ -3247,7 +6541,7 @@
                 <a:ea typeface="Arial"/>
                 <a:cs typeface="Arial"/>
               </a:rPr>
-              <a:t>[Sources]</a:t>
+              <a:t>• AI Pre-Scan establishes candidate facts from public sources: systems, quoted evidence, provenance and unresolved questions.</a:t>
             </a:r>
             <a:endParaRPr sz="2000" b="0" u="none">
               <a:solidFill>
@@ -3271,7 +6565,7 @@
                 <a:ea typeface="Arial"/>
                 <a:cs typeface="Arial"/>
               </a:rPr>
-              <a:t>- README.md</a:t>
+              <a:t/>
             </a:r>
             <a:endParaRPr sz="2000" b="0" u="none">
               <a:solidFill>
@@ -3295,6 +6589,381 @@
                 <a:ea typeface="Arial"/>
                 <a:cs typeface="Arial"/>
               </a:rPr>
+              <a:t>• It does not classify legal risk.</a:t>
+            </a:r>
+            <a:endParaRPr sz="2000" b="0" u="none">
+              <a:solidFill>
+                <a:srgbClr val="000000"/>
+              </a:solidFill>
+              <a:latin typeface="Arial"/>
+              <a:ea typeface="Arial"/>
+              <a:cs typeface="Arial"/>
+            </a:endParaRPr>
+          </a:p>
+          <a:p xmlns:a="http://schemas.openxmlformats.org/drawingml/2006/main">
+            <a:pPr indent="0" algn="l">
+              <a:buNone/>
+            </a:pPr>
+            <a:r>
+              <a:rPr sz="2000" b="0" u="none">
+                <a:solidFill>
+                  <a:srgbClr val="000000"/>
+                </a:solidFill>
+                <a:latin typeface="Arial"/>
+                <a:ea typeface="Arial"/>
+                <a:cs typeface="Arial"/>
+              </a:rPr>
+              <a:t/>
+            </a:r>
+            <a:endParaRPr sz="2000" b="0" u="none">
+              <a:solidFill>
+                <a:srgbClr val="000000"/>
+              </a:solidFill>
+              <a:latin typeface="Arial"/>
+              <a:ea typeface="Arial"/>
+              <a:cs typeface="Arial"/>
+            </a:endParaRPr>
+          </a:p>
+          <a:p xmlns:a="http://schemas.openxmlformats.org/drawingml/2006/main">
+            <a:pPr indent="0" algn="l">
+              <a:lnSpc>
+                <a:spcPct val="100000"/>
+              </a:lnSpc>
+              <a:buNone/>
+            </a:pPr>
+            <a:r>
+              <a:rPr sz="2000" b="0" u="none">
+                <a:solidFill>
+                  <a:srgbClr val="000000"/>
+                </a:solidFill>
+                <a:latin typeface="Arial"/>
+                <a:ea typeface="Arial"/>
+                <a:cs typeface="Arial"/>
+              </a:rPr>
+              <a:t>• An adviser confirms the facts with the client at the human-review checkpoint.</a:t>
+            </a:r>
+            <a:endParaRPr sz="2000" b="0" u="none">
+              <a:solidFill>
+                <a:srgbClr val="000000"/>
+              </a:solidFill>
+              <a:latin typeface="Arial"/>
+              <a:ea typeface="Arial"/>
+              <a:cs typeface="Arial"/>
+            </a:endParaRPr>
+          </a:p>
+          <a:p xmlns:a="http://schemas.openxmlformats.org/drawingml/2006/main">
+            <a:pPr indent="0" algn="l">
+              <a:lnSpc>
+                <a:spcPct val="100000"/>
+              </a:lnSpc>
+              <a:buNone/>
+            </a:pPr>
+            <a:r>
+              <a:rPr sz="2000" b="0" u="none">
+                <a:solidFill>
+                  <a:srgbClr val="000000"/>
+                </a:solidFill>
+                <a:latin typeface="Arial"/>
+                <a:ea typeface="Arial"/>
+                <a:cs typeface="Arial"/>
+              </a:rPr>
+              <a:t/>
+            </a:r>
+            <a:endParaRPr sz="2000" b="0" u="none">
+              <a:solidFill>
+                <a:srgbClr val="000000"/>
+              </a:solidFill>
+              <a:latin typeface="Arial"/>
+              <a:ea typeface="Arial"/>
+              <a:cs typeface="Arial"/>
+            </a:endParaRPr>
+          </a:p>
+          <a:p xmlns:a="http://schemas.openxmlformats.org/drawingml/2006/main">
+            <a:pPr indent="0" algn="l">
+              <a:lnSpc>
+                <a:spcPct val="100000"/>
+              </a:lnSpc>
+              <a:buNone/>
+            </a:pPr>
+            <a:r>
+              <a:rPr sz="2000" b="0" u="none">
+                <a:solidFill>
+                  <a:srgbClr val="000000"/>
+                </a:solidFill>
+                <a:latin typeface="Arial"/>
+                <a:ea typeface="Arial"/>
+                <a:cs typeface="Arial"/>
+              </a:rPr>
+              <a:t>• Only then does a separate deterministic checker classify risk and determine obligations.</a:t>
+            </a:r>
+            <a:endParaRPr sz="2000" b="0" u="none">
+              <a:solidFill>
+                <a:srgbClr val="000000"/>
+              </a:solidFill>
+              <a:latin typeface="Arial"/>
+              <a:ea typeface="Arial"/>
+              <a:cs typeface="Arial"/>
+            </a:endParaRPr>
+          </a:p>
+          <a:p xmlns:a="http://schemas.openxmlformats.org/drawingml/2006/main">
+            <a:pPr indent="0" algn="l">
+              <a:lnSpc>
+                <a:spcPct val="100000"/>
+              </a:lnSpc>
+              <a:buNone/>
+            </a:pPr>
+            <a:r>
+              <a:rPr sz="2000" b="0" u="none">
+                <a:solidFill>
+                  <a:srgbClr val="000000"/>
+                </a:solidFill>
+                <a:latin typeface="Arial"/>
+                <a:ea typeface="Arial"/>
+                <a:cs typeface="Arial"/>
+              </a:rPr>
+              <a:t/>
+            </a:r>
+            <a:endParaRPr sz="2000" b="0" u="none">
+              <a:solidFill>
+                <a:srgbClr val="000000"/>
+              </a:solidFill>
+              <a:latin typeface="Arial"/>
+              <a:ea typeface="Arial"/>
+              <a:cs typeface="Arial"/>
+            </a:endParaRPr>
+          </a:p>
+          <a:p xmlns:a="http://schemas.openxmlformats.org/drawingml/2006/main">
+            <a:pPr indent="0" algn="l">
+              <a:lnSpc>
+                <a:spcPct val="100000"/>
+              </a:lnSpc>
+              <a:buNone/>
+            </a:pPr>
+            <a:r>
+              <a:rPr sz="2000" b="0" u="none">
+                <a:solidFill>
+                  <a:srgbClr val="000000"/>
+                </a:solidFill>
+                <a:latin typeface="Arial"/>
+                <a:ea typeface="Arial"/>
+                <a:cs typeface="Arial"/>
+              </a:rPr>
+              <a:t>• Internal tools, systems behind a login and employee use of consumer AI remain outside the external scan's field of view.</a:t>
+            </a:r>
+            <a:endParaRPr sz="2000" b="0" u="none">
+              <a:solidFill>
+                <a:srgbClr val="000000"/>
+              </a:solidFill>
+              <a:latin typeface="Arial"/>
+              <a:ea typeface="Arial"/>
+              <a:cs typeface="Arial"/>
+            </a:endParaRPr>
+          </a:p>
+          <a:p xmlns:a="http://schemas.openxmlformats.org/drawingml/2006/main">
+            <a:pPr indent="0" algn="l">
+              <a:lnSpc>
+                <a:spcPct val="100000"/>
+              </a:lnSpc>
+              <a:buNone/>
+            </a:pPr>
+            <a:r>
+              <a:rPr sz="2000" b="0" u="none">
+                <a:solidFill>
+                  <a:srgbClr val="000000"/>
+                </a:solidFill>
+                <a:latin typeface="Arial"/>
+                <a:ea typeface="Arial"/>
+                <a:cs typeface="Arial"/>
+              </a:rPr>
+              <a:t/>
+            </a:r>
+            <a:endParaRPr sz="2000" b="0" u="none">
+              <a:solidFill>
+                <a:srgbClr val="000000"/>
+              </a:solidFill>
+              <a:latin typeface="Arial"/>
+              <a:ea typeface="Arial"/>
+              <a:cs typeface="Arial"/>
+            </a:endParaRPr>
+          </a:p>
+          <a:p xmlns:a="http://schemas.openxmlformats.org/drawingml/2006/main">
+            <a:pPr indent="0" algn="l">
+              <a:lnSpc>
+                <a:spcPct val="100000"/>
+              </a:lnSpc>
+              <a:buNone/>
+            </a:pPr>
+            <a:r>
+              <a:rPr sz="2000" b="0" u="none">
+                <a:solidFill>
+                  <a:srgbClr val="000000"/>
+                </a:solidFill>
+                <a:latin typeface="Arial"/>
+                <a:ea typeface="Arial"/>
+                <a:cs typeface="Arial"/>
+              </a:rPr>
+              <a:t>• [Pause.]</a:t>
+            </a:r>
+            <a:endParaRPr sz="2000" b="0" u="none">
+              <a:solidFill>
+                <a:srgbClr val="000000"/>
+              </a:solidFill>
+              <a:latin typeface="Arial"/>
+              <a:ea typeface="Arial"/>
+              <a:cs typeface="Arial"/>
+            </a:endParaRPr>
+          </a:p>
+          <a:p xmlns:a="http://schemas.openxmlformats.org/drawingml/2006/main">
+            <a:pPr indent="0" algn="l">
+              <a:lnSpc>
+                <a:spcPct val="100000"/>
+              </a:lnSpc>
+              <a:buNone/>
+            </a:pPr>
+            <a:r>
+              <a:rPr sz="2000" b="0" u="none">
+                <a:solidFill>
+                  <a:srgbClr val="000000"/>
+                </a:solidFill>
+                <a:latin typeface="Arial"/>
+                <a:ea typeface="Arial"/>
+                <a:cs typeface="Arial"/>
+              </a:rPr>
+              <a:t/>
+            </a:r>
+            <a:endParaRPr sz="2000" b="0" u="none">
+              <a:solidFill>
+                <a:srgbClr val="000000"/>
+              </a:solidFill>
+              <a:latin typeface="Arial"/>
+              <a:ea typeface="Arial"/>
+              <a:cs typeface="Arial"/>
+            </a:endParaRPr>
+          </a:p>
+          <a:p xmlns:a="http://schemas.openxmlformats.org/drawingml/2006/main">
+            <a:pPr indent="0" algn="l">
+              <a:lnSpc>
+                <a:spcPct val="100000"/>
+              </a:lnSpc>
+              <a:buNone/>
+            </a:pPr>
+            <a:r>
+              <a:rPr sz="2000" b="0" u="none">
+                <a:solidFill>
+                  <a:srgbClr val="000000"/>
+                </a:solidFill>
+                <a:latin typeface="Arial"/>
+                <a:ea typeface="Arial"/>
+                <a:cs typeface="Arial"/>
+              </a:rPr>
+              <a:t>• The product never claims complete visibility, legal advice or an autonomous compliance decision.</a:t>
+            </a:r>
+            <a:endParaRPr sz="2000" b="0" u="none">
+              <a:solidFill>
+                <a:srgbClr val="000000"/>
+              </a:solidFill>
+              <a:latin typeface="Arial"/>
+              <a:ea typeface="Arial"/>
+              <a:cs typeface="Arial"/>
+            </a:endParaRPr>
+          </a:p>
+          <a:p xmlns:a="http://schemas.openxmlformats.org/drawingml/2006/main">
+            <a:pPr indent="0" algn="l">
+              <a:lnSpc>
+                <a:spcPct val="100000"/>
+              </a:lnSpc>
+              <a:buNone/>
+            </a:pPr>
+            <a:r>
+              <a:rPr sz="2000" b="0" u="none">
+                <a:solidFill>
+                  <a:srgbClr val="000000"/>
+                </a:solidFill>
+                <a:latin typeface="Arial"/>
+                <a:ea typeface="Arial"/>
+                <a:cs typeface="Arial"/>
+              </a:rPr>
+              <a:t/>
+            </a:r>
+            <a:endParaRPr sz="2000" b="0" u="none">
+              <a:solidFill>
+                <a:srgbClr val="000000"/>
+              </a:solidFill>
+              <a:latin typeface="Arial"/>
+              <a:ea typeface="Arial"/>
+              <a:cs typeface="Arial"/>
+            </a:endParaRPr>
+          </a:p>
+          <a:p xmlns:a="http://schemas.openxmlformats.org/drawingml/2006/main">
+            <a:pPr indent="0" algn="l">
+              <a:lnSpc>
+                <a:spcPct val="100000"/>
+              </a:lnSpc>
+              <a:buNone/>
+            </a:pPr>
+            <a:r>
+              <a:rPr sz="2000" b="0" u="none">
+                <a:solidFill>
+                  <a:srgbClr val="000000"/>
+                </a:solidFill>
+                <a:latin typeface="Arial"/>
+                <a:ea typeface="Arial"/>
+                <a:cs typeface="Arial"/>
+              </a:rPr>
+              <a:t>[Sources]</a:t>
+            </a:r>
+            <a:endParaRPr sz="2000" b="0" u="none">
+              <a:solidFill>
+                <a:srgbClr val="000000"/>
+              </a:solidFill>
+              <a:latin typeface="Arial"/>
+              <a:ea typeface="Arial"/>
+              <a:cs typeface="Arial"/>
+            </a:endParaRPr>
+          </a:p>
+          <a:p xmlns:a="http://schemas.openxmlformats.org/drawingml/2006/main">
+            <a:pPr indent="0" algn="l">
+              <a:lnSpc>
+                <a:spcPct val="100000"/>
+              </a:lnSpc>
+              <a:buNone/>
+            </a:pPr>
+            <a:r>
+              <a:rPr sz="2000" b="0" u="none">
+                <a:solidFill>
+                  <a:srgbClr val="000000"/>
+                </a:solidFill>
+                <a:latin typeface="Arial"/>
+                <a:ea typeface="Arial"/>
+                <a:cs typeface="Arial"/>
+              </a:rPr>
+              <a:t>- README.md</a:t>
+            </a:r>
+            <a:endParaRPr sz="2000" b="0" u="none">
+              <a:solidFill>
+                <a:srgbClr val="000000"/>
+              </a:solidFill>
+              <a:latin typeface="Arial"/>
+              <a:ea typeface="Arial"/>
+              <a:cs typeface="Arial"/>
+            </a:endParaRPr>
+          </a:p>
+          <a:p xmlns:a="http://schemas.openxmlformats.org/drawingml/2006/main">
+            <a:pPr indent="0" algn="l">
+              <a:lnSpc>
+                <a:spcPct val="100000"/>
+              </a:lnSpc>
+              <a:buNone/>
+            </a:pPr>
+            <a:r>
+              <a:rPr sz="2000" b="0" u="none">
+                <a:solidFill>
+                  <a:srgbClr val="000000"/>
+                </a:solidFill>
+                <a:latin typeface="Arial"/>
+                <a:ea typeface="Arial"/>
+                <a:cs typeface="Arial"/>
+              </a:rPr>
               <a:t>- docs/report-spec.md</a:t>
             </a:r>
             <a:endParaRPr sz="2000" b="0" u="none">
@@ -3308,6 +6977,9 @@
           </a:p>
           <a:p xmlns:a="http://schemas.openxmlformats.org/drawingml/2006/main">
             <a:pPr indent="0" algn="l">
+              <a:lnSpc>
+                <a:spcPct val="100000"/>
+              </a:lnSpc>
               <a:buNone/>
             </a:pPr>
             <a:r>
@@ -4046,8 +7718,8 @@
   </p:cSld>
   <p:clrMap bg1="lt1" tx1="dk1" bg2="lt2" tx2="dk2" accent1="accent1" accent2="accent2" accent3="accent3" accent4="accent4" accent5="accent5" accent6="accent6" hlink="hlink" folHlink="folHlink"/>
   <p:sldLayoutIdLst>
-    <p:sldLayoutId xmlns:r="http://schemas.openxmlformats.org/officeDocument/2006/relationships" id="2147483649" r:id="Re96647f487494410"/>
-    <p:sldLayoutId xmlns:r="http://schemas.openxmlformats.org/officeDocument/2006/relationships" id="2147483650" r:id="R8e418028d1914cc7"/>
+    <p:sldLayoutId xmlns:r="http://schemas.openxmlformats.org/officeDocument/2006/relationships" id="2147483649" r:id="R114454eb44da4509"/>
+    <p:sldLayoutId xmlns:r="http://schemas.openxmlformats.org/officeDocument/2006/relationships" id="2147483650" r:id="Ra25ed1cd907d4697"/>
   </p:sldLayoutIdLst>
 </p:sldMaster>
 </file>
@@ -5849,7 +9521,7 @@
         </p:style>
         <p:txBody>
           <a:bodyPr xmlns:a="http://schemas.openxmlformats.org/drawingml/2006/main" lIns="0" tIns="0" rIns="0" bIns="0" anchor="ctr">
-            <a:normAutofit/>
+            <a:normAutofit fontScale="100000"/>
           </a:bodyPr>
           <a:lstStyle xmlns:a="http://schemas.openxmlformats.org/drawingml/2006/main"/>
           <a:p xmlns:a="http://schemas.openxmlformats.org/drawingml/2006/main">
@@ -5871,7 +9543,7 @@
                 <a:ea typeface="Aptos"/>
                 <a:cs typeface="Aptos"/>
               </a:rPr>
-              <a:t>RESEARCHES</a:t>
+              <a:t>FINDS EVIDENCE</a:t>
             </a:r>
             <a:endParaRPr sz="1050" b="0" u="none">
               <a:solidFill>
@@ -6099,7 +9771,7 @@
         </p:style>
         <p:txBody>
           <a:bodyPr xmlns:a="http://schemas.openxmlformats.org/drawingml/2006/main" lIns="0" tIns="0" rIns="0" bIns="0" anchor="ctr">
-            <a:normAutofit/>
+            <a:normAutofit fontScale="100000"/>
           </a:bodyPr>
           <a:lstStyle xmlns:a="http://schemas.openxmlformats.org/drawingml/2006/main"/>
           <a:p xmlns:a="http://schemas.openxmlformats.org/drawingml/2006/main">
@@ -6121,7 +9793,7 @@
                 <a:ea typeface="Aptos"/>
                 <a:cs typeface="Aptos"/>
               </a:rPr>
-              <a:t>GROUNDS</a:t>
+              <a:t>VERIFIES</a:t>
             </a:r>
             <a:endParaRPr sz="1050" b="0" u="none">
               <a:solidFill>
@@ -10305,7 +13977,7 @@
         </p:style>
         <p:txBody>
           <a:bodyPr xmlns:a="http://schemas.openxmlformats.org/drawingml/2006/main" lIns="0" tIns="0" rIns="0" bIns="0" anchor="ctr">
-            <a:normAutofit/>
+            <a:normAutofit fontScale="100000"/>
           </a:bodyPr>
           <a:lstStyle xmlns:a="http://schemas.openxmlformats.org/drawingml/2006/main"/>
           <a:p xmlns:a="http://schemas.openxmlformats.org/drawingml/2006/main">
@@ -10327,7 +13999,7 @@
                 <a:ea typeface="Aptos"/>
                 <a:cs typeface="Aptos"/>
               </a:rPr>
-              <a:t>HAND OFF</a:t>
+              <a:t>REVIEW</a:t>
             </a:r>
             <a:endParaRPr sz="1050" b="0" u="none">
               <a:solidFill>
@@ -13255,7 +16927,7 @@
         </p:style>
         <p:txBody>
           <a:bodyPr xmlns:a="http://schemas.openxmlformats.org/drawingml/2006/main" lIns="0" tIns="0" rIns="0" bIns="0" anchor="ctr">
-            <a:normAutofit lnSpcReduction="9999"/>
+            <a:normAutofit fontScale="81878" lnSpcReduction="9999"/>
           </a:bodyPr>
           <a:lstStyle xmlns:a="http://schemas.openxmlformats.org/drawingml/2006/main"/>
           <a:p xmlns:a="http://schemas.openxmlformats.org/drawingml/2006/main">
@@ -13277,7 +16949,7 @@
                 <a:ea typeface="Aptos Display"/>
                 <a:cs typeface="Aptos Display"/>
               </a:rPr>
-              <a:t>Provenance</a:t>
+              <a:t>Traceable source</a:t>
             </a:r>
             <a:endParaRPr sz="2200" b="0" u="none">
               <a:solidFill>
@@ -13325,7 +16997,7 @@
         </p:style>
         <p:txBody>
           <a:bodyPr xmlns:a="http://schemas.openxmlformats.org/drawingml/2006/main" lIns="0" tIns="0" rIns="0" bIns="0" anchor="t">
-            <a:normAutofit/>
+            <a:normAutofit fontScale="100000"/>
           </a:bodyPr>
           <a:lstStyle xmlns:a="http://schemas.openxmlformats.org/drawingml/2006/main"/>
           <a:p xmlns:a="http://schemas.openxmlformats.org/drawingml/2006/main">
@@ -13347,7 +17019,7 @@
                 <a:ea typeface="Aptos"/>
                 <a:cs typeface="Aptos"/>
               </a:rPr>
-              <a:t>Source identity and retrieval metadata are complete</a:t>
+              <a:t>Source identity and retrieval details are complete</a:t>
             </a:r>
             <a:endParaRPr sz="1400" b="0" u="none">
               <a:solidFill>
@@ -13575,7 +17247,7 @@
         </p:style>
         <p:txBody>
           <a:bodyPr xmlns:a="http://schemas.openxmlformats.org/drawingml/2006/main" lIns="0" tIns="0" rIns="0" bIns="0" anchor="ctr">
-            <a:normAutofit fontScale="92500" lnSpcReduction="9999"/>
+            <a:normAutofit fontScale="89620" lnSpcReduction="9999"/>
           </a:bodyPr>
           <a:lstStyle xmlns:a="http://schemas.openxmlformats.org/drawingml/2006/main"/>
           <a:p xmlns:a="http://schemas.openxmlformats.org/drawingml/2006/main">
@@ -13597,7 +17269,7 @@
                 <a:ea typeface="Aptos Display"/>
                 <a:cs typeface="Aptos Display"/>
               </a:rPr>
-              <a:t>Currentness fit</a:t>
+              <a:t>Current enough</a:t>
             </a:r>
             <a:endParaRPr sz="2200" b="0" u="none">
               <a:solidFill>
@@ -13645,7 +17317,7 @@
         </p:style>
         <p:txBody>
           <a:bodyPr xmlns:a="http://schemas.openxmlformats.org/drawingml/2006/main" lIns="0" tIns="0" rIns="0" bIns="0" anchor="t">
-            <a:normAutofit/>
+            <a:normAutofit fontScale="100000"/>
           </a:bodyPr>
           <a:lstStyle xmlns:a="http://schemas.openxmlformats.org/drawingml/2006/main"/>
           <a:p xmlns:a="http://schemas.openxmlformats.org/drawingml/2006/main">
@@ -13667,7 +17339,7 @@
                 <a:ea typeface="Aptos"/>
                 <a:cs typeface="Aptos"/>
               </a:rPr>
-              <a:t>The source can support the claim's time</a:t>
+              <a:t>The source supports the claim's timing</a:t>
             </a:r>
             <a:endParaRPr sz="1400" b="0" u="none">
               <a:solidFill>
@@ -14019,7 +17691,7 @@
         </p:style>
         <p:txBody>
           <a:bodyPr xmlns:a="http://schemas.openxmlformats.org/drawingml/2006/main" lIns="0" tIns="0" rIns="0" bIns="0" anchor="t">
-            <a:normAutofit/>
+            <a:normAutofit fontScale="100000"/>
           </a:bodyPr>
           <a:lstStyle xmlns:a="http://schemas.openxmlformats.org/drawingml/2006/main"/>
           <a:p xmlns:a="http://schemas.openxmlformats.org/drawingml/2006/main">
@@ -14041,7 +17713,7 @@
                 <a:ea typeface="Aptos"/>
                 <a:cs typeface="Aptos"/>
               </a:rPr>
-              <a:t>honest refusal rate</a:t>
+              <a:t>unsupported claims refused</a:t>
             </a:r>
             <a:endParaRPr sz="1250" b="0" u="none">
               <a:solidFill>
@@ -14215,7 +17887,7 @@
         </p:style>
         <p:txBody>
           <a:bodyPr xmlns:a="http://schemas.openxmlformats.org/drawingml/2006/main" lIns="0" tIns="0" rIns="0" bIns="0" anchor="t">
-            <a:normAutofit/>
+            <a:normAutofit fontScale="100000"/>
           </a:bodyPr>
           <a:lstStyle xmlns:a="http://schemas.openxmlformats.org/drawingml/2006/main"/>
           <a:p xmlns:a="http://schemas.openxmlformats.org/drawingml/2006/main">
@@ -14237,7 +17909,7 @@
                 <a:ea typeface="Aptos"/>
                 <a:cs typeface="Aptos"/>
               </a:rPr>
-              <a:t>thin-company false positives</a:t>
+              <a:t>false claims on thin-data companies</a:t>
             </a:r>
             <a:endParaRPr sz="1250" b="0" u="none">
               <a:solidFill>
@@ -14411,7 +18083,7 @@
         </p:style>
         <p:txBody>
           <a:bodyPr xmlns:a="http://schemas.openxmlformats.org/drawingml/2006/main" lIns="0" tIns="0" rIns="0" bIns="0" anchor="t">
-            <a:normAutofit/>
+            <a:normAutofit fontScale="100000"/>
           </a:bodyPr>
           <a:lstStyle xmlns:a="http://schemas.openxmlformats.org/drawingml/2006/main"/>
           <a:p xmlns:a="http://schemas.openxmlformats.org/drawingml/2006/main">
@@ -14433,7 +18105,7 @@
                 <a:ea typeface="Aptos"/>
                 <a:cs typeface="Aptos"/>
               </a:rPr>
-              <a:t>provenance violations</a:t>
+              <a:t>missing source details</a:t>
             </a:r>
             <a:endParaRPr sz="1250" b="0" u="none">
               <a:solidFill>
@@ -15803,7 +19475,7 @@
         </p:style>
         <p:txBody>
           <a:bodyPr xmlns:a="http://schemas.openxmlformats.org/drawingml/2006/main" lIns="0" tIns="0" rIns="0" bIns="0" anchor="t">
-            <a:normAutofit lnSpcReduction="9999"/>
+            <a:normAutofit fontScale="81290" lnSpcReduction="9999"/>
           </a:bodyPr>
           <a:lstStyle xmlns:a="http://schemas.openxmlformats.org/drawingml/2006/main"/>
           <a:p xmlns:a="http://schemas.openxmlformats.org/drawingml/2006/main">
@@ -15825,7 +19497,8 @@
                 <a:ea typeface="Aptos Display"/>
                 <a:cs typeface="Aptos Display"/>
               </a:rPr>
-              <a:t>Facts + questions</a:t>
+              <a:t>Supported facts
++ questions</a:t>
             </a:r>
             <a:endParaRPr sz="1900" b="0" u="none">
               <a:solidFill>
@@ -15854,8 +19527,8 @@
         </p:nvSpPr>
         <p:spPr>
           <a:xfrm xmlns:a="http://schemas.openxmlformats.org/drawingml/2006/main">
-            <a:off x="4846320" y="4325040"/>
-            <a:ext cx="749520" cy="219240"/>
+            <a:off x="4762500" y="3981450"/>
+            <a:ext cx="1714500" cy="219240"/>
           </a:xfrm>
           <a:prstGeom xmlns:a="http://schemas.openxmlformats.org/drawingml/2006/main" prst="rect">
             <a:avLst/>
@@ -15873,7 +19546,7 @@
         </p:style>
         <p:txBody>
           <a:bodyPr xmlns:a="http://schemas.openxmlformats.org/drawingml/2006/main" lIns="0" tIns="0" rIns="0" bIns="0" anchor="ctr">
-            <a:normAutofit/>
+            <a:normAutofit fontScale="100000"/>
           </a:bodyPr>
           <a:lstStyle xmlns:a="http://schemas.openxmlformats.org/drawingml/2006/main"/>
           <a:p xmlns:a="http://schemas.openxmlformats.org/drawingml/2006/main">
@@ -15895,7 +19568,7 @@
                 <a:ea typeface="Aptos"/>
                 <a:cs typeface="Aptos"/>
               </a:rPr>
-              <a:t>RETRY</a:t>
+              <a:t>RESEARCH AGAIN</a:t>
             </a:r>
             <a:endParaRPr sz="1000" b="0" u="none">
               <a:solidFill>
@@ -15999,7 +19672,7 @@
         </p:style>
         <p:txBody>
           <a:bodyPr xmlns:a="http://schemas.openxmlformats.org/drawingml/2006/main" lIns="0" tIns="0" rIns="0" bIns="0" anchor="ctr">
-            <a:normAutofit fontScale="92500" lnSpcReduction="9999"/>
+            <a:normAutofit fontScale="96246" lnSpcReduction="9999"/>
           </a:bodyPr>
           <a:lstStyle xmlns:a="http://schemas.openxmlformats.org/drawingml/2006/main"/>
           <a:p xmlns:a="http://schemas.openxmlformats.org/drawingml/2006/main">
@@ -16021,7 +19694,7 @@
                 <a:ea typeface="Aptos"/>
                 <a:cs typeface="Aptos"/>
               </a:rPr>
-              <a:t>EXHAUSTED → UNDETERMINED</a:t>
+              <a:t>NO RETRIES → UNDETERMINED</a:t>
             </a:r>
             <a:endParaRPr sz="1050" b="0" u="none">
               <a:solidFill>
@@ -16679,7 +20352,7 @@
         </p:style>
         <p:txBody>
           <a:bodyPr xmlns:a="http://schemas.openxmlformats.org/drawingml/2006/main" lIns="0" tIns="0" rIns="0" bIns="0" anchor="ctr">
-            <a:normAutofit/>
+            <a:normAutofit fontScale="100000"/>
           </a:bodyPr>
           <a:lstStyle xmlns:a="http://schemas.openxmlformats.org/drawingml/2006/main"/>
           <a:p xmlns:a="http://schemas.openxmlformats.org/drawingml/2006/main">
@@ -16701,7 +20374,7 @@
                 <a:ea typeface="Aptos"/>
                 <a:cs typeface="Aptos"/>
               </a:rPr>
-              <a:t>THE POST-MVP PATH</a:t>
+              <a:t>POST-MVP • VENDOR DRIFT</a:t>
             </a:r>
             <a:endParaRPr sz="1100" b="0" u="none">
               <a:solidFill>
@@ -16749,7 +20422,7 @@
         </p:style>
         <p:txBody>
           <a:bodyPr xmlns:a="http://schemas.openxmlformats.org/drawingml/2006/main" lIns="0" tIns="0" rIns="0" bIns="0" anchor="t">
-            <a:normAutofit fontScale="85000" lnSpcReduction="9999"/>
+            <a:normAutofit fontScale="88810" lnSpcReduction="9999"/>
           </a:bodyPr>
           <a:lstStyle xmlns:a="http://schemas.openxmlformats.org/drawingml/2006/main"/>
           <a:p xmlns:a="http://schemas.openxmlformats.org/drawingml/2006/main">
@@ -16771,7 +20444,7 @@
                 <a:ea typeface="Aptos Display"/>
                 <a:cs typeface="Aptos Display"/>
               </a:rPr>
-              <a:t>The recurring product is vendor-drift monitoring</a:t>
+              <a:t>Vendor updates can change a client's AI inventory</a:t>
             </a:r>
             <a:endParaRPr sz="4000" b="0" u="none">
               <a:solidFill>
@@ -17190,7 +20863,7 @@
         </p:style>
         <p:txBody>
           <a:bodyPr xmlns:a="http://schemas.openxmlformats.org/drawingml/2006/main" lIns="0" tIns="0" rIns="0" bIns="0" anchor="t">
-            <a:normAutofit fontScale="85000" lnSpcReduction="9999"/>
+            <a:normAutofit fontScale="100000" lnSpcReduction="9999"/>
           </a:bodyPr>
           <a:lstStyle xmlns:a="http://schemas.openxmlformats.org/drawingml/2006/main"/>
           <a:p xmlns:a="http://schemas.openxmlformats.org/drawingml/2006/main">
@@ -17212,7 +20885,7 @@
                 <a:ea typeface="Aptos"/>
                 <a:cs typeface="Aptos"/>
               </a:rPr>
-              <a:t>Client's ATS is outside the inventory</a:t>
+              <a:t>Client already uses the ATS</a:t>
             </a:r>
             <a:endParaRPr sz="1350" b="0" u="none">
               <a:solidFill>
@@ -17440,7 +21113,7 @@
         </p:style>
         <p:txBody>
           <a:bodyPr xmlns:a="http://schemas.openxmlformats.org/drawingml/2006/main" lIns="0" tIns="0" rIns="0" bIns="0" anchor="t">
-            <a:normAutofit fontScale="85000" lnSpcReduction="9999"/>
+            <a:normAutofit fontScale="77953" lnSpcReduction="9999"/>
           </a:bodyPr>
           <a:lstStyle xmlns:a="http://schemas.openxmlformats.org/drawingml/2006/main"/>
           <a:p xmlns:a="http://schemas.openxmlformats.org/drawingml/2006/main">
@@ -17462,7 +21135,7 @@
                 <a:ea typeface="Aptos Display"/>
                 <a:cs typeface="Aptos Display"/>
               </a:rPr>
-              <a:t>Vendor ships AI CV ranking</a:t>
+              <a:t>Vendor adds AI CV ranking</a:t>
             </a:r>
             <a:endParaRPr sz="2000" b="0" u="none">
               <a:solidFill>
@@ -17510,7 +21183,7 @@
         </p:style>
         <p:txBody>
           <a:bodyPr xmlns:a="http://schemas.openxmlformats.org/drawingml/2006/main" lIns="0" tIns="0" rIns="0" bIns="0" anchor="t">
-            <a:normAutofit fontScale="85000" lnSpcReduction="9999"/>
+            <a:normAutofit fontScale="100000" lnSpcReduction="9999"/>
           </a:bodyPr>
           <a:lstStyle xmlns:a="http://schemas.openxmlformats.org/drawingml/2006/main"/>
           <a:p xmlns:a="http://schemas.openxmlformats.org/drawingml/2006/main">
@@ -17532,7 +21205,7 @@
                 <a:ea typeface="Aptos"/>
                 <a:cs typeface="Aptos"/>
               </a:rPr>
-              <a:t>The software changes without a new purchase</a:t>
+              <a:t>No new client purchase</a:t>
             </a:r>
             <a:endParaRPr sz="1350" b="0" u="none">
               <a:solidFill>
@@ -17767,7 +21440,7 @@
         </p:style>
         <p:txBody>
           <a:bodyPr xmlns:a="http://schemas.openxmlformats.org/drawingml/2006/main" lIns="0" tIns="0" rIns="0" bIns="0" anchor="t">
-            <a:normAutofit fontScale="85000" lnSpcReduction="19999"/>
+            <a:normAutofit fontScale="75704" lnSpcReduction="19999"/>
           </a:bodyPr>
           <a:lstStyle xmlns:a="http://schemas.openxmlformats.org/drawingml/2006/main"/>
           <a:p xmlns:a="http://schemas.openxmlformats.org/drawingml/2006/main">
@@ -17789,7 +21462,7 @@
                 <a:ea typeface="Aptos Display"/>
                 <a:cs typeface="Aptos Display"/>
               </a:rPr>
-              <a:t>The client's systems changed</a:t>
+              <a:t>The AI inventory changed</a:t>
             </a:r>
             <a:endParaRPr sz="2200" b="0" u="none">
               <a:solidFill>
@@ -17837,7 +21510,7 @@
         </p:style>
         <p:txBody>
           <a:bodyPr xmlns:a="http://schemas.openxmlformats.org/drawingml/2006/main" lIns="0" tIns="0" rIns="0" bIns="0" anchor="t">
-            <a:normAutofit/>
+            <a:normAutofit fontScale="100000"/>
           </a:bodyPr>
           <a:lstStyle xmlns:a="http://schemas.openxmlformats.org/drawingml/2006/main"/>
           <a:p xmlns:a="http://schemas.openxmlformats.org/drawingml/2006/main">
@@ -17859,7 +21532,7 @@
                 <a:ea typeface="Aptos"/>
                 <a:cs typeface="Aptos"/>
               </a:rPr>
-              <a:t>even though the client did nothing</a:t>
+              <a:t>Alert the adviser</a:t>
             </a:r>
             <a:endParaRPr sz="1350" b="0" u="none">
               <a:solidFill>
@@ -18029,7 +21702,7 @@
         </p:style>
         <p:txBody>
           <a:bodyPr xmlns:a="http://schemas.openxmlformats.org/drawingml/2006/main" lIns="0" tIns="0" rIns="0" bIns="0" anchor="ctr">
-            <a:normAutofit/>
+            <a:normAutofit fontScale="100000"/>
           </a:bodyPr>
           <a:lstStyle xmlns:a="http://schemas.openxmlformats.org/drawingml/2006/main"/>
           <a:p xmlns:a="http://schemas.openxmlformats.org/drawingml/2006/main">
@@ -18051,7 +21724,7 @@
                 <a:ea typeface="Aptos"/>
                 <a:cs typeface="Aptos"/>
               </a:rPr>
-              <a:t>CONFIRMED DRIFT ALERTS</a:t>
+              <a:t>VALIDATE DRIFT ALERTS</a:t>
             </a:r>
             <a:endParaRPr sz="1100" b="0" u="none">
               <a:solidFill>
@@ -18221,7 +21894,7 @@
         </p:style>
         <p:txBody>
           <a:bodyPr xmlns:a="http://schemas.openxmlformats.org/drawingml/2006/main" lIns="0" tIns="0" rIns="0" bIns="0" anchor="ctr">
-            <a:normAutofit lnSpcReduction="9999"/>
+            <a:normAutofit fontScale="91339" lnSpcReduction="9999"/>
           </a:bodyPr>
           <a:lstStyle xmlns:a="http://schemas.openxmlformats.org/drawingml/2006/main"/>
           <a:p xmlns:a="http://schemas.openxmlformats.org/drawingml/2006/main">
@@ -18243,7 +21916,7 @@
                 <a:ea typeface="Aptos Display"/>
                 <a:cs typeface="Aptos Display"/>
               </a:rPr>
-              <a:t>From a blank-page investigation to an auditable, recurring conversation.</a:t>
+              <a:t>Turn a blank-page scan into an auditable, recurring conversation.</a:t>
             </a:r>
             <a:endParaRPr sz="2100" b="0" u="none">
               <a:solidFill>
@@ -18867,7 +22540,7 @@
         </p:style>
         <p:txBody>
           <a:bodyPr xmlns:a="http://schemas.openxmlformats.org/drawingml/2006/main" lIns="0" tIns="0" rIns="0" bIns="0" anchor="t">
-            <a:normAutofit/>
+            <a:normAutofit fontScale="100000"/>
           </a:bodyPr>
           <a:lstStyle xmlns:a="http://schemas.openxmlformats.org/drawingml/2006/main"/>
           <a:p xmlns:a="http://schemas.openxmlformats.org/drawingml/2006/main">
@@ -18889,7 +22562,7 @@
                 <a:ea typeface="Aptos"/>
                 <a:cs typeface="Aptos"/>
               </a:rPr>
-              <a:t>Honest refusal</a:t>
+              <a:t>Unsupported claims refused</a:t>
             </a:r>
             <a:endParaRPr sz="1250" b="0" u="none">
               <a:solidFill>
@@ -19063,7 +22736,7 @@
         </p:style>
         <p:txBody>
           <a:bodyPr xmlns:a="http://schemas.openxmlformats.org/drawingml/2006/main" lIns="0" tIns="0" rIns="0" bIns="0" anchor="t">
-            <a:normAutofit/>
+            <a:normAutofit fontScale="100000"/>
           </a:bodyPr>
           <a:lstStyle xmlns:a="http://schemas.openxmlformats.org/drawingml/2006/main"/>
           <a:p xmlns:a="http://schemas.openxmlformats.org/drawingml/2006/main">
@@ -19085,7 +22758,7 @@
                 <a:ea typeface="Aptos"/>
                 <a:cs typeface="Aptos"/>
               </a:rPr>
-              <a:t>Thin-company false positives</a:t>
+              <a:t>False claims on thin-data companies</a:t>
             </a:r>
             <a:endParaRPr sz="1250" b="0" u="none">
               <a:solidFill>
@@ -19259,7 +22932,7 @@
         </p:style>
         <p:txBody>
           <a:bodyPr xmlns:a="http://schemas.openxmlformats.org/drawingml/2006/main" lIns="0" tIns="0" rIns="0" bIns="0" anchor="t">
-            <a:normAutofit/>
+            <a:normAutofit fontScale="100000"/>
           </a:bodyPr>
           <a:lstStyle xmlns:a="http://schemas.openxmlformats.org/drawingml/2006/main"/>
           <a:p xmlns:a="http://schemas.openxmlformats.org/drawingml/2006/main">
@@ -19281,7 +22954,7 @@
                 <a:ea typeface="Aptos"/>
                 <a:cs typeface="Aptos"/>
               </a:rPr>
-              <a:t>Provenance violations</a:t>
+              <a:t>Missing source details</a:t>
             </a:r>
             <a:endParaRPr sz="1250" b="0" u="none">
               <a:solidFill>
@@ -19455,7 +23128,7 @@
         </p:style>
         <p:txBody>
           <a:bodyPr xmlns:a="http://schemas.openxmlformats.org/drawingml/2006/main" lIns="0" tIns="0" rIns="0" bIns="0" anchor="ctr">
-            <a:normAutofit/>
+            <a:normAutofit fontScale="100000"/>
           </a:bodyPr>
           <a:lstStyle xmlns:a="http://schemas.openxmlformats.org/drawingml/2006/main"/>
           <a:p xmlns:a="http://schemas.openxmlformats.org/drawingml/2006/main">
@@ -19477,7 +23150,7 @@
                 <a:ea typeface="Aptos"/>
                 <a:cs typeface="Aptos"/>
               </a:rPr>
-              <a:t>Recall</a:t>
+              <a:t>Systems found</a:t>
             </a:r>
             <a:endParaRPr sz="1500" b="0" u="none">
               <a:solidFill>
@@ -19721,7 +23394,7 @@
         </p:style>
         <p:txBody>
           <a:bodyPr xmlns:a="http://schemas.openxmlformats.org/drawingml/2006/main" lIns="0" tIns="0" rIns="0" bIns="0" anchor="ctr">
-            <a:normAutofit/>
+            <a:normAutofit fontScale="100000"/>
           </a:bodyPr>
           <a:lstStyle xmlns:a="http://schemas.openxmlformats.org/drawingml/2006/main"/>
           <a:p xmlns:a="http://schemas.openxmlformats.org/drawingml/2006/main">
@@ -19743,7 +23416,7 @@
                 <a:ea typeface="Aptos"/>
                 <a:cs typeface="Aptos"/>
               </a:rPr>
-              <a:t>Role correctness</a:t>
+              <a:t>Role labels correct</a:t>
             </a:r>
             <a:endParaRPr sz="1500" b="0" u="none">
               <a:solidFill>
@@ -19987,7 +23660,7 @@
         </p:style>
         <p:txBody>
           <a:bodyPr xmlns:a="http://schemas.openxmlformats.org/drawingml/2006/main" lIns="0" tIns="0" rIns="0" bIns="0" anchor="ctr">
-            <a:normAutofit/>
+            <a:normAutofit fontScale="86642"/>
           </a:bodyPr>
           <a:lstStyle xmlns:a="http://schemas.openxmlformats.org/drawingml/2006/main"/>
           <a:p xmlns:a="http://schemas.openxmlformats.org/drawingml/2006/main">
@@ -20009,7 +23682,7 @@
                 <a:ea typeface="Aptos"/>
                 <a:cs typeface="Aptos"/>
               </a:rPr>
-              <a:t>Over-claim rate</a:t>
+              <a:t>Unsupported use claims</a:t>
             </a:r>
             <a:endParaRPr sz="1500" b="0" u="none">
               <a:solidFill>
@@ -20445,7 +24118,7 @@
         </p:style>
         <p:txBody>
           <a:bodyPr xmlns:a="http://schemas.openxmlformats.org/drawingml/2006/main" lIns="0" tIns="0" rIns="0" bIns="0" anchor="ctr">
-            <a:normAutofit fontScale="92500" lnSpcReduction="9999"/>
+            <a:normAutofit fontScale="76947" lnSpcReduction="9999"/>
           </a:bodyPr>
           <a:lstStyle xmlns:a="http://schemas.openxmlformats.org/drawingml/2006/main"/>
           <a:p xmlns:a="http://schemas.openxmlformats.org/drawingml/2006/main">
@@ -20467,7 +24140,7 @@
                 <a:ea typeface="Aptos"/>
                 <a:cs typeface="Aptos"/>
               </a:rPr>
-              <a:t>One run cannot attribute a change to a configuration.</a:t>
+              <a:t>Same code, different recall: one run is not evidence of improvement.</a:t>
             </a:r>
             <a:endParaRPr sz="1400" b="0" u="none">
               <a:solidFill>

</xml_diff>

<commit_message>
Clarify LangGraph boundary on slide 6
</commit_message>
<xml_diff>
--- a/docs/ai-pre-scan-presentation.pptx
+++ b/docs/ai-pre-scan-presentation.pptx
@@ -2,22 +2,22 @@
 <file path=ppt/presentation.xml><?xml version="1.0" encoding="utf-8"?>
 <p:presentation xmlns:p="http://schemas.openxmlformats.org/presentationml/2006/main">
   <p:sldMasterIdLst>
-    <p:sldMasterId xmlns:r="http://schemas.openxmlformats.org/officeDocument/2006/relationships" id="2147483648" r:id="R748a65716b3e4f92"/>
+    <p:sldMasterId xmlns:r="http://schemas.openxmlformats.org/officeDocument/2006/relationships" id="2147483648" r:id="R92dd9d272a2e463c"/>
   </p:sldMasterIdLst>
   <p:notesMasterIdLst>
-    <p:notesMasterId xmlns:r="http://schemas.openxmlformats.org/officeDocument/2006/relationships" r:id="R5b5f6733174e4b5d"/>
+    <p:notesMasterId xmlns:r="http://schemas.openxmlformats.org/officeDocument/2006/relationships" r:id="Rab09dc90d9854225"/>
   </p:notesMasterIdLst>
   <p:sldIdLst>
-    <p:sldId xmlns:r="http://schemas.openxmlformats.org/officeDocument/2006/relationships" id="256" r:id="Ra12f18d98f844b34"/>
-    <p:sldId xmlns:r="http://schemas.openxmlformats.org/officeDocument/2006/relationships" id="257" r:id="R18eeb41c2a9944f0"/>
-    <p:sldId xmlns:r="http://schemas.openxmlformats.org/officeDocument/2006/relationships" id="258" r:id="R6c0bda55158d4cf5"/>
-    <p:sldId xmlns:r="http://schemas.openxmlformats.org/officeDocument/2006/relationships" id="259" r:id="Rab726b1460e445bc"/>
-    <p:sldId xmlns:r="http://schemas.openxmlformats.org/officeDocument/2006/relationships" id="260" r:id="Rdf04b6412d934680"/>
-    <p:sldId xmlns:r="http://schemas.openxmlformats.org/officeDocument/2006/relationships" id="261" r:id="Ree4a65eb775d46e3"/>
-    <p:sldId xmlns:r="http://schemas.openxmlformats.org/officeDocument/2006/relationships" id="262" r:id="R840e91533dce4774"/>
-    <p:sldId xmlns:r="http://schemas.openxmlformats.org/officeDocument/2006/relationships" id="263" r:id="Rd3dc5642fbaa4d6e"/>
-    <p:sldId xmlns:r="http://schemas.openxmlformats.org/officeDocument/2006/relationships" id="264" r:id="Ree7b6fc777414f78"/>
-    <p:sldId xmlns:r="http://schemas.openxmlformats.org/officeDocument/2006/relationships" id="265" r:id="Rde7afdbcf69e4726"/>
+    <p:sldId xmlns:r="http://schemas.openxmlformats.org/officeDocument/2006/relationships" id="256" r:id="Rb69ed3058c7e46e9"/>
+    <p:sldId xmlns:r="http://schemas.openxmlformats.org/officeDocument/2006/relationships" id="257" r:id="Rc8d0374a177843f4"/>
+    <p:sldId xmlns:r="http://schemas.openxmlformats.org/officeDocument/2006/relationships" id="258" r:id="R7fa9599ad871449c"/>
+    <p:sldId xmlns:r="http://schemas.openxmlformats.org/officeDocument/2006/relationships" id="259" r:id="R4930c031385943cf"/>
+    <p:sldId xmlns:r="http://schemas.openxmlformats.org/officeDocument/2006/relationships" id="260" r:id="R3b3ff263e9c24384"/>
+    <p:sldId xmlns:r="http://schemas.openxmlformats.org/officeDocument/2006/relationships" id="261" r:id="R337fc485321c4029"/>
+    <p:sldId xmlns:r="http://schemas.openxmlformats.org/officeDocument/2006/relationships" id="262" r:id="R1af2332d03614bb9"/>
+    <p:sldId xmlns:r="http://schemas.openxmlformats.org/officeDocument/2006/relationships" id="263" r:id="R0ef8cb050297458c"/>
+    <p:sldId xmlns:r="http://schemas.openxmlformats.org/officeDocument/2006/relationships" id="264" r:id="Reb96827a9bf04190"/>
+    <p:sldId xmlns:r="http://schemas.openxmlformats.org/officeDocument/2006/relationships" id="265" r:id="Rc2c909992d5a4f5f"/>
   </p:sldIdLst>
   <p:sldSz cx="12192000" cy="6858000"/>
   <p:notesSz cx="6858000" cy="9144000"/>
@@ -4489,7 +4489,7 @@
                 <a:ea typeface="Arial"/>
                 <a:cs typeface="Arial"/>
               </a:rPr>
-              <a:t>• LangGraph keeps the deterministic evidence gate inside the workflow loop.</a:t>
+              <a:t>• Everything above the grey delivery rail sits inside LangGraph: research, extraction, the evidence gate, retry state and report routing.</a:t>
             </a:r>
             <a:endParaRPr sz="2000" b="0" u="none">
               <a:solidFill>
@@ -4529,7 +4529,7 @@
                 <a:ea typeface="Arial"/>
                 <a:cs typeface="Arial"/>
               </a:rPr>
-              <a:t>• If the evidence checks pass, supported facts and questions move to the report.</a:t>
+              <a:t>• LangGraph keeps the deterministic evidence gate inside that workflow loop.</a:t>
             </a:r>
             <a:endParaRPr sz="2000" b="0" u="none">
               <a:solidFill>
@@ -4569,7 +4569,7 @@
                 <a:ea typeface="Arial"/>
                 <a:cs typeface="Arial"/>
               </a:rPr>
-              <a:t>• If a check fails and retries remain, the workflow researches again.</a:t>
+              <a:t>• If the evidence checks pass, supported facts and questions move to the report.</a:t>
             </a:r>
             <a:endParaRPr sz="2000" b="0" u="none">
               <a:solidFill>
@@ -4617,6 +4617,57 @@
                 <a:ea typeface="Arial"/>
                 <a:cs typeface="Arial"/>
               </a:rPr>
+              <a:t>• If a check fails and retries remain, the workflow researches again.</a:t>
+            </a:r>
+            <a:endParaRPr sz="2000" b="0" u="none">
+              <a:solidFill>
+                <a:srgbClr val="000000"/>
+              </a:solidFill>
+              <a:latin typeface="Arial"/>
+              <a:ea typeface="Arial"/>
+              <a:cs typeface="Arial"/>
+            </a:endParaRPr>
+          </a:p>
+          <a:p xmlns:a="http://schemas.openxmlformats.org/drawingml/2006/main">
+            <a:pPr indent="0" algn="l">
+              <a:buNone/>
+            </a:pPr>
+            <a:r>
+              <a:rPr sz="2000" b="0" u="none">
+                <a:solidFill>
+                  <a:srgbClr val="000000"/>
+                </a:solidFill>
+                <a:latin typeface="Arial"/>
+                <a:ea typeface="Arial"/>
+                <a:cs typeface="Arial"/>
+              </a:rPr>
+              <a:t/>
+            </a:r>
+            <a:endParaRPr sz="2000" b="0" u="none">
+              <a:solidFill>
+                <a:srgbClr val="000000"/>
+              </a:solidFill>
+              <a:latin typeface="Arial"/>
+              <a:ea typeface="Arial"/>
+              <a:cs typeface="Arial"/>
+            </a:endParaRPr>
+          </a:p>
+          <a:p xmlns:a="http://schemas.openxmlformats.org/drawingml/2006/main">
+            <a:pPr indent="0" algn="l">
+              <a:lnSpc>
+                <a:spcPct val="100000"/>
+              </a:lnSpc>
+              <a:buNone/>
+            </a:pPr>
+            <a:r>
+              <a:rPr sz="2000" b="0" u="none">
+                <a:solidFill>
+                  <a:srgbClr val="000000"/>
+                </a:solidFill>
+                <a:latin typeface="Arial"/>
+                <a:ea typeface="Arial"/>
+                <a:cs typeface="Arial"/>
+              </a:rPr>
               <a:t>• If no retries remain, the claim becomes undetermined.</a:t>
             </a:r>
             <a:endParaRPr sz="2000" b="0" u="none">
@@ -4630,6 +4681,9 @@
           </a:p>
           <a:p xmlns:a="http://schemas.openxmlformats.org/drawingml/2006/main">
             <a:pPr indent="0" algn="l">
+              <a:lnSpc>
+                <a:spcPct val="100000"/>
+              </a:lnSpc>
               <a:buNone/>
             </a:pPr>
             <a:r>
@@ -7718,8 +7772,8 @@
   </p:cSld>
   <p:clrMap bg1="lt1" tx1="dk1" bg2="lt2" tx2="dk2" accent1="accent1" accent2="accent2" accent3="accent3" accent4="accent4" accent5="accent5" accent6="accent6" hlink="hlink" folHlink="folHlink"/>
   <p:sldLayoutIdLst>
-    <p:sldLayoutId xmlns:r="http://schemas.openxmlformats.org/officeDocument/2006/relationships" id="2147483649" r:id="R114454eb44da4509"/>
-    <p:sldLayoutId xmlns:r="http://schemas.openxmlformats.org/officeDocument/2006/relationships" id="2147483650" r:id="Ra25ed1cd907d4697"/>
+    <p:sldLayoutId xmlns:r="http://schemas.openxmlformats.org/officeDocument/2006/relationships" id="2147483649" r:id="Rbd58e1ae051846b3"/>
+    <p:sldLayoutId xmlns:r="http://schemas.openxmlformats.org/officeDocument/2006/relationships" id="2147483650" r:id="R24032771bf754a90"/>
   </p:sldLayoutIdLst>
 </p:sldMaster>
 </file>
@@ -18345,7 +18399,7 @@
                 <a:ea typeface="Aptos"/>
                 <a:cs typeface="Aptos"/>
               </a:rPr>
-              <a:t>THE ARCHITECTURE</a:t>
+              <a:t>LANGGRAPH WORKFLOW</a:t>
             </a:r>
             <a:endParaRPr sz="1100" b="0" u="none">
               <a:solidFill>
@@ -18393,7 +18447,7 @@
         </p:style>
         <p:txBody>
           <a:bodyPr xmlns:a="http://schemas.openxmlformats.org/drawingml/2006/main" lIns="0" tIns="0" rIns="0" bIns="0" anchor="t">
-            <a:normAutofit fontScale="85000" lnSpcReduction="9999"/>
+            <a:normAutofit fontScale="100000" lnSpcReduction="9999"/>
           </a:bodyPr>
           <a:lstStyle xmlns:a="http://schemas.openxmlformats.org/drawingml/2006/main"/>
           <a:p xmlns:a="http://schemas.openxmlformats.org/drawingml/2006/main">
@@ -18415,7 +18469,7 @@
                 <a:ea typeface="Aptos Display"/>
                 <a:cs typeface="Aptos Display"/>
               </a:rPr>
-              <a:t>LangGraph makes the evidence gate operational</a:t>
+              <a:t>LangGraph runs the full evidence loop</a:t>
             </a:r>
             <a:endParaRPr sz="4000" b="0" u="none">
               <a:solidFill>

</xml_diff>

<commit_message>
Make LangGraph boundary explicit on slide 6
</commit_message>
<xml_diff>
--- a/docs/ai-pre-scan-presentation.pptx
+++ b/docs/ai-pre-scan-presentation.pptx
@@ -2,22 +2,22 @@
 <file path=ppt/presentation.xml><?xml version="1.0" encoding="utf-8"?>
 <p:presentation xmlns:p="http://schemas.openxmlformats.org/presentationml/2006/main">
   <p:sldMasterIdLst>
-    <p:sldMasterId xmlns:r="http://schemas.openxmlformats.org/officeDocument/2006/relationships" id="2147483648" r:id="R92dd9d272a2e463c"/>
+    <p:sldMasterId xmlns:r="http://schemas.openxmlformats.org/officeDocument/2006/relationships" id="2147483648" r:id="R1e8dda934a2c4f45"/>
   </p:sldMasterIdLst>
   <p:notesMasterIdLst>
-    <p:notesMasterId xmlns:r="http://schemas.openxmlformats.org/officeDocument/2006/relationships" r:id="Rab09dc90d9854225"/>
+    <p:notesMasterId xmlns:r="http://schemas.openxmlformats.org/officeDocument/2006/relationships" r:id="R548e4a765b4d4190"/>
   </p:notesMasterIdLst>
   <p:sldIdLst>
-    <p:sldId xmlns:r="http://schemas.openxmlformats.org/officeDocument/2006/relationships" id="256" r:id="Rb69ed3058c7e46e9"/>
-    <p:sldId xmlns:r="http://schemas.openxmlformats.org/officeDocument/2006/relationships" id="257" r:id="Rc8d0374a177843f4"/>
-    <p:sldId xmlns:r="http://schemas.openxmlformats.org/officeDocument/2006/relationships" id="258" r:id="R7fa9599ad871449c"/>
-    <p:sldId xmlns:r="http://schemas.openxmlformats.org/officeDocument/2006/relationships" id="259" r:id="R4930c031385943cf"/>
-    <p:sldId xmlns:r="http://schemas.openxmlformats.org/officeDocument/2006/relationships" id="260" r:id="R3b3ff263e9c24384"/>
-    <p:sldId xmlns:r="http://schemas.openxmlformats.org/officeDocument/2006/relationships" id="261" r:id="R337fc485321c4029"/>
-    <p:sldId xmlns:r="http://schemas.openxmlformats.org/officeDocument/2006/relationships" id="262" r:id="R1af2332d03614bb9"/>
-    <p:sldId xmlns:r="http://schemas.openxmlformats.org/officeDocument/2006/relationships" id="263" r:id="R0ef8cb050297458c"/>
-    <p:sldId xmlns:r="http://schemas.openxmlformats.org/officeDocument/2006/relationships" id="264" r:id="Reb96827a9bf04190"/>
-    <p:sldId xmlns:r="http://schemas.openxmlformats.org/officeDocument/2006/relationships" id="265" r:id="Rc2c909992d5a4f5f"/>
+    <p:sldId xmlns:r="http://schemas.openxmlformats.org/officeDocument/2006/relationships" id="256" r:id="Rd624c8fcb45d4a21"/>
+    <p:sldId xmlns:r="http://schemas.openxmlformats.org/officeDocument/2006/relationships" id="257" r:id="R0d4d4488bb244fa5"/>
+    <p:sldId xmlns:r="http://schemas.openxmlformats.org/officeDocument/2006/relationships" id="258" r:id="Rf158f3a6603a46ba"/>
+    <p:sldId xmlns:r="http://schemas.openxmlformats.org/officeDocument/2006/relationships" id="259" r:id="Rcd026d3d4b01469f"/>
+    <p:sldId xmlns:r="http://schemas.openxmlformats.org/officeDocument/2006/relationships" id="260" r:id="R5e4d70e0746649a2"/>
+    <p:sldId xmlns:r="http://schemas.openxmlformats.org/officeDocument/2006/relationships" id="261" r:id="R688882ab16734417"/>
+    <p:sldId xmlns:r="http://schemas.openxmlformats.org/officeDocument/2006/relationships" id="262" r:id="R58e3d6344c0b45fb"/>
+    <p:sldId xmlns:r="http://schemas.openxmlformats.org/officeDocument/2006/relationships" id="263" r:id="R6721ca0fd92b456d"/>
+    <p:sldId xmlns:r="http://schemas.openxmlformats.org/officeDocument/2006/relationships" id="264" r:id="Rbd4f2bdc60814b51"/>
+    <p:sldId xmlns:r="http://schemas.openxmlformats.org/officeDocument/2006/relationships" id="265" r:id="R387f4e21c4d54215"/>
   </p:sldIdLst>
   <p:sldSz cx="12192000" cy="6858000"/>
   <p:notesSz cx="6858000" cy="9144000"/>
@@ -4489,7 +4489,7 @@
                 <a:ea typeface="Arial"/>
                 <a:cs typeface="Arial"/>
               </a:rPr>
-              <a:t>• Everything above the grey delivery rail sits inside LangGraph: research, extraction, the evidence gate, retry state and report routing.</a:t>
+              <a:t>• The blue outline is the LangGraph boundary.</a:t>
             </a:r>
             <a:endParaRPr sz="2000" b="0" u="none">
               <a:solidFill>
@@ -4529,7 +4529,7 @@
                 <a:ea typeface="Arial"/>
                 <a:cs typeface="Arial"/>
               </a:rPr>
-              <a:t>• LangGraph keeps the deterministic evidence gate inside that workflow loop.</a:t>
+              <a:t>• Inside it are research, extraction, the evidence gate, retry state and report routing.</a:t>
             </a:r>
             <a:endParaRPr sz="2000" b="0" u="none">
               <a:solidFill>
@@ -4569,7 +4569,7 @@
                 <a:ea typeface="Arial"/>
                 <a:cs typeface="Arial"/>
               </a:rPr>
-              <a:t>• If the evidence checks pass, supported facts and questions move to the report.</a:t>
+              <a:t>• LangGraph keeps the deterministic evidence gate inside that workflow loop.</a:t>
             </a:r>
             <a:endParaRPr sz="2000" b="0" u="none">
               <a:solidFill>
@@ -4617,7 +4617,7 @@
                 <a:ea typeface="Arial"/>
                 <a:cs typeface="Arial"/>
               </a:rPr>
-              <a:t>• If a check fails and retries remain, the workflow researches again.</a:t>
+              <a:t>• If the evidence checks pass, supported facts and questions move to the report.</a:t>
             </a:r>
             <a:endParaRPr sz="2000" b="0" u="none">
               <a:solidFill>
@@ -4668,7 +4668,7 @@
                 <a:ea typeface="Arial"/>
                 <a:cs typeface="Arial"/>
               </a:rPr>
-              <a:t>• If no retries remain, the claim becomes undetermined.</a:t>
+              <a:t>• If a check fails and retries remain, the workflow researches again.</a:t>
             </a:r>
             <a:endParaRPr sz="2000" b="0" u="none">
               <a:solidFill>
@@ -4722,7 +4722,7 @@
                 <a:ea typeface="Arial"/>
                 <a:cs typeface="Arial"/>
               </a:rPr>
-              <a:t>• Nothing is forced through.</a:t>
+              <a:t>• If no retries remain, the claim becomes undetermined.</a:t>
             </a:r>
             <a:endParaRPr sz="2000" b="0" u="none">
               <a:solidFill>
@@ -4776,7 +4776,61 @@
                 <a:ea typeface="Arial"/>
                 <a:cs typeface="Arial"/>
               </a:rPr>
-              <a:t>• The grey rail is separate: n8n only files the finished report in Notion.</a:t>
+              <a:t>• Nothing is forced through.</a:t>
+            </a:r>
+            <a:endParaRPr sz="2000" b="0" u="none">
+              <a:solidFill>
+                <a:srgbClr val="000000"/>
+              </a:solidFill>
+              <a:latin typeface="Arial"/>
+              <a:ea typeface="Arial"/>
+              <a:cs typeface="Arial"/>
+            </a:endParaRPr>
+          </a:p>
+          <a:p xmlns:a="http://schemas.openxmlformats.org/drawingml/2006/main">
+            <a:pPr indent="0" algn="l">
+              <a:lnSpc>
+                <a:spcPct val="100000"/>
+              </a:lnSpc>
+              <a:buNone/>
+            </a:pPr>
+            <a:r>
+              <a:rPr sz="2000" b="0" u="none">
+                <a:solidFill>
+                  <a:srgbClr val="000000"/>
+                </a:solidFill>
+                <a:latin typeface="Arial"/>
+                <a:ea typeface="Arial"/>
+                <a:cs typeface="Arial"/>
+              </a:rPr>
+              <a:t/>
+            </a:r>
+            <a:endParaRPr sz="2000" b="0" u="none">
+              <a:solidFill>
+                <a:srgbClr val="000000"/>
+              </a:solidFill>
+              <a:latin typeface="Arial"/>
+              <a:ea typeface="Arial"/>
+              <a:cs typeface="Arial"/>
+            </a:endParaRPr>
+          </a:p>
+          <a:p xmlns:a="http://schemas.openxmlformats.org/drawingml/2006/main">
+            <a:pPr indent="0" algn="l">
+              <a:lnSpc>
+                <a:spcPct val="100000"/>
+              </a:lnSpc>
+              <a:buNone/>
+            </a:pPr>
+            <a:r>
+              <a:rPr sz="2000" b="0" u="none">
+                <a:solidFill>
+                  <a:srgbClr val="000000"/>
+                </a:solidFill>
+                <a:latin typeface="Arial"/>
+                <a:ea typeface="Arial"/>
+                <a:cs typeface="Arial"/>
+              </a:rPr>
+              <a:t>• The grey rail sits outside LangGraph: n8n only files the finished report in Notion.</a:t>
             </a:r>
             <a:endParaRPr sz="2000" b="0" u="none">
               <a:solidFill>
@@ -7772,8 +7826,8 @@
   </p:cSld>
   <p:clrMap bg1="lt1" tx1="dk1" bg2="lt2" tx2="dk2" accent1="accent1" accent2="accent2" accent3="accent3" accent4="accent4" accent5="accent5" accent6="accent6" hlink="hlink" folHlink="folHlink"/>
   <p:sldLayoutIdLst>
-    <p:sldLayoutId xmlns:r="http://schemas.openxmlformats.org/officeDocument/2006/relationships" id="2147483649" r:id="Rbd58e1ae051846b3"/>
-    <p:sldLayoutId xmlns:r="http://schemas.openxmlformats.org/officeDocument/2006/relationships" id="2147483650" r:id="R24032771bf754a90"/>
+    <p:sldLayoutId xmlns:r="http://schemas.openxmlformats.org/officeDocument/2006/relationships" id="2147483649" r:id="R5deb8bfea42a4d48"/>
+    <p:sldLayoutId xmlns:r="http://schemas.openxmlformats.org/officeDocument/2006/relationships" id="2147483650" r:id="R81460e8185694269"/>
   </p:sldLayoutIdLst>
 </p:sldMaster>
 </file>
@@ -18358,8 +18412,8 @@
         </p:nvSpPr>
         <p:spPr>
           <a:xfrm xmlns:a="http://schemas.openxmlformats.org/drawingml/2006/main">
-            <a:off x="857250" y="384143"/>
-            <a:ext cx="2598706" cy="219266"/>
+            <a:off x="762000" y="1543050"/>
+            <a:ext cx="1952625" cy="219266"/>
           </a:xfrm>
           <a:prstGeom xmlns:a="http://schemas.openxmlformats.org/drawingml/2006/main" prst="rect">
             <a:avLst/>
@@ -18399,7 +18453,7 @@
                 <a:ea typeface="Aptos"/>
                 <a:cs typeface="Aptos"/>
               </a:rPr>
-              <a:t>LANGGRAPH WORKFLOW</a:t>
+              <a:t>INSIDE LANGGRAPH</a:t>
             </a:r>
             <a:endParaRPr sz="1100" b="0" u="none">
               <a:solidFill>
@@ -18653,9 +18707,9 @@
           <p:nvPr/>
         </p:nvSpPr>
         <p:spPr>
-          <a:xfrm xmlns:a="http://schemas.openxmlformats.org/drawingml/2006/main" flipH="1">
-            <a:off x="4187880" y="3675600"/>
-            <a:ext cx="3383280" cy="951120"/>
+          <a:xfrm xmlns:a="http://schemas.openxmlformats.org/drawingml/2006/main" flipH="1" flipV="1">
+            <a:off x="1657350" y="3419475"/>
+            <a:ext cx="5915025" cy="190500"/>
           </a:xfrm>
           <a:prstGeom xmlns:a="http://schemas.openxmlformats.org/drawingml/2006/main" prst="line">
             <a:avLst/>
@@ -19459,7 +19513,7 @@
         </p:style>
         <p:txBody>
           <a:bodyPr xmlns:a="http://schemas.openxmlformats.org/drawingml/2006/main" lIns="0" tIns="0" rIns="0" bIns="0" anchor="ctr">
-            <a:normAutofit/>
+            <a:normAutofit fontScale="100000"/>
           </a:bodyPr>
           <a:lstStyle xmlns:a="http://schemas.openxmlformats.org/drawingml/2006/main"/>
           <a:p xmlns:a="http://schemas.openxmlformats.org/drawingml/2006/main">
@@ -19481,7 +19535,7 @@
                 <a:ea typeface="Aptos"/>
                 <a:cs typeface="Aptos"/>
               </a:rPr>
-              <a:t>REPORT</a:t>
+              <a:t>PASS → REPORT</a:t>
             </a:r>
             <a:endParaRPr sz="1100" b="0" u="none">
               <a:solidFill>
@@ -19581,8 +19635,8 @@
         </p:nvSpPr>
         <p:spPr>
           <a:xfrm xmlns:a="http://schemas.openxmlformats.org/drawingml/2006/main">
-            <a:off x="4762500" y="3981450"/>
-            <a:ext cx="1714500" cy="219240"/>
+            <a:off x="4095750" y="3762375"/>
+            <a:ext cx="1809750" cy="219240"/>
           </a:xfrm>
           <a:prstGeom xmlns:a="http://schemas.openxmlformats.org/drawingml/2006/main" prst="rect">
             <a:avLst/>
@@ -19622,7 +19676,7 @@
                 <a:ea typeface="Aptos"/>
                 <a:cs typeface="Aptos"/>
               </a:rPr>
-              <a:t>RESEARCH AGAIN</a:t>
+              <a:t>RETRY → RESEARCH</a:t>
             </a:r>
             <a:endParaRPr sz="1000" b="0" u="none">
               <a:solidFill>
@@ -19834,7 +19888,7 @@
         <p:spPr>
           <a:xfrm xmlns:a="http://schemas.openxmlformats.org/drawingml/2006/main">
             <a:off x="1005840" y="5769720"/>
-            <a:ext cx="1261440" cy="200880"/>
+            <a:ext cx="1809750" cy="200880"/>
           </a:xfrm>
           <a:prstGeom xmlns:a="http://schemas.openxmlformats.org/drawingml/2006/main" prst="rect">
             <a:avLst/>
@@ -19852,7 +19906,7 @@
         </p:style>
         <p:txBody>
           <a:bodyPr xmlns:a="http://schemas.openxmlformats.org/drawingml/2006/main" lIns="0" tIns="0" rIns="0" bIns="0" anchor="ctr">
-            <a:normAutofit/>
+            <a:normAutofit fontScale="100000"/>
           </a:bodyPr>
           <a:lstStyle xmlns:a="http://schemas.openxmlformats.org/drawingml/2006/main"/>
           <a:p xmlns:a="http://schemas.openxmlformats.org/drawingml/2006/main">
@@ -19874,7 +19928,7 @@
                 <a:ea typeface="Aptos"/>
                 <a:cs typeface="Aptos"/>
               </a:rPr>
-              <a:t>DELIVERY ONLY</a:t>
+              <a:t>OUTSIDE LANGGRAPH</a:t>
             </a:r>
             <a:endParaRPr sz="1050" b="0" u="none">
               <a:solidFill>
@@ -19903,8 +19957,8 @@
         </p:nvSpPr>
         <p:spPr>
           <a:xfrm xmlns:a="http://schemas.openxmlformats.org/drawingml/2006/main">
-            <a:off x="2331720" y="5870160"/>
-            <a:ext cx="914400" cy="360"/>
+            <a:off x="2857500" y="5870160"/>
+            <a:ext cx="390525" cy="360"/>
           </a:xfrm>
           <a:prstGeom xmlns:a="http://schemas.openxmlformats.org/drawingml/2006/main" prst="line">
             <a:avLst/>
@@ -20348,6 +20402,39 @@
             </a:endParaRPr>
           </a:p>
         </p:txBody>
+      </p:sp>
+      <p:sp>
+        <p:nvSpPr>
+          <p:cNvPr id="165" name="LangGraph Boundary">
+            <a:extLst xmlns:a="http://schemas.openxmlformats.org/drawingml/2006/main">
+              <a:ext uri="{FF2B5EF4-FFF2-40B4-BE49-F238E27FC236}">
+                <a16:creationId xmlns:a16="http://schemas.microsoft.com/office/drawing/2014/main" id="{C26BA395-B948-4459-9BEB-80D326C885EE}"/>
+              </a:ext>
+            </a:extLst>
+          </p:cNvPr>
+          <p:cNvSpPr>
+            <a:spLocks xmlns:a="http://schemas.openxmlformats.org/drawingml/2006/main" noGrp="1"/>
+          </p:cNvSpPr>
+          <p:nvPr/>
+        </p:nvSpPr>
+        <p:spPr>
+          <a:xfrm xmlns:a="http://schemas.openxmlformats.org/drawingml/2006/main">
+            <a:off x="514350" y="1762125"/>
+            <a:ext cx="11163300" cy="3619500"/>
+          </a:xfrm>
+          <a:prstGeom xmlns:a="http://schemas.openxmlformats.org/drawingml/2006/main" prst="roundRect">
+            <a:avLst>
+              <a:gd name="adj" fmla="val 3158"/>
+            </a:avLst>
+          </a:prstGeom>
+          <a:noFill xmlns:a="http://schemas.openxmlformats.org/drawingml/2006/main"/>
+          <a:ln xmlns:a="http://schemas.openxmlformats.org/drawingml/2006/main" w="15240">
+            <a:solidFill>
+              <a:srgbClr val="93C5FD"/>
+            </a:solidFill>
+            <a:prstDash val="solid"/>
+          </a:ln>
+        </p:spPr>
       </p:sp>
     </p:spTree>
     <p:extLst>

</xml_diff>

<commit_message>
Align presentation with current demo
</commit_message>
<xml_diff>
--- a/docs/ai-pre-scan-presentation.pptx
+++ b/docs/ai-pre-scan-presentation.pptx
@@ -2,22 +2,22 @@
 <file path=ppt/presentation.xml><?xml version="1.0" encoding="utf-8"?>
 <p:presentation xmlns:p="http://schemas.openxmlformats.org/presentationml/2006/main">
   <p:sldMasterIdLst>
-    <p:sldMasterId xmlns:r="http://schemas.openxmlformats.org/officeDocument/2006/relationships" id="2147483648" r:id="R1e8dda934a2c4f45"/>
+    <p:sldMasterId xmlns:r="http://schemas.openxmlformats.org/officeDocument/2006/relationships" id="2147483648" r:id="R5fbb4cebdc574ad0"/>
   </p:sldMasterIdLst>
   <p:notesMasterIdLst>
-    <p:notesMasterId xmlns:r="http://schemas.openxmlformats.org/officeDocument/2006/relationships" r:id="R548e4a765b4d4190"/>
+    <p:notesMasterId xmlns:r="http://schemas.openxmlformats.org/officeDocument/2006/relationships" r:id="Rbff346cceb5349ff"/>
   </p:notesMasterIdLst>
   <p:sldIdLst>
-    <p:sldId xmlns:r="http://schemas.openxmlformats.org/officeDocument/2006/relationships" id="256" r:id="Rd624c8fcb45d4a21"/>
-    <p:sldId xmlns:r="http://schemas.openxmlformats.org/officeDocument/2006/relationships" id="257" r:id="R0d4d4488bb244fa5"/>
-    <p:sldId xmlns:r="http://schemas.openxmlformats.org/officeDocument/2006/relationships" id="258" r:id="Rf158f3a6603a46ba"/>
-    <p:sldId xmlns:r="http://schemas.openxmlformats.org/officeDocument/2006/relationships" id="259" r:id="Rcd026d3d4b01469f"/>
-    <p:sldId xmlns:r="http://schemas.openxmlformats.org/officeDocument/2006/relationships" id="260" r:id="R5e4d70e0746649a2"/>
-    <p:sldId xmlns:r="http://schemas.openxmlformats.org/officeDocument/2006/relationships" id="261" r:id="R688882ab16734417"/>
-    <p:sldId xmlns:r="http://schemas.openxmlformats.org/officeDocument/2006/relationships" id="262" r:id="R58e3d6344c0b45fb"/>
-    <p:sldId xmlns:r="http://schemas.openxmlformats.org/officeDocument/2006/relationships" id="263" r:id="R6721ca0fd92b456d"/>
-    <p:sldId xmlns:r="http://schemas.openxmlformats.org/officeDocument/2006/relationships" id="264" r:id="Rbd4f2bdc60814b51"/>
-    <p:sldId xmlns:r="http://schemas.openxmlformats.org/officeDocument/2006/relationships" id="265" r:id="R387f4e21c4d54215"/>
+    <p:sldId xmlns:r="http://schemas.openxmlformats.org/officeDocument/2006/relationships" id="256" r:id="Rf954f45e8b554cfc"/>
+    <p:sldId xmlns:r="http://schemas.openxmlformats.org/officeDocument/2006/relationships" id="257" r:id="Rf4cfd48ee289427a"/>
+    <p:sldId xmlns:r="http://schemas.openxmlformats.org/officeDocument/2006/relationships" id="258" r:id="R8958028d75164baa"/>
+    <p:sldId xmlns:r="http://schemas.openxmlformats.org/officeDocument/2006/relationships" id="259" r:id="Rbe63a422366e40e6"/>
+    <p:sldId xmlns:r="http://schemas.openxmlformats.org/officeDocument/2006/relationships" id="260" r:id="R82260448f068455d"/>
+    <p:sldId xmlns:r="http://schemas.openxmlformats.org/officeDocument/2006/relationships" id="261" r:id="R1686bbe0d4b341f5"/>
+    <p:sldId xmlns:r="http://schemas.openxmlformats.org/officeDocument/2006/relationships" id="262" r:id="R206a9ba4301a4645"/>
+    <p:sldId xmlns:r="http://schemas.openxmlformats.org/officeDocument/2006/relationships" id="263" r:id="R862e0c73d763409b"/>
+    <p:sldId xmlns:r="http://schemas.openxmlformats.org/officeDocument/2006/relationships" id="264" r:id="R6b3fd55b6e1b4c0b"/>
+    <p:sldId xmlns:r="http://schemas.openxmlformats.org/officeDocument/2006/relationships" id="265" r:id="R3438a2875f24455c"/>
   </p:sldIdLst>
   <p:sldSz cx="12192000" cy="6858000"/>
   <p:notesSz cx="6858000" cy="9144000"/>
@@ -378,43 +378,71 @@
               <a:t>• [Ask the room.] What AI does your company actually use?</a:t>
             </a:r>
           </a:p>
-          <a:p xmlns:a="http://schemas.openxmlformats.org/drawingml/2006/main"/>
+          <a:p xmlns:a="http://schemas.openxmlformats.org/drawingml/2006/main">
+            <a:r>
+              <a:t/>
+            </a:r>
+          </a:p>
           <a:p xmlns:a="http://schemas.openxmlformats.org/drawingml/2006/main">
             <a:r>
               <a:t>• Under the EU AI Act, every European SME will soon owe regulators that answer — in writing.</a:t>
             </a:r>
           </a:p>
-          <a:p xmlns:a="http://schemas.openxmlformats.org/drawingml/2006/main"/>
+          <a:p xmlns:a="http://schemas.openxmlformats.org/drawingml/2006/main">
+            <a:r>
+              <a:t/>
+            </a:r>
+          </a:p>
           <a:p xmlns:a="http://schemas.openxmlformats.org/drawingml/2006/main">
             <a:r>
               <a:t>• AI Pre-Scan drafts it from just a company name. Minutes, not weeks, from public evidence.</a:t>
             </a:r>
           </a:p>
-          <a:p xmlns:a="http://schemas.openxmlformats.org/drawingml/2006/main"/>
+          <a:p xmlns:a="http://schemas.openxmlformats.org/drawingml/2006/main">
+            <a:r>
+              <a:t/>
+            </a:r>
+          </a:p>
           <a:p xmlns:a="http://schemas.openxmlformats.org/drawingml/2006/main">
             <a:r>
               <a:t>• One rule makes it trustworthy: it would rather hand you a question than a false answer.</a:t>
             </a:r>
           </a:p>
-          <a:p xmlns:a="http://schemas.openxmlformats.org/drawingml/2006/main"/>
-          <a:p xmlns:a="http://schemas.openxmlformats.org/drawingml/2006/main">
-            <a:r>
-              <a:t>• [Point to the card.] One real scan. Top half: proven, and we can show the sentence that proves it. Bottom half: what no public page can settle — so it becomes a question, not a guess.</a:t>
-            </a:r>
-          </a:p>
-          <a:p xmlns:a="http://schemas.openxmlformats.org/drawingml/2006/main"/>
+          <a:p xmlns:a="http://schemas.openxmlformats.org/drawingml/2006/main">
+            <a:r>
+              <a:t/>
+            </a:r>
+          </a:p>
+          <a:p xmlns:a="http://schemas.openxmlformats.org/drawingml/2006/main">
+            <a:r>
+              <a:t>• [Point to the card.] One real scan. Top half: one of two evidenced systems, and we can show the sentence that proves it. Bottom half: the standing question public pages cannot settle — whether either system was renamed, repurposed or retrained.</a:t>
+            </a:r>
+          </a:p>
+          <a:p xmlns:a="http://schemas.openxmlformats.org/drawingml/2006/main">
+            <a:r>
+              <a:t/>
+            </a:r>
+          </a:p>
           <a:p xmlns:a="http://schemas.openxmlformats.org/drawingml/2006/main">
             <a:r>
               <a:t>• [Pause.]</a:t>
             </a:r>
           </a:p>
-          <a:p xmlns:a="http://schemas.openxmlformats.org/drawingml/2006/main"/>
+          <a:p xmlns:a="http://schemas.openxmlformats.org/drawingml/2006/main">
+            <a:r>
+              <a:t/>
+            </a:r>
+          </a:p>
           <a:p xmlns:a="http://schemas.openxmlformats.org/drawingml/2006/main">
             <a:r>
               <a:t>• The problem starts before any compliance form is opened.</a:t>
             </a:r>
           </a:p>
-          <a:p xmlns:a="http://schemas.openxmlformats.org/drawingml/2006/main"/>
+          <a:p xmlns:a="http://schemas.openxmlformats.org/drawingml/2006/main">
+            <a:r>
+              <a:t/>
+            </a:r>
+          </a:p>
           <a:p xmlns:a="http://schemas.openxmlformats.org/drawingml/2006/main">
             <a:r>
               <a:t>[If asked — HOW]</a:t>
@@ -427,10 +455,14 @@
           </a:p>
           <a:p xmlns:a="http://schemas.openxmlformats.org/drawingml/2006/main">
             <a:r>
-              <a:t>– How do you know that top half is proven?  Personio's own page says it, word for word — the scan keeps the sentence, the page and the fetch date.</a:t>
-            </a:r>
-          </a:p>
-          <a:p xmlns:a="http://schemas.openxmlformats.org/drawingml/2006/main"/>
+              <a:t>– How do you know that top half is proven?  Personio's own Assistant page says it, word for word — the scan keeps the sentence, the page and the fetch date.</a:t>
+            </a:r>
+          </a:p>
+          <a:p xmlns:a="http://schemas.openxmlformats.org/drawingml/2006/main">
+            <a:r>
+              <a:t/>
+            </a:r>
+          </a:p>
           <a:p xmlns:a="http://schemas.openxmlformats.org/drawingml/2006/main">
             <a:r>
               <a:t>[Sources]</a:t>
@@ -444,6 +476,11 @@
           <a:p xmlns:a="http://schemas.openxmlformats.org/drawingml/2006/main">
             <a:r>
               <a:t>- README.md</a:t>
+            </a:r>
+          </a:p>
+          <a:p xmlns:a="http://schemas.openxmlformats.org/drawingml/2006/main">
+            <a:r>
+              <a:t>- src/ai_prescan/fixtures.py</a:t>
             </a:r>
           </a:p>
           <a:p xmlns:a="http://schemas.openxmlformats.org/drawingml/2006/main">
@@ -526,55 +563,91 @@
               <a:t>• The MVP works end to end.</a:t>
             </a:r>
           </a:p>
-          <a:p xmlns:a="http://schemas.openxmlformats.org/drawingml/2006/main"/>
+          <a:p xmlns:a="http://schemas.openxmlformats.org/drawingml/2006/main">
+            <a:r>
+              <a:t/>
+            </a:r>
+          </a:p>
           <a:p xmlns:a="http://schemas.openxmlformats.org/drawingml/2006/main">
             <a:r>
               <a:t>• It runs in the browser or from the command line with a company-name trigger.</a:t>
             </a:r>
           </a:p>
-          <a:p xmlns:a="http://schemas.openxmlformats.org/drawingml/2006/main"/>
+          <a:p xmlns:a="http://schemas.openxmlformats.org/drawingml/2006/main">
+            <a:r>
+              <a:t/>
+            </a:r>
+          </a:p>
           <a:p xmlns:a="http://schemas.openxmlformats.org/drawingml/2006/main">
             <a:r>
               <a:t>• It finds evidence through Serper, NewsAPI, GLEIF and Wikidata.</a:t>
             </a:r>
           </a:p>
-          <a:p xmlns:a="http://schemas.openxmlformats.org/drawingml/2006/main"/>
+          <a:p xmlns:a="http://schemas.openxmlformats.org/drawingml/2006/main">
+            <a:r>
+              <a:t/>
+            </a:r>
+          </a:p>
           <a:p xmlns:a="http://schemas.openxmlformats.org/drawingml/2006/main">
             <a:r>
               <a:t>• OpenAI supports extraction, Pinecone stores evidence and the deterministic gate verifies each finding.</a:t>
             </a:r>
           </a:p>
-          <a:p xmlns:a="http://schemas.openxmlformats.org/drawingml/2006/main"/>
+          <a:p xmlns:a="http://schemas.openxmlformats.org/drawingml/2006/main">
+            <a:r>
+              <a:t/>
+            </a:r>
+          </a:p>
           <a:p xmlns:a="http://schemas.openxmlformats.org/drawingml/2006/main">
             <a:r>
               <a:t>• The output is a Markdown report; n8n can deliver it into Notion.</a:t>
             </a:r>
           </a:p>
-          <a:p xmlns:a="http://schemas.openxmlformats.org/drawingml/2006/main"/>
-          <a:p xmlns:a="http://schemas.openxmlformats.org/drawingml/2006/main">
-            <a:r>
-              <a:t>• The evidence base includes a twelve-company evaluation, two retained sample reports and 104 passing offline tests.</a:t>
-            </a:r>
-          </a:p>
-          <a:p xmlns:a="http://schemas.openxmlformats.org/drawingml/2006/main"/>
+          <a:p xmlns:a="http://schemas.openxmlformats.org/drawingml/2006/main">
+            <a:r>
+              <a:t/>
+            </a:r>
+          </a:p>
+          <a:p xmlns:a="http://schemas.openxmlformats.org/drawingml/2006/main">
+            <a:r>
+              <a:t>• The evidence base includes a twelve-company evaluation, two retained sample reports and 107 passing offline tests.</a:t>
+            </a:r>
+          </a:p>
+          <a:p xmlns:a="http://schemas.openxmlformats.org/drawingml/2006/main">
+            <a:r>
+              <a:t/>
+            </a:r>
+          </a:p>
           <a:p xmlns:a="http://schemas.openxmlformats.org/drawingml/2006/main">
             <a:r>
               <a:t>• The retained samples are generated artefacts—not hand-edited showcase copy.</a:t>
             </a:r>
           </a:p>
-          <a:p xmlns:a="http://schemas.openxmlformats.org/drawingml/2006/main"/>
+          <a:p xmlns:a="http://schemas.openxmlformats.org/drawingml/2006/main">
+            <a:r>
+              <a:t/>
+            </a:r>
+          </a:p>
           <a:p xmlns:a="http://schemas.openxmlformats.org/drawingml/2006/main">
             <a:r>
               <a:t>• [Pause.]</a:t>
             </a:r>
           </a:p>
-          <a:p xmlns:a="http://schemas.openxmlformats.org/drawingml/2006/main"/>
+          <a:p xmlns:a="http://schemas.openxmlformats.org/drawingml/2006/main">
+            <a:r>
+              <a:t/>
+            </a:r>
+          </a:p>
           <a:p xmlns:a="http://schemas.openxmlformats.org/drawingml/2006/main">
             <a:r>
               <a:t>• Scheduled sweeps and vendor-corpus ingestion are designed next steps, not part of the built MVP.</a:t>
             </a:r>
           </a:p>
-          <a:p xmlns:a="http://schemas.openxmlformats.org/drawingml/2006/main"/>
+          <a:p xmlns:a="http://schemas.openxmlformats.org/drawingml/2006/main">
+            <a:r>
+              <a:t/>
+            </a:r>
+          </a:p>
           <a:p xmlns:a="http://schemas.openxmlformats.org/drawingml/2006/main">
             <a:r>
               <a:t>[If asked — HOW]</a:t>
@@ -582,7 +655,7 @@
           </a:p>
           <a:p xmlns:a="http://schemas.openxmlformats.org/drawingml/2006/main">
             <a:r>
-              <a:t>– How is it tested?  104 offline tests, plus the twelve-company evaluation and the two retained sample reports.</a:t>
+              <a:t>– How is it tested?  107 offline tests, plus the twelve-company evaluation and the two retained sample reports.</a:t>
             </a:r>
           </a:p>
           <a:p xmlns:a="http://schemas.openxmlformats.org/drawingml/2006/main">
@@ -595,7 +668,11 @@
               <a:t>– What does a scan cost?  Not formally benchmarked. It is a small number of search and model calls per company — the checks themselves are free, they are code. Measuring cost per scan is part of pilot prep.</a:t>
             </a:r>
           </a:p>
-          <a:p xmlns:a="http://schemas.openxmlformats.org/drawingml/2006/main"/>
+          <a:p xmlns:a="http://schemas.openxmlformats.org/drawingml/2006/main">
+            <a:r>
+              <a:t/>
+            </a:r>
+          </a:p>
           <a:p xmlns:a="http://schemas.openxmlformats.org/drawingml/2006/main">
             <a:r>
               <a:t>[Sources]</a:t>
@@ -1002,85 +1079,141 @@
               <a:t>• [Enter Personio and press Scan.]</a:t>
             </a:r>
           </a:p>
-          <a:p xmlns:a="http://schemas.openxmlformats.org/drawingml/2006/main"/>
+          <a:p xmlns:a="http://schemas.openxmlformats.org/drawingml/2006/main">
+            <a:r>
+              <a:t/>
+            </a:r>
+          </a:p>
           <a:p xmlns:a="http://schemas.openxmlformats.org/drawingml/2006/main">
             <a:r>
               <a:t>• I start with nothing but a company name — and take my hands off the keyboard.</a:t>
             </a:r>
           </a:p>
-          <a:p xmlns:a="http://schemas.openxmlformats.org/drawingml/2006/main"/>
+          <a:p xmlns:a="http://schemas.openxmlformats.org/drawingml/2006/main">
+            <a:r>
+              <a:t/>
+            </a:r>
+          </a:p>
           <a:p xmlns:a="http://schemas.openxmlformats.org/drawingml/2006/main">
             <a:r>
               <a:t>• [If the workflow loops back to research, point to it.]</a:t>
             </a:r>
           </a:p>
-          <a:p xmlns:a="http://schemas.openxmlformats.org/drawingml/2006/main"/>
+          <a:p xmlns:a="http://schemas.openxmlformats.org/drawingml/2006/main">
+            <a:r>
+              <a:t/>
+            </a:r>
+          </a:p>
           <a:p xmlns:a="http://schemas.openxmlformats.org/drawingml/2006/main">
             <a:r>
               <a:t>• That loop-back is deliberate: the gate refused a claim, so the system went back for better evidence.</a:t>
             </a:r>
           </a:p>
-          <a:p xmlns:a="http://schemas.openxmlformats.org/drawingml/2006/main"/>
+          <a:p xmlns:a="http://schemas.openxmlformats.org/drawingml/2006/main">
+            <a:r>
+              <a:t/>
+            </a:r>
+          </a:p>
           <a:p xmlns:a="http://schemas.openxmlformats.org/drawingml/2006/main">
             <a:r>
               <a:t>• [Open the Personio result. Point to the highlighted quote.]</a:t>
             </a:r>
           </a:p>
-          <a:p xmlns:a="http://schemas.openxmlformats.org/drawingml/2006/main"/>
-          <a:p xmlns:a="http://schemas.openxmlformats.org/drawingml/2006/main">
-            <a:r>
-              <a:t>• Three possible systems: one proven, two undetermined.</a:t>
-            </a:r>
-          </a:p>
-          <a:p xmlns:a="http://schemas.openxmlformats.org/drawingml/2006/main"/>
-          <a:p xmlns:a="http://schemas.openxmlformats.org/drawingml/2006/main">
-            <a:r>
-              <a:t>• What makes the proven one proven is this exact sentence from Personio's own page — not the model's wording.</a:t>
-            </a:r>
-          </a:p>
-          <a:p xmlns:a="http://schemas.openxmlformats.org/drawingml/2006/main"/>
-          <a:p xmlns:a="http://schemas.openxmlformats.org/drawingml/2006/main">
-            <a:r>
-              <a:t>• The two unproven ones become questions for the client.</a:t>
-            </a:r>
-          </a:p>
-          <a:p xmlns:a="http://schemas.openxmlformats.org/drawingml/2006/main"/>
+          <a:p xmlns:a="http://schemas.openxmlformats.org/drawingml/2006/main">
+            <a:r>
+              <a:t/>
+            </a:r>
+          </a:p>
+          <a:p xmlns:a="http://schemas.openxmlformats.org/drawingml/2006/main">
+            <a:r>
+              <a:t>• Two possible systems: both proven, zero undetermined.</a:t>
+            </a:r>
+          </a:p>
+          <a:p xmlns:a="http://schemas.openxmlformats.org/drawingml/2006/main">
+            <a:r>
+              <a:t/>
+            </a:r>
+          </a:p>
+          <a:p xmlns:a="http://schemas.openxmlformats.org/drawingml/2006/main">
+            <a:r>
+              <a:t>• The card highlights Personio Assistant. What makes it proven is this exact sentence from Personio's own page — not the model's wording.</a:t>
+            </a:r>
+          </a:p>
+          <a:p xmlns:a="http://schemas.openxmlformats.org/drawingml/2006/main">
+            <a:r>
+              <a:t/>
+            </a:r>
+          </a:p>
+          <a:p xmlns:a="http://schemas.openxmlformats.org/drawingml/2006/main">
+            <a:r>
+              <a:t>• One question still goes to the client: was either tool renamed, repurposed, configured or retrained? Public evidence cannot settle that.</a:t>
+            </a:r>
+          </a:p>
+          <a:p xmlns:a="http://schemas.openxmlformats.org/drawingml/2006/main">
+            <a:r>
+              <a:t/>
+            </a:r>
+          </a:p>
           <a:p xmlns:a="http://schemas.openxmlformats.org/drawingml/2006/main">
             <a:r>
               <a:t>• [Switch to Ballymaloe Foods.]</a:t>
             </a:r>
           </a:p>
-          <a:p xmlns:a="http://schemas.openxmlformats.org/drawingml/2006/main"/>
+          <a:p xmlns:a="http://schemas.openxmlformats.org/drawingml/2006/main">
+            <a:r>
+              <a:t/>
+            </a:r>
+          </a:p>
           <a:p xmlns:a="http://schemas.openxmlformats.org/drawingml/2006/main">
             <a:r>
               <a:t>• Here the scan found nothing public — so it claimed nothing, and produced one question.</a:t>
             </a:r>
           </a:p>
-          <a:p xmlns:a="http://schemas.openxmlformats.org/drawingml/2006/main"/>
+          <a:p xmlns:a="http://schemas.openxmlformats.org/drawingml/2006/main">
+            <a:r>
+              <a:t/>
+            </a:r>
+          </a:p>
           <a:p xmlns:a="http://schemas.openxmlformats.org/drawingml/2006/main">
             <a:r>
               <a:t>• No public evidence is not the same as no AI use. It means an outside scan cannot make that claim.</a:t>
             </a:r>
           </a:p>
-          <a:p xmlns:a="http://schemas.openxmlformats.org/drawingml/2006/main"/>
+          <a:p xmlns:a="http://schemas.openxmlformats.org/drawingml/2006/main">
+            <a:r>
+              <a:t/>
+            </a:r>
+          </a:p>
           <a:p xmlns:a="http://schemas.openxmlformats.org/drawingml/2006/main">
             <a:r>
               <a:t>• [If the live run fails, open the retained samples — same pipeline, output unedited.]</a:t>
             </a:r>
           </a:p>
-          <a:p xmlns:a="http://schemas.openxmlformats.org/drawingml/2006/main"/>
+          <a:p xmlns:a="http://schemas.openxmlformats.org/drawingml/2006/main">
+            <a:r>
+              <a:t/>
+            </a:r>
+          </a:p>
           <a:p xmlns:a="http://schemas.openxmlformats.org/drawingml/2006/main">
             <a:r>
               <a:t>• [Pause.]</a:t>
             </a:r>
           </a:p>
-          <a:p xmlns:a="http://schemas.openxmlformats.org/drawingml/2006/main"/>
+          <a:p xmlns:a="http://schemas.openxmlformats.org/drawingml/2006/main">
+            <a:r>
+              <a:t/>
+            </a:r>
+          </a:p>
           <a:p xmlns:a="http://schemas.openxmlformats.org/drawingml/2006/main">
             <a:r>
               <a:t>• Two companies, two honest results. That honesty is enforced — next slide.</a:t>
             </a:r>
           </a:p>
-          <a:p xmlns:a="http://schemas.openxmlformats.org/drawingml/2006/main"/>
+          <a:p xmlns:a="http://schemas.openxmlformats.org/drawingml/2006/main">
+            <a:r>
+              <a:t/>
+            </a:r>
+          </a:p>
           <a:p xmlns:a="http://schemas.openxmlformats.org/drawingml/2006/main">
             <a:r>
               <a:t>[If asked — HOW]</a:t>
@@ -1101,7 +1234,11 @@
               <a:t>– What if the page changes after the scan?  The stored hash no longer matches — a silently edited page is detectable, not invisible.</a:t>
             </a:r>
           </a:p>
-          <a:p xmlns:a="http://schemas.openxmlformats.org/drawingml/2006/main"/>
+          <a:p xmlns:a="http://schemas.openxmlformats.org/drawingml/2006/main">
+            <a:r>
+              <a:t/>
+            </a:r>
+          </a:p>
           <a:p xmlns:a="http://schemas.openxmlformats.org/drawingml/2006/main">
             <a:r>
               <a:t>[Sources]</a:t>
@@ -1109,7 +1246,7 @@
           </a:p>
           <a:p xmlns:a="http://schemas.openxmlformats.org/drawingml/2006/main">
             <a:r>
-              <a:t>- samples/personio.md</a:t>
+              <a:t>- src/ai_prescan/fixtures.py</a:t>
             </a:r>
           </a:p>
           <a:p xmlns:a="http://schemas.openxmlformats.org/drawingml/2006/main">
@@ -2633,8 +2770,8 @@
   </p:cSld>
   <p:clrMap bg1="lt1" tx1="dk1" bg2="lt2" tx2="dk2" accent1="accent1" accent2="accent2" accent3="accent3" accent4="accent4" accent5="accent5" accent6="accent6" hlink="hlink" folHlink="folHlink"/>
   <p:sldLayoutIdLst>
-    <p:sldLayoutId xmlns:r="http://schemas.openxmlformats.org/officeDocument/2006/relationships" id="2147483649" r:id="R5deb8bfea42a4d48"/>
-    <p:sldLayoutId xmlns:r="http://schemas.openxmlformats.org/officeDocument/2006/relationships" id="2147483650" r:id="R81460e8185694269"/>
+    <p:sldLayoutId xmlns:r="http://schemas.openxmlformats.org/officeDocument/2006/relationships" id="2147483649" r:id="R4e4e39095a194e1c"/>
+    <p:sldLayoutId xmlns:r="http://schemas.openxmlformats.org/officeDocument/2006/relationships" id="2147483650" r:id="R283891e31d444636"/>
   </p:sldLayoutIdLst>
 </p:sldMaster>
 </file>
@@ -3279,7 +3416,7 @@
         </p:style>
         <p:txBody>
           <a:bodyPr xmlns:a="http://schemas.openxmlformats.org/drawingml/2006/main" lIns="0" tIns="0" rIns="0" bIns="0" anchor="ctr">
-            <a:normAutofit fontScale="92500" lnSpcReduction="9999"/>
+            <a:normAutofit fontScale="90000" lnSpcReduction="9999"/>
           </a:bodyPr>
           <a:lstStyle xmlns:a="http://schemas.openxmlformats.org/drawingml/2006/main"/>
           <a:p xmlns:a="http://schemas.openxmlformats.org/drawingml/2006/main">
@@ -3301,7 +3438,7 @@
                 <a:ea typeface="Aptos Display"/>
                 <a:cs typeface="Aptos Display"/>
               </a:rPr>
-              <a:t>Ships its own AI that summarises employee performance reviews</a:t>
+              <a:t>Offers its own AI assistant for HR questions and workforce insights</a:t>
             </a:r>
             <a:endParaRPr sz="2200" b="0" u="none">
               <a:solidFill>
@@ -3470,7 +3607,7 @@
         </p:style>
         <p:txBody>
           <a:bodyPr xmlns:a="http://schemas.openxmlformats.org/drawingml/2006/main" lIns="0" tIns="0" rIns="0" bIns="0" anchor="t">
-            <a:normAutofit fontScale="85000" lnSpcReduction="19999"/>
+            <a:normAutofit fontScale="90000" lnSpcReduction="19999"/>
           </a:bodyPr>
           <a:lstStyle xmlns:a="http://schemas.openxmlformats.org/drawingml/2006/main"/>
           <a:p xmlns:a="http://schemas.openxmlformats.org/drawingml/2006/main">
@@ -3492,7 +3629,7 @@
                 <a:ea typeface="Aptos Display"/>
                 <a:cs typeface="Aptos Display"/>
               </a:rPr>
-              <a:t>Do their customers have it switched on — and since when?</a:t>
+              <a:t>Has either system been renamed, repurposed or retrained?</a:t>
             </a:r>
             <a:endParaRPr sz="2200" b="0" u="none">
               <a:solidFill>
@@ -3544,7 +3681,7 @@
         </p:style>
         <p:txBody>
           <a:bodyPr xmlns:a="http://schemas.openxmlformats.org/drawingml/2006/main" lIns="360" tIns="360" rIns="360" bIns="360" anchor="ctr">
-            <a:normAutofit/>
+            <a:normAutofit fontScale="100000"/>
           </a:bodyPr>
           <a:lstStyle xmlns:a="http://schemas.openxmlformats.org/drawingml/2006/main"/>
           <a:p xmlns:a="http://schemas.openxmlformats.org/drawingml/2006/main">
@@ -3566,7 +3703,7 @@
                 <a:ea typeface="Aptos"/>
                 <a:cs typeface="Aptos"/>
               </a:rPr>
-              <a:t>UNDETERMINED</a:t>
+              <a:t>ASK CLIENT</a:t>
             </a:r>
             <a:endParaRPr sz="1000" b="0" u="none">
               <a:solidFill>
@@ -5631,7 +5768,7 @@
         </p:style>
         <p:txBody>
           <a:bodyPr xmlns:a="http://schemas.openxmlformats.org/drawingml/2006/main" lIns="0" tIns="0" rIns="0" bIns="0" anchor="ctr">
-            <a:normAutofit/>
+            <a:normAutofit fontScale="100000"/>
           </a:bodyPr>
           <a:lstStyle xmlns:a="http://schemas.openxmlformats.org/drawingml/2006/main"/>
           <a:p xmlns:a="http://schemas.openxmlformats.org/drawingml/2006/main">
@@ -5653,7 +5790,7 @@
                 <a:ea typeface="Aptos"/>
                 <a:cs typeface="Aptos"/>
               </a:rPr>
-              <a:t>104 offline tests</a:t>
+              <a:t>107 offline tests</a:t>
             </a:r>
             <a:endParaRPr sz="1350" b="0" u="none">
               <a:solidFill>
@@ -9807,7 +9944,7 @@
                 <a:ea typeface="Aptos"/>
                 <a:cs typeface="Aptos"/>
               </a:rPr>
-              <a:t>3 possible systems  •  1 proven  •  2 undetermined</a:t>
+              <a:t>2 possible systems  •  2 proven  •  0 undetermined</a:t>
             </a:r>
             <a:endParaRPr sz="1400" b="0" u="none">
               <a:solidFill>
@@ -10003,7 +10140,7 @@
                 <a:ea typeface="Aptos"/>
                 <a:cs typeface="Aptos"/>
               </a:rPr>
-              <a:t>“AI Performance Summaries provide an AI-generated summary of all continuous feedback, manager, peer, and upward reviews…”</a:t>
+              <a:t>“Turn complex HR data into confident decisions. Ask Personio Assistant any question and get AI-powered insights in seconds…”</a:t>
             </a:r>
             <a:endParaRPr sz="1650" b="0" u="none">
               <a:solidFill>
@@ -10073,7 +10210,7 @@
                 <a:ea typeface="Aptos"/>
                 <a:cs typeface="Aptos"/>
               </a:rPr>
-              <a:t>Question to verify: Is this in use today, and since when?</a:t>
+              <a:t>Question: Was either tool renamed, repurposed or retrained?</a:t>
             </a:r>
             <a:endParaRPr sz="1500" b="0" u="none">
               <a:solidFill>
@@ -15320,7 +15457,7 @@
         </p:nvSpPr>
         <p:spPr>
           <a:xfrm xmlns:a="http://schemas.openxmlformats.org/drawingml/2006/main">
-            <a:off x="749880" y="1508760"/>
+            <a:off x="749880" y="1833563"/>
             <a:ext cx="5486400" cy="228240"/>
           </a:xfrm>
           <a:prstGeom xmlns:a="http://schemas.openxmlformats.org/drawingml/2006/main" prst="rect">
@@ -17909,7 +18046,7 @@
           </a:bodyPr>
           <a:lstStyle xmlns:a="http://schemas.openxmlformats.org/drawingml/2006/main"/>
           <a:p xmlns:a="http://schemas.openxmlformats.org/drawingml/2006/main">
-            <a:pPr defTabSz="914400" algn="r">
+            <a:pPr algn="r" defTabSz="914400">
               <a:lnSpc>
                 <a:spcPct val="100000"/>
               </a:lnSpc>
@@ -18175,7 +18312,7 @@
           </a:bodyPr>
           <a:lstStyle xmlns:a="http://schemas.openxmlformats.org/drawingml/2006/main"/>
           <a:p xmlns:a="http://schemas.openxmlformats.org/drawingml/2006/main">
-            <a:pPr defTabSz="914400" algn="r">
+            <a:pPr algn="r" defTabSz="914400">
               <a:lnSpc>
                 <a:spcPct val="100000"/>
               </a:lnSpc>
@@ -18441,7 +18578,7 @@
           </a:bodyPr>
           <a:lstStyle xmlns:a="http://schemas.openxmlformats.org/drawingml/2006/main"/>
           <a:p xmlns:a="http://schemas.openxmlformats.org/drawingml/2006/main">
-            <a:pPr defTabSz="914400" algn="r">
+            <a:pPr algn="r" defTabSz="914400">
               <a:lnSpc>
                 <a:spcPct val="100000"/>
               </a:lnSpc>
@@ -19116,7 +19253,7 @@
           </a:bodyPr>
           <a:lstStyle xmlns:a="http://schemas.openxmlformats.org/drawingml/2006/main"/>
           <a:p xmlns:a="http://schemas.openxmlformats.org/drawingml/2006/main">
-            <a:pPr defTabSz="914400" algn="l">
+            <a:pPr algn="l" defTabSz="914400">
               <a:lnSpc>
                 <a:spcPct val="100000"/>
               </a:lnSpc>
@@ -19147,411 +19284,492 @@
           </a:p>
         </p:txBody>
       </p:sp>
-      <p:sp xmlns:a="http://schemas.openxmlformats.org/drawingml/2006/main">
-        <p:nvSpPr>
-          <p:cNvPr id="778" name="Rounded Rectangle 777"/>
-          <p:cNvSpPr/>
-          <p:nvPr/>
-        </p:nvSpPr>
-        <p:spPr>
-          <a:xfrm>
+      <p:sp>
+        <p:nvSpPr>
+          <p:cNvPr id="778" name="Rounded Rectangle 777">
+            <a:extLst xmlns:a="http://schemas.openxmlformats.org/drawingml/2006/main">
+              <a:ext uri="{FF2B5EF4-FFF2-40B4-BE49-F238E27FC236}">
+                <a16:creationId xmlns:a16="http://schemas.microsoft.com/office/drawing/2014/main" id="{3FF65F1F-F246-4C7E-9DB8-AB9501227147}"/>
+              </a:ext>
+            </a:extLst>
+          </p:cNvPr>
+          <p:cNvSpPr>
+            <a:spLocks xmlns:a="http://schemas.openxmlformats.org/drawingml/2006/main" noGrp="1"/>
+          </p:cNvSpPr>
+          <p:nvPr/>
+        </p:nvSpPr>
+        <p:spPr>
+          <a:xfrm xmlns:a="http://schemas.openxmlformats.org/drawingml/2006/main">
             <a:off x="6647688" y="2706624"/>
             <a:ext cx="4535424" cy="128016"/>
           </a:xfrm>
-          <a:prstGeom prst="roundRect">
+          <a:prstGeom xmlns:a="http://schemas.openxmlformats.org/drawingml/2006/main" prst="roundRect">
             <a:avLst>
               <a:gd name="adj" fmla="val 50000"/>
             </a:avLst>
           </a:prstGeom>
-          <a:solidFill>
+          <a:solidFill xmlns:a="http://schemas.openxmlformats.org/drawingml/2006/main">
             <a:srgbClr val="F3D9B5"/>
           </a:solidFill>
-          <a:ln>
+          <a:ln xmlns:a="http://schemas.openxmlformats.org/drawingml/2006/main">
             <a:noFill/>
           </a:ln>
-          <a:effectLst/>
-        </p:spPr>
-        <p:style>
-          <a:lnRef idx="1">
+        </p:spPr>
+        <p:style>
+          <a:lnRef xmlns:a="http://schemas.openxmlformats.org/drawingml/2006/main" idx="1">
             <a:schemeClr val="accent1"/>
           </a:lnRef>
-          <a:fillRef idx="3">
+          <a:fillRef xmlns:a="http://schemas.openxmlformats.org/drawingml/2006/main" idx="3">
             <a:schemeClr val="accent1"/>
           </a:fillRef>
-          <a:effectRef idx="2">
+          <a:effectRef xmlns:a="http://schemas.openxmlformats.org/drawingml/2006/main" idx="2">
             <a:schemeClr val="accent1"/>
           </a:effectRef>
-          <a:fontRef idx="minor">
+          <a:fontRef xmlns:a="http://schemas.openxmlformats.org/drawingml/2006/main" idx="minor">
             <a:schemeClr val="lt1"/>
           </a:fontRef>
         </p:style>
         <p:txBody>
-          <a:bodyPr rtlCol="0" anchor="ctr"/>
-          <a:lstStyle/>
-          <a:p>
-            <a:pPr algn="ctr"/>
-          </a:p>
-        </p:txBody>
-      </p:sp>
-      <p:sp xmlns:a="http://schemas.openxmlformats.org/drawingml/2006/main">
-        <p:nvSpPr>
-          <p:cNvPr id="779" name="Rounded Rectangle 778"/>
-          <p:cNvSpPr/>
-          <p:nvPr/>
-        </p:nvSpPr>
-        <p:spPr>
-          <a:xfrm>
+          <a:bodyPr xmlns:a="http://schemas.openxmlformats.org/drawingml/2006/main" anchor="ctr"/>
+          <a:lstStyle xmlns:a="http://schemas.openxmlformats.org/drawingml/2006/main"/>
+          <a:p xmlns:a="http://schemas.openxmlformats.org/drawingml/2006/main">
+            <a:pPr algn="ctr">
+              <a:buNone/>
+            </a:pPr>
+          </a:p>
+        </p:txBody>
+      </p:sp>
+      <p:sp>
+        <p:nvSpPr>
+          <p:cNvPr id="779" name="Rounded Rectangle 778">
+            <a:extLst xmlns:a="http://schemas.openxmlformats.org/drawingml/2006/main">
+              <a:ext uri="{FF2B5EF4-FFF2-40B4-BE49-F238E27FC236}">
+                <a16:creationId xmlns:a16="http://schemas.microsoft.com/office/drawing/2014/main" id="{8D1B59A7-AE1A-4296-B29B-11851FD43371}"/>
+              </a:ext>
+            </a:extLst>
+          </p:cNvPr>
+          <p:cNvSpPr>
+            <a:spLocks xmlns:a="http://schemas.openxmlformats.org/drawingml/2006/main" noGrp="1"/>
+          </p:cNvSpPr>
+          <p:nvPr/>
+        </p:nvSpPr>
+        <p:spPr>
+          <a:xfrm xmlns:a="http://schemas.openxmlformats.org/drawingml/2006/main">
             <a:off x="6647688" y="2706624"/>
             <a:ext cx="2013728" cy="128016"/>
           </a:xfrm>
-          <a:prstGeom prst="roundRect">
+          <a:prstGeom xmlns:a="http://schemas.openxmlformats.org/drawingml/2006/main" prst="roundRect">
             <a:avLst>
               <a:gd name="adj" fmla="val 50000"/>
             </a:avLst>
           </a:prstGeom>
-          <a:solidFill>
+          <a:solidFill xmlns:a="http://schemas.openxmlformats.org/drawingml/2006/main">
             <a:srgbClr val="B45309"/>
           </a:solidFill>
-          <a:ln>
+          <a:ln xmlns:a="http://schemas.openxmlformats.org/drawingml/2006/main">
             <a:noFill/>
           </a:ln>
-          <a:effectLst/>
-        </p:spPr>
-        <p:style>
-          <a:lnRef idx="1">
+        </p:spPr>
+        <p:style>
+          <a:lnRef xmlns:a="http://schemas.openxmlformats.org/drawingml/2006/main" idx="1">
             <a:schemeClr val="accent1"/>
           </a:lnRef>
-          <a:fillRef idx="3">
+          <a:fillRef xmlns:a="http://schemas.openxmlformats.org/drawingml/2006/main" idx="3">
             <a:schemeClr val="accent1"/>
           </a:fillRef>
-          <a:effectRef idx="2">
+          <a:effectRef xmlns:a="http://schemas.openxmlformats.org/drawingml/2006/main" idx="2">
             <a:schemeClr val="accent1"/>
           </a:effectRef>
-          <a:fontRef idx="minor">
+          <a:fontRef xmlns:a="http://schemas.openxmlformats.org/drawingml/2006/main" idx="minor">
             <a:schemeClr val="lt1"/>
           </a:fontRef>
         </p:style>
         <p:txBody>
-          <a:bodyPr rtlCol="0" anchor="ctr"/>
-          <a:lstStyle/>
-          <a:p>
-            <a:pPr algn="ctr"/>
-          </a:p>
-        </p:txBody>
-      </p:sp>
-      <p:sp xmlns:a="http://schemas.openxmlformats.org/drawingml/2006/main">
-        <p:nvSpPr>
-          <p:cNvPr id="780" name="Rectangle 779"/>
-          <p:cNvSpPr/>
-          <p:nvPr/>
-        </p:nvSpPr>
-        <p:spPr>
-          <a:xfrm>
+          <a:bodyPr xmlns:a="http://schemas.openxmlformats.org/drawingml/2006/main" anchor="ctr"/>
+          <a:lstStyle xmlns:a="http://schemas.openxmlformats.org/drawingml/2006/main"/>
+          <a:p xmlns:a="http://schemas.openxmlformats.org/drawingml/2006/main">
+            <a:pPr algn="ctr">
+              <a:buNone/>
+            </a:pPr>
+          </a:p>
+        </p:txBody>
+      </p:sp>
+      <p:sp>
+        <p:nvSpPr>
+          <p:cNvPr id="780" name="Rectangle 779">
+            <a:extLst xmlns:a="http://schemas.openxmlformats.org/drawingml/2006/main">
+              <a:ext uri="{FF2B5EF4-FFF2-40B4-BE49-F238E27FC236}">
+                <a16:creationId xmlns:a16="http://schemas.microsoft.com/office/drawing/2014/main" id="{12ECBF05-95A9-46DA-8C70-CFE185A7EDC8}"/>
+              </a:ext>
+            </a:extLst>
+          </p:cNvPr>
+          <p:cNvSpPr>
+            <a:spLocks xmlns:a="http://schemas.openxmlformats.org/drawingml/2006/main" noGrp="1"/>
+          </p:cNvSpPr>
+          <p:nvPr/>
+        </p:nvSpPr>
+        <p:spPr>
+          <a:xfrm xmlns:a="http://schemas.openxmlformats.org/drawingml/2006/main">
             <a:off x="10035539" y="2642616"/>
             <a:ext cx="27432" cy="256032"/>
           </a:xfrm>
-          <a:prstGeom prst="rect">
-            <a:avLst/>
-          </a:prstGeom>
-          <a:solidFill>
+          <a:prstGeom xmlns:a="http://schemas.openxmlformats.org/drawingml/2006/main" prst="rect">
+            <a:avLst/>
+          </a:prstGeom>
+          <a:solidFill xmlns:a="http://schemas.openxmlformats.org/drawingml/2006/main">
             <a:srgbClr val="0B1020"/>
           </a:solidFill>
-          <a:ln>
+          <a:ln xmlns:a="http://schemas.openxmlformats.org/drawingml/2006/main">
             <a:noFill/>
           </a:ln>
-          <a:effectLst/>
-        </p:spPr>
-        <p:style>
-          <a:lnRef idx="1">
+        </p:spPr>
+        <p:style>
+          <a:lnRef xmlns:a="http://schemas.openxmlformats.org/drawingml/2006/main" idx="1">
             <a:schemeClr val="accent1"/>
           </a:lnRef>
-          <a:fillRef idx="3">
+          <a:fillRef xmlns:a="http://schemas.openxmlformats.org/drawingml/2006/main" idx="3">
             <a:schemeClr val="accent1"/>
           </a:fillRef>
-          <a:effectRef idx="2">
+          <a:effectRef xmlns:a="http://schemas.openxmlformats.org/drawingml/2006/main" idx="2">
             <a:schemeClr val="accent1"/>
           </a:effectRef>
-          <a:fontRef idx="minor">
+          <a:fontRef xmlns:a="http://schemas.openxmlformats.org/drawingml/2006/main" idx="minor">
             <a:schemeClr val="lt1"/>
           </a:fontRef>
         </p:style>
         <p:txBody>
-          <a:bodyPr rtlCol="0" anchor="ctr"/>
-          <a:lstStyle/>
-          <a:p>
-            <a:pPr algn="ctr"/>
-          </a:p>
-        </p:txBody>
-      </p:sp>
-      <p:sp xmlns:a="http://schemas.openxmlformats.org/drawingml/2006/main">
-        <p:nvSpPr>
-          <p:cNvPr id="781" name="Rounded Rectangle 780"/>
-          <p:cNvSpPr/>
-          <p:nvPr/>
-        </p:nvSpPr>
-        <p:spPr>
-          <a:xfrm>
+          <a:bodyPr xmlns:a="http://schemas.openxmlformats.org/drawingml/2006/main" anchor="ctr"/>
+          <a:lstStyle xmlns:a="http://schemas.openxmlformats.org/drawingml/2006/main"/>
+          <a:p xmlns:a="http://schemas.openxmlformats.org/drawingml/2006/main">
+            <a:pPr algn="ctr">
+              <a:buNone/>
+            </a:pPr>
+          </a:p>
+        </p:txBody>
+      </p:sp>
+      <p:sp>
+        <p:nvSpPr>
+          <p:cNvPr id="781" name="Rounded Rectangle 780">
+            <a:extLst xmlns:a="http://schemas.openxmlformats.org/drawingml/2006/main">
+              <a:ext uri="{FF2B5EF4-FFF2-40B4-BE49-F238E27FC236}">
+                <a16:creationId xmlns:a16="http://schemas.microsoft.com/office/drawing/2014/main" id="{3D7251BA-EC82-4B04-8C05-6193DE487152}"/>
+              </a:ext>
+            </a:extLst>
+          </p:cNvPr>
+          <p:cNvSpPr>
+            <a:spLocks xmlns:a="http://schemas.openxmlformats.org/drawingml/2006/main" noGrp="1"/>
+          </p:cNvSpPr>
+          <p:nvPr/>
+        </p:nvSpPr>
+        <p:spPr>
+          <a:xfrm xmlns:a="http://schemas.openxmlformats.org/drawingml/2006/main">
             <a:off x="6647688" y="3712464"/>
             <a:ext cx="4535424" cy="128016"/>
           </a:xfrm>
-          <a:prstGeom prst="roundRect">
+          <a:prstGeom xmlns:a="http://schemas.openxmlformats.org/drawingml/2006/main" prst="roundRect">
             <a:avLst>
               <a:gd name="adj" fmla="val 50000"/>
             </a:avLst>
           </a:prstGeom>
-          <a:solidFill>
+          <a:solidFill xmlns:a="http://schemas.openxmlformats.org/drawingml/2006/main">
             <a:srgbClr val="F3D9B5"/>
           </a:solidFill>
-          <a:ln>
+          <a:ln xmlns:a="http://schemas.openxmlformats.org/drawingml/2006/main">
             <a:noFill/>
           </a:ln>
-          <a:effectLst/>
-        </p:spPr>
-        <p:style>
-          <a:lnRef idx="1">
+        </p:spPr>
+        <p:style>
+          <a:lnRef xmlns:a="http://schemas.openxmlformats.org/drawingml/2006/main" idx="1">
             <a:schemeClr val="accent1"/>
           </a:lnRef>
-          <a:fillRef idx="3">
+          <a:fillRef xmlns:a="http://schemas.openxmlformats.org/drawingml/2006/main" idx="3">
             <a:schemeClr val="accent1"/>
           </a:fillRef>
-          <a:effectRef idx="2">
+          <a:effectRef xmlns:a="http://schemas.openxmlformats.org/drawingml/2006/main" idx="2">
             <a:schemeClr val="accent1"/>
           </a:effectRef>
-          <a:fontRef idx="minor">
+          <a:fontRef xmlns:a="http://schemas.openxmlformats.org/drawingml/2006/main" idx="minor">
             <a:schemeClr val="lt1"/>
           </a:fontRef>
         </p:style>
         <p:txBody>
-          <a:bodyPr rtlCol="0" anchor="ctr"/>
-          <a:lstStyle/>
-          <a:p>
-            <a:pPr algn="ctr"/>
-          </a:p>
-        </p:txBody>
-      </p:sp>
-      <p:sp xmlns:a="http://schemas.openxmlformats.org/drawingml/2006/main">
-        <p:nvSpPr>
-          <p:cNvPr id="782" name="Rounded Rectangle 781"/>
-          <p:cNvSpPr/>
-          <p:nvPr/>
-        </p:nvSpPr>
-        <p:spPr>
-          <a:xfrm>
+          <a:bodyPr xmlns:a="http://schemas.openxmlformats.org/drawingml/2006/main" anchor="ctr"/>
+          <a:lstStyle xmlns:a="http://schemas.openxmlformats.org/drawingml/2006/main"/>
+          <a:p xmlns:a="http://schemas.openxmlformats.org/drawingml/2006/main">
+            <a:pPr algn="ctr">
+              <a:buNone/>
+            </a:pPr>
+          </a:p>
+        </p:txBody>
+      </p:sp>
+      <p:sp>
+        <p:nvSpPr>
+          <p:cNvPr id="782" name="Rounded Rectangle 781">
+            <a:extLst xmlns:a="http://schemas.openxmlformats.org/drawingml/2006/main">
+              <a:ext uri="{FF2B5EF4-FFF2-40B4-BE49-F238E27FC236}">
+                <a16:creationId xmlns:a16="http://schemas.microsoft.com/office/drawing/2014/main" id="{C3A69D42-4797-4EEC-A72C-98DABDF5A243}"/>
+              </a:ext>
+            </a:extLst>
+          </p:cNvPr>
+          <p:cNvSpPr>
+            <a:spLocks xmlns:a="http://schemas.openxmlformats.org/drawingml/2006/main" noGrp="1"/>
+          </p:cNvSpPr>
+          <p:nvPr/>
+        </p:nvSpPr>
+        <p:spPr>
+          <a:xfrm xmlns:a="http://schemas.openxmlformats.org/drawingml/2006/main">
             <a:off x="6647688" y="3712464"/>
             <a:ext cx="3351678" cy="128016"/>
           </a:xfrm>
-          <a:prstGeom prst="roundRect">
+          <a:prstGeom xmlns:a="http://schemas.openxmlformats.org/drawingml/2006/main" prst="roundRect">
             <a:avLst>
               <a:gd name="adj" fmla="val 50000"/>
             </a:avLst>
           </a:prstGeom>
-          <a:solidFill>
+          <a:solidFill xmlns:a="http://schemas.openxmlformats.org/drawingml/2006/main">
             <a:srgbClr val="B45309"/>
           </a:solidFill>
-          <a:ln>
+          <a:ln xmlns:a="http://schemas.openxmlformats.org/drawingml/2006/main">
             <a:noFill/>
           </a:ln>
-          <a:effectLst/>
-        </p:spPr>
-        <p:style>
-          <a:lnRef idx="1">
+        </p:spPr>
+        <p:style>
+          <a:lnRef xmlns:a="http://schemas.openxmlformats.org/drawingml/2006/main" idx="1">
             <a:schemeClr val="accent1"/>
           </a:lnRef>
-          <a:fillRef idx="3">
+          <a:fillRef xmlns:a="http://schemas.openxmlformats.org/drawingml/2006/main" idx="3">
             <a:schemeClr val="accent1"/>
           </a:fillRef>
-          <a:effectRef idx="2">
+          <a:effectRef xmlns:a="http://schemas.openxmlformats.org/drawingml/2006/main" idx="2">
             <a:schemeClr val="accent1"/>
           </a:effectRef>
-          <a:fontRef idx="minor">
+          <a:fontRef xmlns:a="http://schemas.openxmlformats.org/drawingml/2006/main" idx="minor">
             <a:schemeClr val="lt1"/>
           </a:fontRef>
         </p:style>
         <p:txBody>
-          <a:bodyPr rtlCol="0" anchor="ctr"/>
-          <a:lstStyle/>
-          <a:p>
-            <a:pPr algn="ctr"/>
-          </a:p>
-        </p:txBody>
-      </p:sp>
-      <p:sp xmlns:a="http://schemas.openxmlformats.org/drawingml/2006/main">
-        <p:nvSpPr>
-          <p:cNvPr id="783" name="Rectangle 782"/>
-          <p:cNvSpPr/>
-          <p:nvPr/>
-        </p:nvSpPr>
-        <p:spPr>
-          <a:xfrm>
+          <a:bodyPr xmlns:a="http://schemas.openxmlformats.org/drawingml/2006/main" anchor="ctr"/>
+          <a:lstStyle xmlns:a="http://schemas.openxmlformats.org/drawingml/2006/main"/>
+          <a:p xmlns:a="http://schemas.openxmlformats.org/drawingml/2006/main">
+            <a:pPr algn="ctr">
+              <a:buNone/>
+            </a:pPr>
+          </a:p>
+        </p:txBody>
+      </p:sp>
+      <p:sp>
+        <p:nvSpPr>
+          <p:cNvPr id="783" name="Rectangle 782">
+            <a:extLst xmlns:a="http://schemas.openxmlformats.org/drawingml/2006/main">
+              <a:ext uri="{FF2B5EF4-FFF2-40B4-BE49-F238E27FC236}">
+                <a16:creationId xmlns:a16="http://schemas.microsoft.com/office/drawing/2014/main" id="{1071C6EF-AFAE-4D6E-B5D8-846A60ACF94D}"/>
+              </a:ext>
+            </a:extLst>
+          </p:cNvPr>
+          <p:cNvSpPr>
+            <a:spLocks xmlns:a="http://schemas.openxmlformats.org/drawingml/2006/main" noGrp="1"/>
+          </p:cNvSpPr>
+          <p:nvPr/>
+        </p:nvSpPr>
+        <p:spPr>
+          <a:xfrm xmlns:a="http://schemas.openxmlformats.org/drawingml/2006/main">
             <a:off x="10715853" y="3648456"/>
             <a:ext cx="27432" cy="256032"/>
           </a:xfrm>
-          <a:prstGeom prst="rect">
-            <a:avLst/>
-          </a:prstGeom>
-          <a:solidFill>
+          <a:prstGeom xmlns:a="http://schemas.openxmlformats.org/drawingml/2006/main" prst="rect">
+            <a:avLst/>
+          </a:prstGeom>
+          <a:solidFill xmlns:a="http://schemas.openxmlformats.org/drawingml/2006/main">
             <a:srgbClr val="0B1020"/>
           </a:solidFill>
-          <a:ln>
+          <a:ln xmlns:a="http://schemas.openxmlformats.org/drawingml/2006/main">
             <a:noFill/>
           </a:ln>
-          <a:effectLst/>
-        </p:spPr>
-        <p:style>
-          <a:lnRef idx="1">
+        </p:spPr>
+        <p:style>
+          <a:lnRef xmlns:a="http://schemas.openxmlformats.org/drawingml/2006/main" idx="1">
             <a:schemeClr val="accent1"/>
           </a:lnRef>
-          <a:fillRef idx="3">
+          <a:fillRef xmlns:a="http://schemas.openxmlformats.org/drawingml/2006/main" idx="3">
             <a:schemeClr val="accent1"/>
           </a:fillRef>
-          <a:effectRef idx="2">
+          <a:effectRef xmlns:a="http://schemas.openxmlformats.org/drawingml/2006/main" idx="2">
             <a:schemeClr val="accent1"/>
           </a:effectRef>
-          <a:fontRef idx="minor">
+          <a:fontRef xmlns:a="http://schemas.openxmlformats.org/drawingml/2006/main" idx="minor">
             <a:schemeClr val="lt1"/>
           </a:fontRef>
         </p:style>
         <p:txBody>
-          <a:bodyPr rtlCol="0" anchor="ctr"/>
-          <a:lstStyle/>
-          <a:p>
-            <a:pPr algn="ctr"/>
-          </a:p>
-        </p:txBody>
-      </p:sp>
-      <p:sp xmlns:a="http://schemas.openxmlformats.org/drawingml/2006/main">
-        <p:nvSpPr>
-          <p:cNvPr id="784" name="Rounded Rectangle 783"/>
-          <p:cNvSpPr/>
-          <p:nvPr/>
-        </p:nvSpPr>
-        <p:spPr>
-          <a:xfrm>
+          <a:bodyPr xmlns:a="http://schemas.openxmlformats.org/drawingml/2006/main" anchor="ctr"/>
+          <a:lstStyle xmlns:a="http://schemas.openxmlformats.org/drawingml/2006/main"/>
+          <a:p xmlns:a="http://schemas.openxmlformats.org/drawingml/2006/main">
+            <a:pPr algn="ctr">
+              <a:buNone/>
+            </a:pPr>
+          </a:p>
+        </p:txBody>
+      </p:sp>
+      <p:sp>
+        <p:nvSpPr>
+          <p:cNvPr id="784" name="Rounded Rectangle 783">
+            <a:extLst xmlns:a="http://schemas.openxmlformats.org/drawingml/2006/main">
+              <a:ext uri="{FF2B5EF4-FFF2-40B4-BE49-F238E27FC236}">
+                <a16:creationId xmlns:a16="http://schemas.microsoft.com/office/drawing/2014/main" id="{7503D16D-8CD3-4371-AA47-0480691F8D53}"/>
+              </a:ext>
+            </a:extLst>
+          </p:cNvPr>
+          <p:cNvSpPr>
+            <a:spLocks xmlns:a="http://schemas.openxmlformats.org/drawingml/2006/main" noGrp="1"/>
+          </p:cNvSpPr>
+          <p:nvPr/>
+        </p:nvSpPr>
+        <p:spPr>
+          <a:xfrm xmlns:a="http://schemas.openxmlformats.org/drawingml/2006/main">
             <a:off x="6647688" y="4718304"/>
             <a:ext cx="4535424" cy="128016"/>
           </a:xfrm>
-          <a:prstGeom prst="roundRect">
+          <a:prstGeom xmlns:a="http://schemas.openxmlformats.org/drawingml/2006/main" prst="roundRect">
             <a:avLst>
               <a:gd name="adj" fmla="val 50000"/>
             </a:avLst>
           </a:prstGeom>
-          <a:solidFill>
+          <a:solidFill xmlns:a="http://schemas.openxmlformats.org/drawingml/2006/main">
             <a:srgbClr val="F3D9B5"/>
           </a:solidFill>
-          <a:ln>
+          <a:ln xmlns:a="http://schemas.openxmlformats.org/drawingml/2006/main">
             <a:noFill/>
           </a:ln>
-          <a:effectLst/>
-        </p:spPr>
-        <p:style>
-          <a:lnRef idx="1">
+        </p:spPr>
+        <p:style>
+          <a:lnRef xmlns:a="http://schemas.openxmlformats.org/drawingml/2006/main" idx="1">
             <a:schemeClr val="accent1"/>
           </a:lnRef>
-          <a:fillRef idx="3">
+          <a:fillRef xmlns:a="http://schemas.openxmlformats.org/drawingml/2006/main" idx="3">
             <a:schemeClr val="accent1"/>
           </a:fillRef>
-          <a:effectRef idx="2">
+          <a:effectRef xmlns:a="http://schemas.openxmlformats.org/drawingml/2006/main" idx="2">
             <a:schemeClr val="accent1"/>
           </a:effectRef>
-          <a:fontRef idx="minor">
+          <a:fontRef xmlns:a="http://schemas.openxmlformats.org/drawingml/2006/main" idx="minor">
             <a:schemeClr val="lt1"/>
           </a:fontRef>
         </p:style>
         <p:txBody>
-          <a:bodyPr rtlCol="0" anchor="ctr"/>
-          <a:lstStyle/>
-          <a:p>
-            <a:pPr algn="ctr"/>
-          </a:p>
-        </p:txBody>
-      </p:sp>
-      <p:sp xmlns:a="http://schemas.openxmlformats.org/drawingml/2006/main">
-        <p:nvSpPr>
-          <p:cNvPr id="785" name="Rounded Rectangle 784"/>
-          <p:cNvSpPr/>
-          <p:nvPr/>
-        </p:nvSpPr>
-        <p:spPr>
-          <a:xfrm>
+          <a:bodyPr xmlns:a="http://schemas.openxmlformats.org/drawingml/2006/main" anchor="ctr"/>
+          <a:lstStyle xmlns:a="http://schemas.openxmlformats.org/drawingml/2006/main"/>
+          <a:p xmlns:a="http://schemas.openxmlformats.org/drawingml/2006/main">
+            <a:pPr algn="ctr">
+              <a:buNone/>
+            </a:pPr>
+          </a:p>
+        </p:txBody>
+      </p:sp>
+      <p:sp>
+        <p:nvSpPr>
+          <p:cNvPr id="785" name="Rounded Rectangle 784">
+            <a:extLst xmlns:a="http://schemas.openxmlformats.org/drawingml/2006/main">
+              <a:ext uri="{FF2B5EF4-FFF2-40B4-BE49-F238E27FC236}">
+                <a16:creationId xmlns:a16="http://schemas.microsoft.com/office/drawing/2014/main" id="{F0CC2C07-7414-4BE8-91AA-D9E94C76EAF1}"/>
+              </a:ext>
+            </a:extLst>
+          </p:cNvPr>
+          <p:cNvSpPr>
+            <a:spLocks xmlns:a="http://schemas.openxmlformats.org/drawingml/2006/main" noGrp="1"/>
+          </p:cNvSpPr>
+          <p:nvPr/>
+        </p:nvSpPr>
+        <p:spPr>
+          <a:xfrm xmlns:a="http://schemas.openxmlformats.org/drawingml/2006/main">
             <a:off x="6647688" y="4718304"/>
             <a:ext cx="1510296" cy="128016"/>
           </a:xfrm>
-          <a:prstGeom prst="roundRect">
+          <a:prstGeom xmlns:a="http://schemas.openxmlformats.org/drawingml/2006/main" prst="roundRect">
             <a:avLst>
               <a:gd name="adj" fmla="val 50000"/>
             </a:avLst>
           </a:prstGeom>
-          <a:solidFill>
+          <a:solidFill xmlns:a="http://schemas.openxmlformats.org/drawingml/2006/main">
             <a:srgbClr val="B45309"/>
           </a:solidFill>
-          <a:ln>
+          <a:ln xmlns:a="http://schemas.openxmlformats.org/drawingml/2006/main">
             <a:noFill/>
           </a:ln>
-          <a:effectLst/>
-        </p:spPr>
-        <p:style>
-          <a:lnRef idx="1">
+        </p:spPr>
+        <p:style>
+          <a:lnRef xmlns:a="http://schemas.openxmlformats.org/drawingml/2006/main" idx="1">
             <a:schemeClr val="accent1"/>
           </a:lnRef>
-          <a:fillRef idx="3">
+          <a:fillRef xmlns:a="http://schemas.openxmlformats.org/drawingml/2006/main" idx="3">
             <a:schemeClr val="accent1"/>
           </a:fillRef>
-          <a:effectRef idx="2">
+          <a:effectRef xmlns:a="http://schemas.openxmlformats.org/drawingml/2006/main" idx="2">
             <a:schemeClr val="accent1"/>
           </a:effectRef>
-          <a:fontRef idx="minor">
+          <a:fontRef xmlns:a="http://schemas.openxmlformats.org/drawingml/2006/main" idx="minor">
             <a:schemeClr val="lt1"/>
           </a:fontRef>
         </p:style>
         <p:txBody>
-          <a:bodyPr rtlCol="0" anchor="ctr"/>
-          <a:lstStyle/>
-          <a:p>
-            <a:pPr algn="ctr"/>
-          </a:p>
-        </p:txBody>
-      </p:sp>
-      <p:sp xmlns:a="http://schemas.openxmlformats.org/drawingml/2006/main">
-        <p:nvSpPr>
-          <p:cNvPr id="786" name="Rectangle 785"/>
-          <p:cNvSpPr/>
-          <p:nvPr/>
-        </p:nvSpPr>
-        <p:spPr>
-          <a:xfrm>
+          <a:bodyPr xmlns:a="http://schemas.openxmlformats.org/drawingml/2006/main" anchor="ctr"/>
+          <a:lstStyle xmlns:a="http://schemas.openxmlformats.org/drawingml/2006/main"/>
+          <a:p xmlns:a="http://schemas.openxmlformats.org/drawingml/2006/main">
+            <a:pPr algn="ctr">
+              <a:buNone/>
+            </a:pPr>
+          </a:p>
+        </p:txBody>
+      </p:sp>
+      <p:sp>
+        <p:nvSpPr>
+          <p:cNvPr id="786" name="Rectangle 785">
+            <a:extLst xmlns:a="http://schemas.openxmlformats.org/drawingml/2006/main">
+              <a:ext uri="{FF2B5EF4-FFF2-40B4-BE49-F238E27FC236}">
+                <a16:creationId xmlns:a16="http://schemas.microsoft.com/office/drawing/2014/main" id="{05035308-45E1-4C98-A2DB-239A9C34DC24}"/>
+              </a:ext>
+            </a:extLst>
+          </p:cNvPr>
+          <p:cNvSpPr>
+            <a:spLocks xmlns:a="http://schemas.openxmlformats.org/drawingml/2006/main" noGrp="1"/>
+          </p:cNvSpPr>
+          <p:nvPr/>
+        </p:nvSpPr>
+        <p:spPr>
+          <a:xfrm xmlns:a="http://schemas.openxmlformats.org/drawingml/2006/main">
             <a:off x="7087514" y="4654296"/>
             <a:ext cx="27432" cy="256032"/>
           </a:xfrm>
-          <a:prstGeom prst="rect">
-            <a:avLst/>
-          </a:prstGeom>
-          <a:solidFill>
+          <a:prstGeom xmlns:a="http://schemas.openxmlformats.org/drawingml/2006/main" prst="rect">
+            <a:avLst/>
+          </a:prstGeom>
+          <a:solidFill xmlns:a="http://schemas.openxmlformats.org/drawingml/2006/main">
             <a:srgbClr val="0B1020"/>
           </a:solidFill>
-          <a:ln>
+          <a:ln xmlns:a="http://schemas.openxmlformats.org/drawingml/2006/main">
             <a:noFill/>
           </a:ln>
-          <a:effectLst/>
-        </p:spPr>
-        <p:style>
-          <a:lnRef idx="1">
+        </p:spPr>
+        <p:style>
+          <a:lnRef xmlns:a="http://schemas.openxmlformats.org/drawingml/2006/main" idx="1">
             <a:schemeClr val="accent1"/>
           </a:lnRef>
-          <a:fillRef idx="3">
+          <a:fillRef xmlns:a="http://schemas.openxmlformats.org/drawingml/2006/main" idx="3">
             <a:schemeClr val="accent1"/>
           </a:fillRef>
-          <a:effectRef idx="2">
+          <a:effectRef xmlns:a="http://schemas.openxmlformats.org/drawingml/2006/main" idx="2">
             <a:schemeClr val="accent1"/>
           </a:effectRef>
-          <a:fontRef idx="minor">
+          <a:fontRef xmlns:a="http://schemas.openxmlformats.org/drawingml/2006/main" idx="minor">
             <a:schemeClr val="lt1"/>
           </a:fontRef>
         </p:style>
         <p:txBody>
-          <a:bodyPr rtlCol="0" anchor="ctr"/>
-          <a:lstStyle/>
-          <a:p>
-            <a:pPr algn="ctr"/>
+          <a:bodyPr xmlns:a="http://schemas.openxmlformats.org/drawingml/2006/main" anchor="ctr"/>
+          <a:lstStyle xmlns:a="http://schemas.openxmlformats.org/drawingml/2006/main"/>
+          <a:p xmlns:a="http://schemas.openxmlformats.org/drawingml/2006/main">
+            <a:pPr algn="ctr">
+              <a:buNone/>
+            </a:pPr>
           </a:p>
         </p:txBody>
       </p:sp>

</xml_diff>

<commit_message>
Clarify presentation workflow ownership
</commit_message>
<xml_diff>
--- a/docs/ai-pre-scan-presentation.pptx
+++ b/docs/ai-pre-scan-presentation.pptx
@@ -2,22 +2,22 @@
 <file path=ppt/presentation.xml><?xml version="1.0" encoding="utf-8"?>
 <p:presentation xmlns:p="http://schemas.openxmlformats.org/presentationml/2006/main">
   <p:sldMasterIdLst>
-    <p:sldMasterId xmlns:r="http://schemas.openxmlformats.org/officeDocument/2006/relationships" id="2147483648" r:id="R5fbb4cebdc574ad0"/>
+    <p:sldMasterId xmlns:r="http://schemas.openxmlformats.org/officeDocument/2006/relationships" id="2147483648" r:id="R6abf094b6b6641b0"/>
   </p:sldMasterIdLst>
   <p:notesMasterIdLst>
-    <p:notesMasterId xmlns:r="http://schemas.openxmlformats.org/officeDocument/2006/relationships" r:id="Rbff346cceb5349ff"/>
+    <p:notesMasterId xmlns:r="http://schemas.openxmlformats.org/officeDocument/2006/relationships" r:id="R0d6c137416f340aa"/>
   </p:notesMasterIdLst>
   <p:sldIdLst>
-    <p:sldId xmlns:r="http://schemas.openxmlformats.org/officeDocument/2006/relationships" id="256" r:id="Rf954f45e8b554cfc"/>
-    <p:sldId xmlns:r="http://schemas.openxmlformats.org/officeDocument/2006/relationships" id="257" r:id="Rf4cfd48ee289427a"/>
-    <p:sldId xmlns:r="http://schemas.openxmlformats.org/officeDocument/2006/relationships" id="258" r:id="R8958028d75164baa"/>
-    <p:sldId xmlns:r="http://schemas.openxmlformats.org/officeDocument/2006/relationships" id="259" r:id="Rbe63a422366e40e6"/>
-    <p:sldId xmlns:r="http://schemas.openxmlformats.org/officeDocument/2006/relationships" id="260" r:id="R82260448f068455d"/>
-    <p:sldId xmlns:r="http://schemas.openxmlformats.org/officeDocument/2006/relationships" id="261" r:id="R1686bbe0d4b341f5"/>
-    <p:sldId xmlns:r="http://schemas.openxmlformats.org/officeDocument/2006/relationships" id="262" r:id="R206a9ba4301a4645"/>
-    <p:sldId xmlns:r="http://schemas.openxmlformats.org/officeDocument/2006/relationships" id="263" r:id="R862e0c73d763409b"/>
-    <p:sldId xmlns:r="http://schemas.openxmlformats.org/officeDocument/2006/relationships" id="264" r:id="R6b3fd55b6e1b4c0b"/>
-    <p:sldId xmlns:r="http://schemas.openxmlformats.org/officeDocument/2006/relationships" id="265" r:id="R3438a2875f24455c"/>
+    <p:sldId xmlns:r="http://schemas.openxmlformats.org/officeDocument/2006/relationships" id="256" r:id="R7f249dbc64e54f28"/>
+    <p:sldId xmlns:r="http://schemas.openxmlformats.org/officeDocument/2006/relationships" id="257" r:id="R7cd0312964ca4326"/>
+    <p:sldId xmlns:r="http://schemas.openxmlformats.org/officeDocument/2006/relationships" id="258" r:id="R4c29b7fc4d804bba"/>
+    <p:sldId xmlns:r="http://schemas.openxmlformats.org/officeDocument/2006/relationships" id="259" r:id="R51b5f79036cb40d9"/>
+    <p:sldId xmlns:r="http://schemas.openxmlformats.org/officeDocument/2006/relationships" id="260" r:id="Ra93d87df7eb94682"/>
+    <p:sldId xmlns:r="http://schemas.openxmlformats.org/officeDocument/2006/relationships" id="261" r:id="R66c87e4ddba2469f"/>
+    <p:sldId xmlns:r="http://schemas.openxmlformats.org/officeDocument/2006/relationships" id="262" r:id="R90d66177e83a43c3"/>
+    <p:sldId xmlns:r="http://schemas.openxmlformats.org/officeDocument/2006/relationships" id="263" r:id="R9b0898a352184154"/>
+    <p:sldId xmlns:r="http://schemas.openxmlformats.org/officeDocument/2006/relationships" id="264" r:id="R7a53c2e0bb5d44e2"/>
+    <p:sldId xmlns:r="http://schemas.openxmlformats.org/officeDocument/2006/relationships" id="265" r:id="Redc47983f02a401b"/>
   </p:sldIdLst>
   <p:sldSz cx="12192000" cy="6858000"/>
   <p:notesSz cx="6858000" cy="9144000"/>
@@ -920,49 +920,101 @@
               <a:t>• The only input is a company name.</a:t>
             </a:r>
           </a:p>
-          <a:p xmlns:a="http://schemas.openxmlformats.org/drawingml/2006/main"/>
-          <a:p xmlns:a="http://schemas.openxmlformats.org/drawingml/2006/main">
-            <a:r>
-              <a:t>• One — map the public footprint: registry, website, careers pages, vendor references, news.</a:t>
-            </a:r>
-          </a:p>
-          <a:p xmlns:a="http://schemas.openxmlformats.org/drawingml/2006/main"/>
-          <a:p xmlns:a="http://schemas.openxmlformats.org/drawingml/2006/main">
-            <a:r>
-              <a:t>• Two — test every finding. The exact sentence must exist, on a page we can name, and that page must still be live.</a:t>
-            </a:r>
-          </a:p>
-          <a:p xmlns:a="http://schemas.openxmlformats.org/drawingml/2006/main"/>
-          <a:p xmlns:a="http://schemas.openxmlformats.org/drawingml/2006/main">
-            <a:r>
-              <a:t>• Anything that fails is not asserted and not deleted — it is marked undetermined.</a:t>
-            </a:r>
-          </a:p>
-          <a:p xmlns:a="http://schemas.openxmlformats.org/drawingml/2006/main"/>
-          <a:p xmlns:a="http://schemas.openxmlformats.org/drawingml/2006/main">
-            <a:r>
-              <a:t>• Three — the adviser walks into the client meeting with a draft inventory and focused questions.</a:t>
-            </a:r>
-          </a:p>
-          <a:p xmlns:a="http://schemas.openxmlformats.org/drawingml/2006/main"/>
-          <a:p xmlns:a="http://schemas.openxmlformats.org/drawingml/2006/main">
-            <a:r>
-              <a:t>• Humans confirm the facts. Applying the law is a separate job, and it stays with people.</a:t>
-            </a:r>
-          </a:p>
-          <a:p xmlns:a="http://schemas.openxmlformats.org/drawingml/2006/main"/>
+          <a:p xmlns:a="http://schemas.openxmlformats.org/drawingml/2006/main">
+            <a:r>
+              <a:t/>
+            </a:r>
+          </a:p>
+          <a:p xmlns:a="http://schemas.openxmlformats.org/drawingml/2006/main">
+            <a:r>
+              <a:t>• [Point to card 1.] LangGraph runs the research loop. Search and identity tools find relevant URLs, and the fetcher retrieves the actual page text.</a:t>
+            </a:r>
+          </a:p>
+          <a:p xmlns:a="http://schemas.openxmlformats.org/drawingml/2006/main">
+            <a:r>
+              <a:t/>
+            </a:r>
+          </a:p>
+          <a:p xmlns:a="http://schemas.openxmlformats.org/drawingml/2006/main">
+            <a:r>
+              <a:t>• Those pages can come from the company itself, a vendor, a careers page or credible news coverage.</a:t>
+            </a:r>
+          </a:p>
+          <a:p xmlns:a="http://schemas.openxmlformats.org/drawingml/2006/main">
+            <a:r>
+              <a:t/>
+            </a:r>
+          </a:p>
+          <a:p xmlns:a="http://schemas.openxmlformats.org/drawingml/2006/main">
+            <a:r>
+              <a:t>• [Point to card 2.] OpenAI reads each fetched page and proposes a candidate system fact with a verbatim supporting sentence from that same page.</a:t>
+            </a:r>
+          </a:p>
+          <a:p xmlns:a="http://schemas.openxmlformats.org/drawingml/2006/main">
+            <a:r>
+              <a:t/>
+            </a:r>
+          </a:p>
+          <a:p xmlns:a="http://schemas.openxmlformats.org/drawingml/2006/main">
+            <a:r>
+              <a:t>• Deterministic code checks that the sentence really appears on the page and describes AI behaviour. The evidence gate then checks source traceability and whether the page is current enough for the claim.</a:t>
+            </a:r>
+          </a:p>
+          <a:p xmlns:a="http://schemas.openxmlformats.org/drawingml/2006/main">
+            <a:r>
+              <a:t/>
+            </a:r>
+          </a:p>
+          <a:p xmlns:a="http://schemas.openxmlformats.org/drawingml/2006/main">
+            <a:r>
+              <a:t>• If a check fails, LangGraph researches again. If support still cannot be found, the candidate becomes undetermined rather than a fact.</a:t>
+            </a:r>
+          </a:p>
+          <a:p xmlns:a="http://schemas.openxmlformats.org/drawingml/2006/main">
+            <a:r>
+              <a:t/>
+            </a:r>
+          </a:p>
+          <a:p xmlns:a="http://schemas.openxmlformats.org/drawingml/2006/main">
+            <a:r>
+              <a:t>• [Point to card 3.] The adviser and client confirm the draft inventory and answer the questions public evidence cannot settle.</a:t>
+            </a:r>
+          </a:p>
+          <a:p xmlns:a="http://schemas.openxmlformats.org/drawingml/2006/main">
+            <a:r>
+              <a:t/>
+            </a:r>
+          </a:p>
+          <a:p xmlns:a="http://schemas.openxmlformats.org/drawingml/2006/main">
+            <a:r>
+              <a:t>• Applying the law remains a separate human-led step.</a:t>
+            </a:r>
+          </a:p>
+          <a:p xmlns:a="http://schemas.openxmlformats.org/drawingml/2006/main">
+            <a:r>
+              <a:t/>
+            </a:r>
+          </a:p>
           <a:p xmlns:a="http://schemas.openxmlformats.org/drawingml/2006/main">
             <a:r>
               <a:t>• [Pause.]</a:t>
             </a:r>
           </a:p>
-          <a:p xmlns:a="http://schemas.openxmlformats.org/drawingml/2006/main"/>
-          <a:p xmlns:a="http://schemas.openxmlformats.org/drawingml/2006/main">
-            <a:r>
-              <a:t>• The fastest way to understand this is to see both kinds of output.</a:t>
-            </a:r>
-          </a:p>
-          <a:p xmlns:a="http://schemas.openxmlformats.org/drawingml/2006/main"/>
+          <a:p xmlns:a="http://schemas.openxmlformats.org/drawingml/2006/main">
+            <a:r>
+              <a:t/>
+            </a:r>
+          </a:p>
+          <a:p xmlns:a="http://schemas.openxmlformats.org/drawingml/2006/main">
+            <a:r>
+              <a:t>• So every stage has a named owner, and the supporting quote never appears from nowhere.</a:t>
+            </a:r>
+          </a:p>
+          <a:p xmlns:a="http://schemas.openxmlformats.org/drawingml/2006/main">
+            <a:r>
+              <a:t/>
+            </a:r>
+          </a:p>
           <a:p xmlns:a="http://schemas.openxmlformats.org/drawingml/2006/main">
             <a:r>
               <a:t>[If asked — HOW]</a:t>
@@ -970,20 +1022,24 @@
           </a:p>
           <a:p xmlns:a="http://schemas.openxmlformats.org/drawingml/2006/main">
             <a:r>
-              <a:t>– How does it search?  Four public sources: web search via Serper, news via NewsAPI, the GLEIF company registry, and Wikidata.</a:t>
-            </a:r>
-          </a:p>
-          <a:p xmlns:a="http://schemas.openxmlformats.org/drawingml/2006/main">
-            <a:r>
-              <a:t>– How do you know a quote is real?  The gate is code, not a model. The sentence must appear in the fetched page or the finding does not ship.</a:t>
-            </a:r>
-          </a:p>
-          <a:p xmlns:a="http://schemas.openxmlformats.org/drawingml/2006/main">
-            <a:r>
-              <a:t>– What does “still live” mean?  The page is re-fetched and content-hashed; a changed or dead page fails the check.</a:t>
-            </a:r>
-          </a:p>
-          <a:p xmlns:a="http://schemas.openxmlformats.org/drawingml/2006/main"/>
+              <a:t>– Which tools handle research?  LangGraph orchestrates Serper and NewsAPI for discovery, GLEIF and Wikidata for identity, and the page fetcher for the source text.</a:t>
+            </a:r>
+          </a:p>
+          <a:p xmlns:a="http://schemas.openxmlformats.org/drawingml/2006/main">
+            <a:r>
+              <a:t>– Where does the quote come from?  The same fetched webpage as the candidate fact. Code rejects it if the wording is not present in that page text.</a:t>
+            </a:r>
+          </a:p>
+          <a:p xmlns:a="http://schemas.openxmlformats.org/drawingml/2006/main">
+            <a:r>
+              <a:t>– What does the adviser add?  Internal confirmation and context that cannot be seen publicly, before any legal classification.</a:t>
+            </a:r>
+          </a:p>
+          <a:p xmlns:a="http://schemas.openxmlformats.org/drawingml/2006/main">
+            <a:r>
+              <a:t/>
+            </a:r>
+          </a:p>
           <a:p xmlns:a="http://schemas.openxmlformats.org/drawingml/2006/main">
             <a:r>
               <a:t>[Sources]</a:t>
@@ -991,7 +1047,17 @@
           </a:p>
           <a:p xmlns:a="http://schemas.openxmlformats.org/drawingml/2006/main">
             <a:r>
-              <a:t>- docs/system-overview-slide.pptx</a:t>
+              <a:t>- src/ai_prescan/graph.py</a:t>
+            </a:r>
+          </a:p>
+          <a:p xmlns:a="http://schemas.openxmlformats.org/drawingml/2006/main">
+            <a:r>
+              <a:t>- src/ai_prescan/extract.py</a:t>
+            </a:r>
+          </a:p>
+          <a:p xmlns:a="http://schemas.openxmlformats.org/drawingml/2006/main">
+            <a:r>
+              <a:t>- src/ai_prescan/gate.py</a:t>
             </a:r>
           </a:p>
           <a:p xmlns:a="http://schemas.openxmlformats.org/drawingml/2006/main">
@@ -2770,8 +2836,8 @@
   </p:cSld>
   <p:clrMap bg1="lt1" tx1="dk1" bg2="lt2" tx2="dk2" accent1="accent1" accent2="accent2" accent3="accent3" accent4="accent4" accent5="accent5" accent6="accent6" hlink="hlink" folHlink="folHlink"/>
   <p:sldLayoutIdLst>
-    <p:sldLayoutId xmlns:r="http://schemas.openxmlformats.org/officeDocument/2006/relationships" id="2147483649" r:id="R4e4e39095a194e1c"/>
-    <p:sldLayoutId xmlns:r="http://schemas.openxmlformats.org/officeDocument/2006/relationships" id="2147483650" r:id="R283891e31d444636"/>
+    <p:sldLayoutId xmlns:r="http://schemas.openxmlformats.org/officeDocument/2006/relationships" id="2147483649" r:id="R1e581d2373d04ce5"/>
+    <p:sldLayoutId xmlns:r="http://schemas.openxmlformats.org/officeDocument/2006/relationships" id="2147483650" r:id="R70a4438fc706432a"/>
   </p:sldLayoutIdLst>
 </p:sldMaster>
 </file>
@@ -8090,7 +8156,7 @@
         </p:style>
         <p:txBody>
           <a:bodyPr xmlns:a="http://schemas.openxmlformats.org/drawingml/2006/main" lIns="0" tIns="0" rIns="0" bIns="0" anchor="ctr">
-            <a:normAutofit/>
+            <a:normAutofit fontScale="100000"/>
           </a:bodyPr>
           <a:lstStyle xmlns:a="http://schemas.openxmlformats.org/drawingml/2006/main"/>
           <a:p xmlns:a="http://schemas.openxmlformats.org/drawingml/2006/main">
@@ -8112,7 +8178,7 @@
                 <a:ea typeface="Aptos"/>
                 <a:cs typeface="Aptos"/>
               </a:rPr>
-              <a:t>RESEARCH</a:t>
+              <a:t>LANGGRAPH</a:t>
             </a:r>
             <a:endParaRPr sz="1050" b="0" u="none">
               <a:solidFill>
@@ -8182,7 +8248,7 @@
                 <a:ea typeface="Aptos Display"/>
                 <a:cs typeface="Aptos Display"/>
               </a:rPr>
-              <a:t>Map the public footprint</a:t>
+              <a:t>Find + fetch public pages</a:t>
             </a:r>
             <a:endParaRPr sz="2200" b="0" u="none">
               <a:solidFill>
@@ -8230,7 +8296,7 @@
         </p:style>
         <p:txBody>
           <a:bodyPr xmlns:a="http://schemas.openxmlformats.org/drawingml/2006/main" lIns="0" tIns="0" rIns="0" bIns="0" anchor="t">
-            <a:normAutofit lnSpcReduction="9999"/>
+            <a:normAutofit fontScale="96344" lnSpcReduction="9999"/>
           </a:bodyPr>
           <a:lstStyle xmlns:a="http://schemas.openxmlformats.org/drawingml/2006/main"/>
           <a:p xmlns:a="http://schemas.openxmlformats.org/drawingml/2006/main">
@@ -8252,7 +8318,7 @@
                 <a:ea typeface="Aptos"/>
                 <a:cs typeface="Aptos"/>
               </a:rPr>
-              <a:t>Registry · website · careers · vendors · news</a:t>
+              <a:t>Company · vendor · careers · news</a:t>
             </a:r>
             <a:endParaRPr sz="1400" b="0" u="none">
               <a:solidFill>
@@ -8487,7 +8553,7 @@
         </p:style>
         <p:txBody>
           <a:bodyPr xmlns:a="http://schemas.openxmlformats.org/drawingml/2006/main" lIns="0" tIns="0" rIns="0" bIns="0" anchor="ctr">
-            <a:normAutofit/>
+            <a:normAutofit fontScale="100000"/>
           </a:bodyPr>
           <a:lstStyle xmlns:a="http://schemas.openxmlformats.org/drawingml/2006/main"/>
           <a:p xmlns:a="http://schemas.openxmlformats.org/drawingml/2006/main">
@@ -8509,7 +8575,7 @@
                 <a:ea typeface="Aptos"/>
                 <a:cs typeface="Aptos"/>
               </a:rPr>
-              <a:t>VERIFY</a:t>
+              <a:t>OPENAI + CODE</a:t>
             </a:r>
             <a:endParaRPr sz="1050" b="0" u="none">
               <a:solidFill>
@@ -8579,7 +8645,7 @@
                 <a:ea typeface="Aptos Display"/>
                 <a:cs typeface="Aptos Display"/>
               </a:rPr>
-              <a:t>Test every finding</a:t>
+              <a:t>Extract facts + verify quotes</a:t>
             </a:r>
             <a:endParaRPr sz="2200" b="0" u="none">
               <a:solidFill>
@@ -8627,7 +8693,7 @@
         </p:style>
         <p:txBody>
           <a:bodyPr xmlns:a="http://schemas.openxmlformats.org/drawingml/2006/main" lIns="0" tIns="0" rIns="0" bIns="0" anchor="t">
-            <a:normAutofit lnSpcReduction="9999"/>
+            <a:normAutofit fontScale="96344" lnSpcReduction="9999"/>
           </a:bodyPr>
           <a:lstStyle xmlns:a="http://schemas.openxmlformats.org/drawingml/2006/main"/>
           <a:p xmlns:a="http://schemas.openxmlformats.org/drawingml/2006/main">
@@ -8649,7 +8715,7 @@
                 <a:ea typeface="Aptos"/>
                 <a:cs typeface="Aptos"/>
               </a:rPr>
-              <a:t>The exact sentence, from a page that is still live</a:t>
+              <a:t>Candidate fact + sentence from the same page</a:t>
             </a:r>
             <a:endParaRPr sz="1400" b="0" u="none">
               <a:solidFill>
@@ -8899,7 +8965,7 @@
                 <a:ea typeface="Aptos"/>
                 <a:cs typeface="Aptos"/>
               </a:rPr>
-              <a:t>REVIEW</a:t>
+              <a:t>ADVISER + CLIENT</a:t>
             </a:r>
             <a:endParaRPr sz="1050" b="0" u="none">
               <a:solidFill>
@@ -8969,7 +9035,7 @@
                 <a:ea typeface="Aptos Display"/>
                 <a:cs typeface="Aptos Display"/>
               </a:rPr>
-              <a:t>Start the client conversation</a:t>
+              <a:t>Confirm the draft</a:t>
             </a:r>
             <a:endParaRPr sz="2200" b="0" u="none">
               <a:solidFill>
@@ -9017,7 +9083,7 @@
         </p:style>
         <p:txBody>
           <a:bodyPr xmlns:a="http://schemas.openxmlformats.org/drawingml/2006/main" lIns="0" tIns="0" rIns="0" bIns="0" anchor="t">
-            <a:normAutofit lnSpcReduction="9999"/>
+            <a:normAutofit fontScale="100000" lnSpcReduction="9999"/>
           </a:bodyPr>
           <a:lstStyle xmlns:a="http://schemas.openxmlformats.org/drawingml/2006/main"/>
           <a:p xmlns:a="http://schemas.openxmlformats.org/drawingml/2006/main">
@@ -9039,7 +9105,7 @@
                 <a:ea typeface="Aptos"/>
                 <a:cs typeface="Aptos"/>
               </a:rPr>
-              <a:t>Draft inventory + focused questions</a:t>
+              <a:t>Inventory + focused questions</a:t>
             </a:r>
             <a:endParaRPr sz="1400" b="0" u="none">
               <a:solidFill>

</xml_diff>

<commit_message>
Clarify presentation retry budget
</commit_message>
<xml_diff>
--- a/docs/ai-pre-scan-presentation.pptx
+++ b/docs/ai-pre-scan-presentation.pptx
@@ -2,22 +2,22 @@
 <file path=ppt/presentation.xml><?xml version="1.0" encoding="utf-8"?>
 <p:presentation xmlns:p="http://schemas.openxmlformats.org/presentationml/2006/main">
   <p:sldMasterIdLst>
-    <p:sldMasterId xmlns:r="http://schemas.openxmlformats.org/officeDocument/2006/relationships" id="2147483648" r:id="R6abf094b6b6641b0"/>
+    <p:sldMasterId xmlns:r="http://schemas.openxmlformats.org/officeDocument/2006/relationships" id="2147483648" r:id="Rca69f8add24e4d78"/>
   </p:sldMasterIdLst>
   <p:notesMasterIdLst>
-    <p:notesMasterId xmlns:r="http://schemas.openxmlformats.org/officeDocument/2006/relationships" r:id="R0d6c137416f340aa"/>
+    <p:notesMasterId xmlns:r="http://schemas.openxmlformats.org/officeDocument/2006/relationships" r:id="Rf30b47301fe44c0f"/>
   </p:notesMasterIdLst>
   <p:sldIdLst>
-    <p:sldId xmlns:r="http://schemas.openxmlformats.org/officeDocument/2006/relationships" id="256" r:id="R7f249dbc64e54f28"/>
-    <p:sldId xmlns:r="http://schemas.openxmlformats.org/officeDocument/2006/relationships" id="257" r:id="R7cd0312964ca4326"/>
-    <p:sldId xmlns:r="http://schemas.openxmlformats.org/officeDocument/2006/relationships" id="258" r:id="R4c29b7fc4d804bba"/>
-    <p:sldId xmlns:r="http://schemas.openxmlformats.org/officeDocument/2006/relationships" id="259" r:id="R51b5f79036cb40d9"/>
-    <p:sldId xmlns:r="http://schemas.openxmlformats.org/officeDocument/2006/relationships" id="260" r:id="Ra93d87df7eb94682"/>
-    <p:sldId xmlns:r="http://schemas.openxmlformats.org/officeDocument/2006/relationships" id="261" r:id="R66c87e4ddba2469f"/>
-    <p:sldId xmlns:r="http://schemas.openxmlformats.org/officeDocument/2006/relationships" id="262" r:id="R90d66177e83a43c3"/>
-    <p:sldId xmlns:r="http://schemas.openxmlformats.org/officeDocument/2006/relationships" id="263" r:id="R9b0898a352184154"/>
-    <p:sldId xmlns:r="http://schemas.openxmlformats.org/officeDocument/2006/relationships" id="264" r:id="R7a53c2e0bb5d44e2"/>
-    <p:sldId xmlns:r="http://schemas.openxmlformats.org/officeDocument/2006/relationships" id="265" r:id="Redc47983f02a401b"/>
+    <p:sldId xmlns:r="http://schemas.openxmlformats.org/officeDocument/2006/relationships" id="256" r:id="R2e932d0452e343d0"/>
+    <p:sldId xmlns:r="http://schemas.openxmlformats.org/officeDocument/2006/relationships" id="257" r:id="R03387c24edae4e3a"/>
+    <p:sldId xmlns:r="http://schemas.openxmlformats.org/officeDocument/2006/relationships" id="258" r:id="R050c385605fe4b45"/>
+    <p:sldId xmlns:r="http://schemas.openxmlformats.org/officeDocument/2006/relationships" id="259" r:id="Rcee5dcc0320149dd"/>
+    <p:sldId xmlns:r="http://schemas.openxmlformats.org/officeDocument/2006/relationships" id="260" r:id="R46ed68d7857b4819"/>
+    <p:sldId xmlns:r="http://schemas.openxmlformats.org/officeDocument/2006/relationships" id="261" r:id="Rb4d881afbacf4b3e"/>
+    <p:sldId xmlns:r="http://schemas.openxmlformats.org/officeDocument/2006/relationships" id="262" r:id="Rbb76a084960d4750"/>
+    <p:sldId xmlns:r="http://schemas.openxmlformats.org/officeDocument/2006/relationships" id="263" r:id="R1a09bb382b9a4ac1"/>
+    <p:sldId xmlns:r="http://schemas.openxmlformats.org/officeDocument/2006/relationships" id="264" r:id="R419c30067df04b2c"/>
+    <p:sldId xmlns:r="http://schemas.openxmlformats.org/officeDocument/2006/relationships" id="265" r:id="R452c70224bfe4dad"/>
   </p:sldIdLst>
   <p:sldSz cx="12192000" cy="6858000"/>
   <p:notesSz cx="6858000" cy="9144000"/>
@@ -1565,67 +1565,131 @@
               <a:t>• The blue outline is the LangGraph boundary.</a:t>
             </a:r>
           </a:p>
-          <a:p xmlns:a="http://schemas.openxmlformats.org/drawingml/2006/main"/>
+          <a:p xmlns:a="http://schemas.openxmlformats.org/drawingml/2006/main">
+            <a:r>
+              <a:t/>
+            </a:r>
+          </a:p>
           <a:p xmlns:a="http://schemas.openxmlformats.org/drawingml/2006/main">
             <a:r>
               <a:t>• Inside it are research, extraction, the evidence gate, retry state and report routing.</a:t>
             </a:r>
           </a:p>
-          <a:p xmlns:a="http://schemas.openxmlformats.org/drawingml/2006/main"/>
-          <a:p xmlns:a="http://schemas.openxmlformats.org/drawingml/2006/main">
-            <a:r>
-              <a:t>• LangGraph keeps the deterministic evidence gate inside that workflow loop.</a:t>
-            </a:r>
-          </a:p>
-          <a:p xmlns:a="http://schemas.openxmlformats.org/drawingml/2006/main"/>
-          <a:p xmlns:a="http://schemas.openxmlformats.org/drawingml/2006/main">
-            <a:r>
-              <a:t>• If the evidence checks pass, supported facts and questions move to the report.</a:t>
-            </a:r>
-          </a:p>
-          <a:p xmlns:a="http://schemas.openxmlformats.org/drawingml/2006/main"/>
-          <a:p xmlns:a="http://schemas.openxmlformats.org/drawingml/2006/main">
-            <a:r>
-              <a:t>• If a check fails and retries remain, the workflow researches again.</a:t>
-            </a:r>
-          </a:p>
-          <a:p xmlns:a="http://schemas.openxmlformats.org/drawingml/2006/main"/>
-          <a:p xmlns:a="http://schemas.openxmlformats.org/drawingml/2006/main">
-            <a:r>
-              <a:t>• If no retries remain, the claim becomes undetermined.</a:t>
-            </a:r>
-          </a:p>
-          <a:p xmlns:a="http://schemas.openxmlformats.org/drawingml/2006/main"/>
+          <a:p xmlns:a="http://schemas.openxmlformats.org/drawingml/2006/main">
+            <a:r>
+              <a:t/>
+            </a:r>
+          </a:p>
+          <a:p xmlns:a="http://schemas.openxmlformats.org/drawingml/2006/main">
+            <a:r>
+              <a:t>• The retry budget is three research passes in total: one initial pass and up to two loop-backs.</a:t>
+            </a:r>
+          </a:p>
+          <a:p xmlns:a="http://schemas.openxmlformats.org/drawingml/2006/main">
+            <a:r>
+              <a:t/>
+            </a:r>
+          </a:p>
+          <a:p xmlns:a="http://schemas.openxmlformats.org/drawingml/2006/main">
+            <a:r>
+              <a:t>• If any candidate needs better evidence, LangGraph reruns the whole research stage. This is a scan-level retry, not a separate retry budget for each claim.</a:t>
+            </a:r>
+          </a:p>
+          <a:p xmlns:a="http://schemas.openxmlformats.org/drawingml/2006/main">
+            <a:r>
+              <a:t/>
+            </a:r>
+          </a:p>
+          <a:p xmlns:a="http://schemas.openxmlformats.org/drawingml/2006/main">
+            <a:r>
+              <a:t>• If every candidate settles earlier, the workflow moves straight to the report.</a:t>
+            </a:r>
+          </a:p>
+          <a:p xmlns:a="http://schemas.openxmlformats.org/drawingml/2006/main">
+            <a:r>
+              <a:t/>
+            </a:r>
+          </a:p>
+          <a:p xmlns:a="http://schemas.openxmlformats.org/drawingml/2006/main">
+            <a:r>
+              <a:t>• On the third pass, the search budget is exhausted. Anything still unsupported becomes undetermined, with the reason retained.</a:t>
+            </a:r>
+          </a:p>
+          <a:p xmlns:a="http://schemas.openxmlformats.org/drawingml/2006/main">
+            <a:r>
+              <a:t/>
+            </a:r>
+          </a:p>
+          <a:p xmlns:a="http://schemas.openxmlformats.org/drawingml/2006/main">
+            <a:r>
+              <a:t>• Three passes is a fixed MVP guardrail to bound runtime and API use. It is not dynamically calculated from confidence or failure type, and it has not yet been empirically calibrated.</a:t>
+            </a:r>
+          </a:p>
+          <a:p xmlns:a="http://schemas.openxmlformats.org/drawingml/2006/main">
+            <a:r>
+              <a:t/>
+            </a:r>
+          </a:p>
+          <a:p xmlns:a="http://schemas.openxmlformats.org/drawingml/2006/main">
+            <a:r>
+              <a:t>• The current retry reruns the research plan. It is not yet a targeted query strategy built from the failed check.</a:t>
+            </a:r>
+          </a:p>
+          <a:p xmlns:a="http://schemas.openxmlformats.org/drawingml/2006/main">
+            <a:r>
+              <a:t/>
+            </a:r>
+          </a:p>
           <a:p xmlns:a="http://schemas.openxmlformats.org/drawingml/2006/main">
             <a:r>
               <a:t>• Nothing is forced through.</a:t>
             </a:r>
           </a:p>
-          <a:p xmlns:a="http://schemas.openxmlformats.org/drawingml/2006/main"/>
+          <a:p xmlns:a="http://schemas.openxmlformats.org/drawingml/2006/main">
+            <a:r>
+              <a:t/>
+            </a:r>
+          </a:p>
           <a:p xmlns:a="http://schemas.openxmlformats.org/drawingml/2006/main">
             <a:r>
               <a:t>• The grey rail sits outside LangGraph: n8n only files the finished report in Notion.</a:t>
             </a:r>
           </a:p>
-          <a:p xmlns:a="http://schemas.openxmlformats.org/drawingml/2006/main"/>
+          <a:p xmlns:a="http://schemas.openxmlformats.org/drawingml/2006/main">
+            <a:r>
+              <a:t/>
+            </a:r>
+          </a:p>
           <a:p xmlns:a="http://schemas.openxmlformats.org/drawingml/2006/main">
             <a:r>
               <a:t>• n8n does not research, judge evidence or make compliance decisions.</a:t>
             </a:r>
           </a:p>
-          <a:p xmlns:a="http://schemas.openxmlformats.org/drawingml/2006/main"/>
+          <a:p xmlns:a="http://schemas.openxmlformats.org/drawingml/2006/main">
+            <a:r>
+              <a:t/>
+            </a:r>
+          </a:p>
           <a:p xmlns:a="http://schemas.openxmlformats.org/drawingml/2006/main">
             <a:r>
               <a:t>• We verified delivery from the Notion API response—not only from an n8n success message.</a:t>
             </a:r>
           </a:p>
-          <a:p xmlns:a="http://schemas.openxmlformats.org/drawingml/2006/main"/>
+          <a:p xmlns:a="http://schemas.openxmlformats.org/drawingml/2006/main">
+            <a:r>
+              <a:t/>
+            </a:r>
+          </a:p>
           <a:p xmlns:a="http://schemas.openxmlformats.org/drawingml/2006/main">
             <a:r>
               <a:t>• The same architecture points to a recurring product, not just a one-off scan.</a:t>
             </a:r>
           </a:p>
-          <a:p xmlns:a="http://schemas.openxmlformats.org/drawingml/2006/main"/>
+          <a:p xmlns:a="http://schemas.openxmlformats.org/drawingml/2006/main">
+            <a:r>
+              <a:t/>
+            </a:r>
+          </a:p>
           <a:p xmlns:a="http://schemas.openxmlformats.org/drawingml/2006/main">
             <a:r>
               <a:t>[If asked — HOW]</a:t>
@@ -1633,23 +1697,42 @@
           </a:p>
           <a:p xmlns:a="http://schemas.openxmlformats.org/drawingml/2006/main">
             <a:r>
-              <a:t>– Why LangGraph rather than prompts?  The loop needs state — gate verdicts, retry budget, per-claim outcomes. That is a state machine, not a prompt.</a:t>
-            </a:r>
-          </a:p>
-          <a:p xmlns:a="http://schemas.openxmlformats.org/drawingml/2006/main">
-            <a:r>
-              <a:t>– How many retries?  A set budget per claim. Out of retries means undetermined, with the reason recorded in the report.</a:t>
-            </a:r>
-          </a:p>
-          <a:p xmlns:a="http://schemas.openxmlformats.org/drawingml/2006/main">
-            <a:r>
-              <a:t>– Why is n8n kept outside?  It only files the finished report. If delivery fails, the evidence is untouched — and delivery was verified from the Notion API response, not n8n's success banner.</a:t>
-            </a:r>
-          </a:p>
-          <a:p xmlns:a="http://schemas.openxmlformats.org/drawingml/2006/main"/>
+              <a:t>– Why three passes?  It is a fixed MVP safety limit for runtime and API cost, not a model confidence threshold. It still needs pilot calibration.</a:t>
+            </a:r>
+          </a:p>
+          <a:p xmlns:a="http://schemas.openxmlformats.org/drawingml/2006/main">
+            <a:r>
+              <a:t>– Is that three retries?  No. Three passes total means one initial research pass and at most two retries.</a:t>
+            </a:r>
+          </a:p>
+          <a:p xmlns:a="http://schemas.openxmlformats.org/drawingml/2006/main">
+            <a:r>
+              <a:t>– Is the retry per claim?  No. Any retry request sends the scan-level research stage around again; unresolved claims become undetermined after pass three.</a:t>
+            </a:r>
+          </a:p>
+          <a:p xmlns:a="http://schemas.openxmlformats.org/drawingml/2006/main">
+            <a:r>
+              <a:t>– Why is n8n kept outside?  It only files the finished report. If delivery fails, the evidence is untouched—and delivery was verified from the Notion API response, not n8n's success banner.</a:t>
+            </a:r>
+          </a:p>
+          <a:p xmlns:a="http://schemas.openxmlformats.org/drawingml/2006/main">
+            <a:r>
+              <a:t/>
+            </a:r>
+          </a:p>
           <a:p xmlns:a="http://schemas.openxmlformats.org/drawingml/2006/main">
             <a:r>
               <a:t>[Sources]</a:t>
+            </a:r>
+          </a:p>
+          <a:p xmlns:a="http://schemas.openxmlformats.org/drawingml/2006/main">
+            <a:r>
+              <a:t>- src/ai_prescan/graph.py</a:t>
+            </a:r>
+          </a:p>
+          <a:p xmlns:a="http://schemas.openxmlformats.org/drawingml/2006/main">
+            <a:r>
+              <a:t>- src/ai_prescan/gate.py</a:t>
             </a:r>
           </a:p>
           <a:p xmlns:a="http://schemas.openxmlformats.org/drawingml/2006/main">
@@ -2836,8 +2919,8 @@
   </p:cSld>
   <p:clrMap bg1="lt1" tx1="dk1" bg2="lt2" tx2="dk2" accent1="accent1" accent2="accent2" accent3="accent3" accent4="accent4" accent5="accent5" accent6="accent6" hlink="hlink" folHlink="folHlink"/>
   <p:sldLayoutIdLst>
-    <p:sldLayoutId xmlns:r="http://schemas.openxmlformats.org/officeDocument/2006/relationships" id="2147483649" r:id="R1e581d2373d04ce5"/>
-    <p:sldLayoutId xmlns:r="http://schemas.openxmlformats.org/officeDocument/2006/relationships" id="2147483650" r:id="R70a4438fc706432a"/>
+    <p:sldLayoutId xmlns:r="http://schemas.openxmlformats.org/officeDocument/2006/relationships" id="2147483649" r:id="R1eaa44ebe9bd420c"/>
+    <p:sldLayoutId xmlns:r="http://schemas.openxmlformats.org/officeDocument/2006/relationships" id="2147483650" r:id="R91bc42ebd7454009"/>
   </p:sldLayoutIdLst>
 </p:sldMaster>
 </file>
@@ -14658,7 +14741,7 @@
                 <a:ea typeface="Aptos"/>
                 <a:cs typeface="Aptos"/>
               </a:rPr>
-              <a:t>OUT OF RETRIES → UNDETERMINED</a:t>
+              <a:t>AFTER 3 PASSES → UNDETERMINED</a:t>
             </a:r>
             <a:endParaRPr sz="1050" b="0" u="none">
               <a:solidFill>

</xml_diff>